<commit_message>
Update S031-P01 layout and sync registries
</commit_message>
<xml_diff>
--- a/presentations/ispring-course/module-01-stropovka-gruzov/live-preview/S029_theme22_preview_2026-06-30_v13_ev-group-techstyle-premium-subslides.pptx
+++ b/presentations/ispring-course/module-01-stropovka-gruzov/live-preview/S029_theme22_preview_2026-06-30_v13_ev-group-techstyle-premium-subslides.pptx
@@ -279,7 +279,7 @@
           <a:p>
             <a:fld id="{3233ECE5-5C77-4820-9FDC-B8AEB273E572}" type="datetimeFigureOut">
               <a:rPr lang="ru-RU" smtClean="0"/>
-              <a:t>29.06.2026</a:t>
+              <a:t>30.06.2026</a:t>
             </a:fld>
             <a:endParaRPr lang="ru-RU"/>
           </a:p>
@@ -477,7 +477,7 @@
           <a:p>
             <a:fld id="{3233ECE5-5C77-4820-9FDC-B8AEB273E572}" type="datetimeFigureOut">
               <a:rPr lang="ru-RU" smtClean="0"/>
-              <a:t>29.06.2026</a:t>
+              <a:t>30.06.2026</a:t>
             </a:fld>
             <a:endParaRPr lang="ru-RU"/>
           </a:p>
@@ -685,7 +685,7 @@
           <a:p>
             <a:fld id="{3233ECE5-5C77-4820-9FDC-B8AEB273E572}" type="datetimeFigureOut">
               <a:rPr lang="ru-RU" smtClean="0"/>
-              <a:t>29.06.2026</a:t>
+              <a:t>30.06.2026</a:t>
             </a:fld>
             <a:endParaRPr lang="ru-RU"/>
           </a:p>
@@ -883,7 +883,7 @@
           <a:p>
             <a:fld id="{3233ECE5-5C77-4820-9FDC-B8AEB273E572}" type="datetimeFigureOut">
               <a:rPr lang="ru-RU" smtClean="0"/>
-              <a:t>29.06.2026</a:t>
+              <a:t>30.06.2026</a:t>
             </a:fld>
             <a:endParaRPr lang="ru-RU"/>
           </a:p>
@@ -1158,7 +1158,7 @@
           <a:p>
             <a:fld id="{3233ECE5-5C77-4820-9FDC-B8AEB273E572}" type="datetimeFigureOut">
               <a:rPr lang="ru-RU" smtClean="0"/>
-              <a:t>29.06.2026</a:t>
+              <a:t>30.06.2026</a:t>
             </a:fld>
             <a:endParaRPr lang="ru-RU"/>
           </a:p>
@@ -1423,7 +1423,7 @@
           <a:p>
             <a:fld id="{3233ECE5-5C77-4820-9FDC-B8AEB273E572}" type="datetimeFigureOut">
               <a:rPr lang="ru-RU" smtClean="0"/>
-              <a:t>29.06.2026</a:t>
+              <a:t>30.06.2026</a:t>
             </a:fld>
             <a:endParaRPr lang="ru-RU"/>
           </a:p>
@@ -1835,7 +1835,7 @@
           <a:p>
             <a:fld id="{3233ECE5-5C77-4820-9FDC-B8AEB273E572}" type="datetimeFigureOut">
               <a:rPr lang="ru-RU" smtClean="0"/>
-              <a:t>29.06.2026</a:t>
+              <a:t>30.06.2026</a:t>
             </a:fld>
             <a:endParaRPr lang="ru-RU"/>
           </a:p>
@@ -1976,7 +1976,7 @@
           <a:p>
             <a:fld id="{3233ECE5-5C77-4820-9FDC-B8AEB273E572}" type="datetimeFigureOut">
               <a:rPr lang="ru-RU" smtClean="0"/>
-              <a:t>29.06.2026</a:t>
+              <a:t>30.06.2026</a:t>
             </a:fld>
             <a:endParaRPr lang="ru-RU"/>
           </a:p>
@@ -2089,7 +2089,7 @@
           <a:p>
             <a:fld id="{3233ECE5-5C77-4820-9FDC-B8AEB273E572}" type="datetimeFigureOut">
               <a:rPr lang="ru-RU" smtClean="0"/>
-              <a:t>29.06.2026</a:t>
+              <a:t>30.06.2026</a:t>
             </a:fld>
             <a:endParaRPr lang="ru-RU"/>
           </a:p>
@@ -2400,7 +2400,7 @@
           <a:p>
             <a:fld id="{3233ECE5-5C77-4820-9FDC-B8AEB273E572}" type="datetimeFigureOut">
               <a:rPr lang="ru-RU" smtClean="0"/>
-              <a:t>29.06.2026</a:t>
+              <a:t>30.06.2026</a:t>
             </a:fld>
             <a:endParaRPr lang="ru-RU"/>
           </a:p>
@@ -2688,7 +2688,7 @@
           <a:p>
             <a:fld id="{3233ECE5-5C77-4820-9FDC-B8AEB273E572}" type="datetimeFigureOut">
               <a:rPr lang="ru-RU" smtClean="0"/>
-              <a:t>29.06.2026</a:t>
+              <a:t>30.06.2026</a:t>
             </a:fld>
             <a:endParaRPr lang="ru-RU"/>
           </a:p>
@@ -2929,7 +2929,7 @@
           <a:p>
             <a:fld id="{3233ECE5-5C77-4820-9FDC-B8AEB273E572}" type="datetimeFigureOut">
               <a:rPr lang="ru-RU" smtClean="0"/>
-              <a:t>29.06.2026</a:t>
+              <a:t>30.06.2026</a:t>
             </a:fld>
             <a:endParaRPr lang="ru-RU"/>
           </a:p>
@@ -3407,7 +3407,7 @@
           <a:noFill/>
         </p:spPr>
         <p:txBody>
-          <a:bodyPr wrap="none" lIns="101600" rIns="101600" tIns="76200" bIns="76200">
+          <a:bodyPr wrap="none" lIns="101600" tIns="76200" rIns="101600" bIns="76200">
             <a:spAutoFit/>
           </a:bodyPr>
           <a:lstStyle/>
@@ -3473,7 +3473,7 @@
           </a:fontRef>
         </p:style>
         <p:txBody>
-          <a:bodyPr rtlCol="0" anchor="ctr" wrap="none" lIns="101600" rIns="101600" tIns="76200" bIns="76200"/>
+          <a:bodyPr wrap="none" lIns="101600" tIns="76200" rIns="101600" bIns="76200" rtlCol="0" anchor="ctr"/>
           <a:lstStyle/>
           <a:p>
             <a:pPr algn="ctr"/>
@@ -3511,7 +3511,7 @@
           <a:noFill/>
         </p:spPr>
         <p:txBody>
-          <a:bodyPr wrap="square" lIns="101600" rIns="101600" tIns="76200" bIns="76200">
+          <a:bodyPr wrap="square" lIns="101600" tIns="76200" rIns="101600" bIns="76200">
             <a:spAutoFit/>
           </a:bodyPr>
           <a:lstStyle/>
@@ -3620,12 +3620,12 @@
           </a:fontRef>
         </p:style>
         <p:txBody>
-          <a:bodyPr lIns="101600" rIns="101600" rtlCol="0" anchor="ctr" wrap="square" tIns="76200" bIns="76200"/>
+          <a:bodyPr wrap="square" lIns="101600" tIns="76200" rIns="101600" bIns="76200" rtlCol="0" anchor="ctr"/>
           <a:lstStyle/>
           <a:p>
             <a:pPr algn="l"/>
             <a:r>
-              <a:rPr lang="ru-RU" b="1" sz="1300">
+              <a:rPr lang="ru-RU" sz="1300" b="1">
                 <a:solidFill>
                   <a:srgbClr val="111111"/>
                 </a:solidFill>
@@ -3658,7 +3658,7 @@
           <a:noFill/>
         </p:spPr>
         <p:txBody>
-          <a:bodyPr wrap="square" lIns="101600" rIns="101600" tIns="76200" bIns="76200">
+          <a:bodyPr wrap="square" lIns="101600" tIns="76200" rIns="101600" bIns="76200">
             <a:spAutoFit/>
           </a:bodyPr>
           <a:lstStyle/>
@@ -3669,7 +3669,7 @@
               </a:spcAft>
             </a:pPr>
             <a:r>
-              <a:rPr lang="ru-RU" dirty="0" sz="1600" b="0">
+              <a:rPr lang="ru-RU" sz="1600" b="0" dirty="0">
                 <a:solidFill>
                   <a:srgbClr val="111111"/>
                 </a:solidFill>
@@ -3678,7 +3678,7 @@
               <a:t>В этом блоке разбираем, как именно работает стропальщик: подготовка к работе, обязанности, сигналы, сопровождение груза, складирование и </a:t>
             </a:r>
             <a:r>
-              <a:rPr lang="ru-RU" dirty="0" err="1" sz="1600" b="0">
+              <a:rPr lang="ru-RU" sz="1600" b="0" dirty="0" err="1">
                 <a:solidFill>
                   <a:srgbClr val="111111"/>
                 </a:solidFill>
@@ -3687,7 +3687,7 @@
               <a:t>расстроповка</a:t>
             </a:r>
             <a:r>
-              <a:rPr lang="ru-RU" dirty="0" sz="1600" b="0">
+              <a:rPr lang="ru-RU" sz="1600" b="0" dirty="0">
                 <a:solidFill>
                   <a:srgbClr val="111111"/>
                 </a:solidFill>
@@ -3768,7 +3768,7 @@
           <a:noFill/>
         </p:spPr>
         <p:txBody>
-          <a:bodyPr wrap="square" lIns="101600" rIns="101600" tIns="76200" bIns="76200">
+          <a:bodyPr wrap="square" lIns="101600" tIns="76200" rIns="101600" bIns="76200">
             <a:spAutoFit/>
           </a:bodyPr>
           <a:lstStyle/>
@@ -3817,7 +3817,7 @@
           </a:fontRef>
         </p:style>
         <p:txBody>
-          <a:bodyPr rtlCol="0" anchor="ctr" wrap="square" lIns="101600" rIns="101600" tIns="76200" bIns="76200"/>
+          <a:bodyPr wrap="square" lIns="101600" tIns="76200" rIns="101600" bIns="76200" rtlCol="0" anchor="ctr"/>
           <a:lstStyle/>
           <a:p>
             <a:pPr algn="ctr"/>
@@ -3880,7 +3880,7 @@
           </a:fontRef>
         </p:style>
         <p:txBody>
-          <a:bodyPr rtlCol="0" anchor="ctr" wrap="square" lIns="101600" rIns="101600" tIns="76200" bIns="76200"/>
+          <a:bodyPr wrap="square" lIns="101600" tIns="76200" rIns="101600" bIns="76200" rtlCol="0" anchor="ctr"/>
           <a:lstStyle/>
           <a:p>
             <a:pPr algn="ctr"/>
@@ -3936,6 +3936,7 @@
           <a:lstStyle/>
           <a:p>
             <a:pPr algn="ctr"/>
+            <a:endParaRPr/>
           </a:p>
         </p:txBody>
       </p:sp>
@@ -3979,6 +3980,7 @@
           <a:lstStyle/>
           <a:p>
             <a:pPr algn="ctr"/>
+            <a:endParaRPr/>
           </a:p>
         </p:txBody>
       </p:sp>
@@ -4018,7 +4020,7 @@
           </a:fontRef>
         </p:style>
         <p:txBody>
-          <a:bodyPr rtlCol="0" anchor="ctr" wrap="none" lIns="50800" rIns="50800" tIns="12700" bIns="12700"/>
+          <a:bodyPr wrap="none" lIns="50800" tIns="12700" rIns="50800" bIns="12700" rtlCol="0" anchor="ctr"/>
           <a:lstStyle/>
           <a:p>
             <a:pPr algn="ctr"/>
@@ -4070,7 +4072,7 @@
           </a:fontRef>
         </p:style>
         <p:txBody>
-          <a:bodyPr rtlCol="0" anchor="ctr" wrap="none" lIns="50800" rIns="50800" tIns="12700" bIns="12700"/>
+          <a:bodyPr wrap="none" lIns="50800" tIns="12700" rIns="50800" bIns="12700" rtlCol="0" anchor="ctr"/>
           <a:lstStyle/>
           <a:p>
             <a:pPr algn="ctr"/>
@@ -4126,6 +4128,7 @@
           <a:lstStyle/>
           <a:p>
             <a:pPr algn="ctr"/>
+            <a:endParaRPr/>
           </a:p>
         </p:txBody>
       </p:sp>
@@ -4165,7 +4168,7 @@
           </a:fontRef>
         </p:style>
         <p:txBody>
-          <a:bodyPr rtlCol="0" anchor="ctr" wrap="none" lIns="50800" rIns="50800" tIns="12700" bIns="12700"/>
+          <a:bodyPr wrap="none" lIns="50800" tIns="12700" rIns="50800" bIns="12700" rtlCol="0" anchor="ctr"/>
           <a:lstStyle/>
           <a:p>
             <a:pPr algn="ctr"/>
@@ -4217,7 +4220,7 @@
           </a:fontRef>
         </p:style>
         <p:txBody>
-          <a:bodyPr rtlCol="0" anchor="ctr" wrap="none" lIns="50800" rIns="50800" tIns="12700" bIns="12700"/>
+          <a:bodyPr wrap="none" lIns="50800" tIns="12700" rIns="50800" bIns="12700" rtlCol="0" anchor="ctr"/>
           <a:lstStyle/>
           <a:p>
             <a:pPr algn="ctr"/>
@@ -4269,7 +4272,7 @@
           </a:fontRef>
         </p:style>
         <p:txBody>
-          <a:bodyPr rtlCol="0" anchor="ctr" wrap="none" lIns="50800" rIns="50800" tIns="12700" bIns="12700"/>
+          <a:bodyPr wrap="none" lIns="50800" tIns="12700" rIns="50800" bIns="12700" rtlCol="0" anchor="ctr"/>
           <a:lstStyle/>
           <a:p>
             <a:pPr algn="ctr"/>
@@ -4302,7 +4305,7 @@
           <a:noFill/>
         </p:spPr>
         <p:txBody>
-          <a:bodyPr wrap="square" lIns="0" rIns="0" tIns="0" bIns="0">
+          <a:bodyPr wrap="square" lIns="0" tIns="0" rIns="0" bIns="0">
             <a:spAutoFit/>
           </a:bodyPr>
           <a:lstStyle/>
@@ -4383,6 +4386,7 @@
           <a:lstStyle/>
           <a:p>
             <a:pPr algn="ctr"/>
+            <a:endParaRPr/>
           </a:p>
         </p:txBody>
       </p:sp>
@@ -4472,7 +4476,7 @@
           <a:noFill/>
         </p:spPr>
         <p:txBody>
-          <a:bodyPr wrap="none" lIns="101600" rIns="101600" tIns="76200" bIns="76200">
+          <a:bodyPr wrap="none" lIns="101600" tIns="76200" rIns="101600" bIns="76200">
             <a:spAutoFit/>
           </a:bodyPr>
           <a:lstStyle/>
@@ -4538,7 +4542,7 @@
           </a:fontRef>
         </p:style>
         <p:txBody>
-          <a:bodyPr rtlCol="0" anchor="ctr" wrap="none" lIns="101600" rIns="101600" tIns="76200" bIns="76200"/>
+          <a:bodyPr wrap="none" lIns="101600" tIns="76200" rIns="101600" bIns="76200" rtlCol="0" anchor="ctr"/>
           <a:lstStyle/>
           <a:p>
             <a:pPr algn="ctr"/>
@@ -4576,7 +4580,7 @@
           <a:noFill/>
         </p:spPr>
         <p:txBody>
-          <a:bodyPr wrap="square" lIns="101600" rIns="101600" tIns="76200" bIns="76200">
+          <a:bodyPr wrap="square" lIns="101600" tIns="76200" rIns="101600" bIns="76200">
             <a:spAutoFit/>
           </a:bodyPr>
           <a:lstStyle/>
@@ -4685,12 +4689,12 @@
           </a:fontRef>
         </p:style>
         <p:txBody>
-          <a:bodyPr lIns="101600" rIns="101600" rtlCol="0" anchor="ctr" wrap="square" tIns="76200" bIns="76200"/>
+          <a:bodyPr wrap="square" lIns="101600" tIns="76200" rIns="101600" bIns="76200" rtlCol="0" anchor="ctr"/>
           <a:lstStyle/>
           <a:p>
             <a:pPr algn="l"/>
             <a:r>
-              <a:rPr lang="ru-RU" b="1" sz="1300">
+              <a:rPr lang="ru-RU" sz="1300" b="1">
                 <a:solidFill>
                   <a:srgbClr val="111111"/>
                 </a:solidFill>
@@ -4723,7 +4727,7 @@
           <a:noFill/>
         </p:spPr>
         <p:txBody>
-          <a:bodyPr wrap="square" lIns="127000" rIns="101600" tIns="76200" bIns="76200">
+          <a:bodyPr wrap="square" lIns="127000" tIns="76200" rIns="101600" bIns="76200">
             <a:spAutoFit/>
           </a:bodyPr>
           <a:lstStyle/>
@@ -4955,7 +4959,7 @@
           <a:noFill/>
         </p:spPr>
         <p:txBody>
-          <a:bodyPr wrap="square" lIns="101600" rIns="101600" tIns="76200" bIns="76200">
+          <a:bodyPr wrap="square" lIns="101600" tIns="76200" rIns="101600" bIns="76200">
             <a:spAutoFit/>
           </a:bodyPr>
           <a:lstStyle/>
@@ -5004,7 +5008,7 @@
           </a:fontRef>
         </p:style>
         <p:txBody>
-          <a:bodyPr rtlCol="0" anchor="ctr" wrap="square" lIns="101600" rIns="101600" tIns="76200" bIns="76200"/>
+          <a:bodyPr wrap="square" lIns="101600" tIns="76200" rIns="101600" bIns="76200" rtlCol="0" anchor="ctr"/>
           <a:lstStyle/>
           <a:p>
             <a:pPr algn="ctr"/>
@@ -5067,7 +5071,7 @@
           </a:fontRef>
         </p:style>
         <p:txBody>
-          <a:bodyPr rtlCol="0" anchor="ctr" wrap="square" lIns="101600" rIns="101600" tIns="76200" bIns="76200"/>
+          <a:bodyPr wrap="square" lIns="101600" tIns="76200" rIns="101600" bIns="76200" rtlCol="0" anchor="ctr"/>
           <a:lstStyle/>
           <a:p>
             <a:pPr algn="ctr"/>
@@ -5123,6 +5127,7 @@
           <a:lstStyle/>
           <a:p>
             <a:pPr algn="ctr"/>
+            <a:endParaRPr/>
           </a:p>
         </p:txBody>
       </p:sp>
@@ -5166,6 +5171,7 @@
           <a:lstStyle/>
           <a:p>
             <a:pPr algn="ctr"/>
+            <a:endParaRPr/>
           </a:p>
         </p:txBody>
       </p:sp>
@@ -5205,7 +5211,7 @@
           </a:fontRef>
         </p:style>
         <p:txBody>
-          <a:bodyPr rtlCol="0" anchor="ctr" wrap="none" lIns="50800" rIns="50800" tIns="12700" bIns="12700"/>
+          <a:bodyPr wrap="none" lIns="50800" tIns="12700" rIns="50800" bIns="12700" rtlCol="0" anchor="ctr"/>
           <a:lstStyle/>
           <a:p>
             <a:pPr algn="ctr"/>
@@ -5257,7 +5263,7 @@
           </a:fontRef>
         </p:style>
         <p:txBody>
-          <a:bodyPr rtlCol="0" anchor="ctr" wrap="none" lIns="50800" rIns="50800" tIns="12700" bIns="12700"/>
+          <a:bodyPr wrap="none" lIns="50800" tIns="12700" rIns="50800" bIns="12700" rtlCol="0" anchor="ctr"/>
           <a:lstStyle/>
           <a:p>
             <a:pPr algn="ctr"/>
@@ -5313,6 +5319,7 @@
           <a:lstStyle/>
           <a:p>
             <a:pPr algn="ctr"/>
+            <a:endParaRPr/>
           </a:p>
         </p:txBody>
       </p:sp>
@@ -5356,6 +5363,7 @@
           <a:lstStyle/>
           <a:p>
             <a:pPr algn="ctr"/>
+            <a:endParaRPr/>
           </a:p>
         </p:txBody>
       </p:sp>
@@ -5399,6 +5407,7 @@
           <a:lstStyle/>
           <a:p>
             <a:pPr algn="ctr"/>
+            <a:endParaRPr/>
           </a:p>
         </p:txBody>
       </p:sp>
@@ -5438,7 +5447,7 @@
           </a:fontRef>
         </p:style>
         <p:txBody>
-          <a:bodyPr rtlCol="0" anchor="ctr" wrap="none" lIns="50800" rIns="50800" tIns="12700" bIns="12700"/>
+          <a:bodyPr wrap="none" lIns="50800" tIns="12700" rIns="50800" bIns="12700" rtlCol="0" anchor="ctr"/>
           <a:lstStyle/>
           <a:p>
             <a:pPr algn="ctr"/>
@@ -5490,7 +5499,7 @@
           </a:fontRef>
         </p:style>
         <p:txBody>
-          <a:bodyPr rtlCol="0" anchor="ctr" wrap="none" lIns="50800" rIns="50800" tIns="12700" bIns="12700"/>
+          <a:bodyPr wrap="none" lIns="50800" tIns="12700" rIns="50800" bIns="12700" rtlCol="0" anchor="ctr"/>
           <a:lstStyle/>
           <a:p>
             <a:pPr algn="ctr"/>
@@ -5542,7 +5551,7 @@
           </a:fontRef>
         </p:style>
         <p:txBody>
-          <a:bodyPr rtlCol="0" anchor="ctr" wrap="none" lIns="50800" rIns="50800" tIns="12700" bIns="12700"/>
+          <a:bodyPr wrap="none" lIns="50800" tIns="12700" rIns="50800" bIns="12700" rtlCol="0" anchor="ctr"/>
           <a:lstStyle/>
           <a:p>
             <a:pPr algn="ctr"/>
@@ -5575,7 +5584,7 @@
           <a:noFill/>
         </p:spPr>
         <p:txBody>
-          <a:bodyPr wrap="square" lIns="0" rIns="0" tIns="0" bIns="0">
+          <a:bodyPr wrap="square" lIns="0" tIns="0" rIns="0" bIns="0">
             <a:spAutoFit/>
           </a:bodyPr>
           <a:lstStyle/>
@@ -5656,6 +5665,7 @@
           <a:lstStyle/>
           <a:p>
             <a:pPr algn="ctr"/>
+            <a:endParaRPr/>
           </a:p>
         </p:txBody>
       </p:sp>
@@ -5750,7 +5760,7 @@
           <a:noFill/>
         </p:spPr>
         <p:txBody>
-          <a:bodyPr wrap="none" lIns="101600" rIns="101600" tIns="76200" bIns="76200">
+          <a:bodyPr wrap="none" lIns="101600" tIns="76200" rIns="101600" bIns="76200">
             <a:spAutoFit/>
           </a:bodyPr>
           <a:lstStyle/>
@@ -5816,7 +5826,7 @@
           </a:fontRef>
         </p:style>
         <p:txBody>
-          <a:bodyPr rtlCol="0" anchor="ctr" wrap="none" lIns="101600" rIns="101600" tIns="76200" bIns="76200"/>
+          <a:bodyPr wrap="none" lIns="101600" tIns="76200" rIns="101600" bIns="76200" rtlCol="0" anchor="ctr"/>
           <a:lstStyle/>
           <a:p>
             <a:pPr algn="ctr"/>
@@ -5854,7 +5864,7 @@
           <a:noFill/>
         </p:spPr>
         <p:txBody>
-          <a:bodyPr wrap="square" lIns="101600" rIns="101600" tIns="76200" bIns="76200">
+          <a:bodyPr wrap="square" lIns="101600" tIns="76200" rIns="101600" bIns="76200">
             <a:spAutoFit/>
           </a:bodyPr>
           <a:lstStyle/>
@@ -5963,12 +5973,12 @@
           </a:fontRef>
         </p:style>
         <p:txBody>
-          <a:bodyPr lIns="101600" rIns="101600" rtlCol="0" anchor="ctr" wrap="square" tIns="76200" bIns="76200"/>
+          <a:bodyPr wrap="square" lIns="101600" tIns="76200" rIns="101600" bIns="76200" rtlCol="0" anchor="ctr"/>
           <a:lstStyle/>
           <a:p>
             <a:pPr algn="l"/>
             <a:r>
-              <a:rPr lang="ru-RU" b="1" sz="1300">
+              <a:rPr lang="ru-RU" sz="1300" b="1">
                 <a:solidFill>
                   <a:srgbClr val="111111"/>
                 </a:solidFill>
@@ -6001,7 +6011,7 @@
           <a:noFill/>
         </p:spPr>
         <p:txBody>
-          <a:bodyPr wrap="square" lIns="127000" rIns="101600" tIns="76200" bIns="76200">
+          <a:bodyPr wrap="square" lIns="127000" tIns="76200" rIns="101600" bIns="76200">
             <a:spAutoFit/>
           </a:bodyPr>
           <a:lstStyle/>
@@ -6217,7 +6227,7 @@
           <a:noFill/>
         </p:spPr>
         <p:txBody>
-          <a:bodyPr wrap="square" lIns="101600" rIns="101600" tIns="76200" bIns="76200">
+          <a:bodyPr wrap="square" lIns="101600" tIns="76200" rIns="101600" bIns="76200">
             <a:spAutoFit/>
           </a:bodyPr>
           <a:lstStyle/>
@@ -6266,7 +6276,7 @@
           </a:fontRef>
         </p:style>
         <p:txBody>
-          <a:bodyPr rtlCol="0" anchor="ctr" wrap="square" lIns="101600" rIns="101600" tIns="76200" bIns="76200"/>
+          <a:bodyPr wrap="square" lIns="101600" tIns="76200" rIns="101600" bIns="76200" rtlCol="0" anchor="ctr"/>
           <a:lstStyle/>
           <a:p>
             <a:pPr algn="ctr"/>
@@ -6329,7 +6339,7 @@
           </a:fontRef>
         </p:style>
         <p:txBody>
-          <a:bodyPr rtlCol="0" anchor="ctr" wrap="square" lIns="101600" rIns="101600" tIns="76200" bIns="76200"/>
+          <a:bodyPr wrap="square" lIns="101600" tIns="76200" rIns="101600" bIns="76200" rtlCol="0" anchor="ctr"/>
           <a:lstStyle/>
           <a:p>
             <a:pPr algn="ctr"/>
@@ -6385,6 +6395,7 @@
           <a:lstStyle/>
           <a:p>
             <a:pPr algn="ctr"/>
+            <a:endParaRPr/>
           </a:p>
         </p:txBody>
       </p:sp>
@@ -6428,6 +6439,7 @@
           <a:lstStyle/>
           <a:p>
             <a:pPr algn="ctr"/>
+            <a:endParaRPr/>
           </a:p>
         </p:txBody>
       </p:sp>
@@ -6467,7 +6479,7 @@
           </a:fontRef>
         </p:style>
         <p:txBody>
-          <a:bodyPr rtlCol="0" anchor="ctr" wrap="none" lIns="50800" rIns="50800" tIns="12700" bIns="12700"/>
+          <a:bodyPr wrap="none" lIns="50800" tIns="12700" rIns="50800" bIns="12700" rtlCol="0" anchor="ctr"/>
           <a:lstStyle/>
           <a:p>
             <a:pPr algn="ctr"/>
@@ -6519,7 +6531,7 @@
           </a:fontRef>
         </p:style>
         <p:txBody>
-          <a:bodyPr rtlCol="0" anchor="ctr" wrap="none" lIns="50800" rIns="50800" tIns="12700" bIns="12700"/>
+          <a:bodyPr wrap="none" lIns="50800" tIns="12700" rIns="50800" bIns="12700" rtlCol="0" anchor="ctr"/>
           <a:lstStyle/>
           <a:p>
             <a:pPr algn="ctr"/>
@@ -6575,6 +6587,7 @@
           <a:lstStyle/>
           <a:p>
             <a:pPr algn="ctr"/>
+            <a:endParaRPr/>
           </a:p>
         </p:txBody>
       </p:sp>
@@ -6618,6 +6631,7 @@
           <a:lstStyle/>
           <a:p>
             <a:pPr algn="ctr"/>
+            <a:endParaRPr/>
           </a:p>
         </p:txBody>
       </p:sp>
@@ -6661,6 +6675,7 @@
           <a:lstStyle/>
           <a:p>
             <a:pPr algn="ctr"/>
+            <a:endParaRPr/>
           </a:p>
         </p:txBody>
       </p:sp>
@@ -6700,7 +6715,7 @@
           </a:fontRef>
         </p:style>
         <p:txBody>
-          <a:bodyPr rtlCol="0" anchor="ctr" wrap="none" lIns="50800" rIns="50800" tIns="12700" bIns="12700"/>
+          <a:bodyPr wrap="none" lIns="50800" tIns="12700" rIns="50800" bIns="12700" rtlCol="0" anchor="ctr"/>
           <a:lstStyle/>
           <a:p>
             <a:pPr algn="ctr"/>
@@ -6752,7 +6767,7 @@
           </a:fontRef>
         </p:style>
         <p:txBody>
-          <a:bodyPr rtlCol="0" anchor="ctr" wrap="none" lIns="50800" rIns="50800" tIns="12700" bIns="12700"/>
+          <a:bodyPr wrap="none" lIns="50800" tIns="12700" rIns="50800" bIns="12700" rtlCol="0" anchor="ctr"/>
           <a:lstStyle/>
           <a:p>
             <a:pPr algn="ctr"/>
@@ -6804,7 +6819,7 @@
           </a:fontRef>
         </p:style>
         <p:txBody>
-          <a:bodyPr rtlCol="0" anchor="ctr" wrap="none" lIns="50800" rIns="50800" tIns="12700" bIns="12700"/>
+          <a:bodyPr wrap="none" lIns="50800" tIns="12700" rIns="50800" bIns="12700" rtlCol="0" anchor="ctr"/>
           <a:lstStyle/>
           <a:p>
             <a:pPr algn="ctr"/>
@@ -6837,7 +6852,7 @@
           <a:noFill/>
         </p:spPr>
         <p:txBody>
-          <a:bodyPr wrap="square" lIns="0" rIns="0" tIns="0" bIns="0">
+          <a:bodyPr wrap="square" lIns="0" tIns="0" rIns="0" bIns="0">
             <a:spAutoFit/>
           </a:bodyPr>
           <a:lstStyle/>
@@ -6918,6 +6933,7 @@
           <a:lstStyle/>
           <a:p>
             <a:pPr algn="ctr"/>
+            <a:endParaRPr/>
           </a:p>
         </p:txBody>
       </p:sp>
@@ -7012,7 +7028,7 @@
           <a:noFill/>
         </p:spPr>
         <p:txBody>
-          <a:bodyPr wrap="none" lIns="101600" rIns="101600" tIns="76200" bIns="76200">
+          <a:bodyPr wrap="none" lIns="101600" tIns="76200" rIns="101600" bIns="76200">
             <a:spAutoFit/>
           </a:bodyPr>
           <a:lstStyle/>
@@ -7078,7 +7094,7 @@
           </a:fontRef>
         </p:style>
         <p:txBody>
-          <a:bodyPr rtlCol="0" anchor="ctr" wrap="none" lIns="101600" rIns="101600" tIns="76200" bIns="76200"/>
+          <a:bodyPr wrap="none" lIns="101600" tIns="76200" rIns="101600" bIns="76200" rtlCol="0" anchor="ctr"/>
           <a:lstStyle/>
           <a:p>
             <a:pPr algn="ctr"/>
@@ -7116,7 +7132,7 @@
           <a:noFill/>
         </p:spPr>
         <p:txBody>
-          <a:bodyPr wrap="square" lIns="101600" rIns="101600" tIns="76200" bIns="76200">
+          <a:bodyPr wrap="square" lIns="101600" tIns="76200" rIns="101600" bIns="76200">
             <a:spAutoFit/>
           </a:bodyPr>
           <a:lstStyle/>
@@ -7225,12 +7241,12 @@
           </a:fontRef>
         </p:style>
         <p:txBody>
-          <a:bodyPr lIns="101600" rIns="101600" rtlCol="0" anchor="ctr" wrap="square" tIns="76200" bIns="76200"/>
+          <a:bodyPr wrap="square" lIns="101600" tIns="76200" rIns="101600" bIns="76200" rtlCol="0" anchor="ctr"/>
           <a:lstStyle/>
           <a:p>
             <a:pPr algn="l"/>
             <a:r>
-              <a:rPr lang="ru-RU" b="1" sz="1300">
+              <a:rPr lang="ru-RU" sz="1300" b="1">
                 <a:solidFill>
                   <a:srgbClr val="111111"/>
                 </a:solidFill>
@@ -7263,7 +7279,7 @@
           <a:noFill/>
         </p:spPr>
         <p:txBody>
-          <a:bodyPr wrap="square" lIns="127000" rIns="101600" tIns="76200" bIns="76200">
+          <a:bodyPr wrap="square" lIns="127000" tIns="76200" rIns="101600" bIns="76200">
             <a:spAutoFit/>
           </a:bodyPr>
           <a:lstStyle/>
@@ -7403,7 +7419,7 @@
           <a:noFill/>
         </p:spPr>
         <p:txBody>
-          <a:bodyPr wrap="square" lIns="101600" rIns="101600" tIns="76200" bIns="76200">
+          <a:bodyPr wrap="square" lIns="101600" tIns="76200" rIns="101600" bIns="76200">
             <a:spAutoFit/>
           </a:bodyPr>
           <a:lstStyle/>
@@ -7452,7 +7468,7 @@
           </a:fontRef>
         </p:style>
         <p:txBody>
-          <a:bodyPr rtlCol="0" anchor="ctr" wrap="square" lIns="101600" rIns="101600" tIns="76200" bIns="76200"/>
+          <a:bodyPr wrap="square" lIns="101600" tIns="76200" rIns="101600" bIns="76200" rtlCol="0" anchor="ctr"/>
           <a:lstStyle/>
           <a:p>
             <a:pPr algn="ctr"/>
@@ -7515,7 +7531,7 @@
           </a:fontRef>
         </p:style>
         <p:txBody>
-          <a:bodyPr rtlCol="0" anchor="ctr" wrap="square" lIns="101600" rIns="101600" tIns="76200" bIns="76200"/>
+          <a:bodyPr wrap="square" lIns="101600" tIns="76200" rIns="101600" bIns="76200" rtlCol="0" anchor="ctr"/>
           <a:lstStyle/>
           <a:p>
             <a:pPr algn="ctr"/>
@@ -7571,6 +7587,7 @@
           <a:lstStyle/>
           <a:p>
             <a:pPr algn="ctr"/>
+            <a:endParaRPr/>
           </a:p>
         </p:txBody>
       </p:sp>
@@ -7614,6 +7631,7 @@
           <a:lstStyle/>
           <a:p>
             <a:pPr algn="ctr"/>
+            <a:endParaRPr/>
           </a:p>
         </p:txBody>
       </p:sp>
@@ -7653,7 +7671,7 @@
           </a:fontRef>
         </p:style>
         <p:txBody>
-          <a:bodyPr rtlCol="0" anchor="ctr" wrap="none" lIns="50800" rIns="50800" tIns="12700" bIns="12700"/>
+          <a:bodyPr wrap="none" lIns="50800" tIns="12700" rIns="50800" bIns="12700" rtlCol="0" anchor="ctr"/>
           <a:lstStyle/>
           <a:p>
             <a:pPr algn="ctr"/>
@@ -7705,7 +7723,7 @@
           </a:fontRef>
         </p:style>
         <p:txBody>
-          <a:bodyPr rtlCol="0" anchor="ctr" wrap="none" lIns="50800" rIns="50800" tIns="12700" bIns="12700"/>
+          <a:bodyPr wrap="none" lIns="50800" tIns="12700" rIns="50800" bIns="12700" rtlCol="0" anchor="ctr"/>
           <a:lstStyle/>
           <a:p>
             <a:pPr algn="ctr"/>
@@ -7761,6 +7779,7 @@
           <a:lstStyle/>
           <a:p>
             <a:pPr algn="ctr"/>
+            <a:endParaRPr/>
           </a:p>
         </p:txBody>
       </p:sp>
@@ -7804,6 +7823,7 @@
           <a:lstStyle/>
           <a:p>
             <a:pPr algn="ctr"/>
+            <a:endParaRPr/>
           </a:p>
         </p:txBody>
       </p:sp>
@@ -7847,6 +7867,7 @@
           <a:lstStyle/>
           <a:p>
             <a:pPr algn="ctr"/>
+            <a:endParaRPr/>
           </a:p>
         </p:txBody>
       </p:sp>
@@ -7886,7 +7907,7 @@
           </a:fontRef>
         </p:style>
         <p:txBody>
-          <a:bodyPr rtlCol="0" anchor="ctr" wrap="none" lIns="50800" rIns="50800" tIns="12700" bIns="12700"/>
+          <a:bodyPr wrap="none" lIns="50800" tIns="12700" rIns="50800" bIns="12700" rtlCol="0" anchor="ctr"/>
           <a:lstStyle/>
           <a:p>
             <a:pPr algn="ctr"/>
@@ -7938,7 +7959,7 @@
           </a:fontRef>
         </p:style>
         <p:txBody>
-          <a:bodyPr rtlCol="0" anchor="ctr" wrap="none" lIns="50800" rIns="50800" tIns="12700" bIns="12700"/>
+          <a:bodyPr wrap="none" lIns="50800" tIns="12700" rIns="50800" bIns="12700" rtlCol="0" anchor="ctr"/>
           <a:lstStyle/>
           <a:p>
             <a:pPr algn="ctr"/>
@@ -7990,7 +8011,7 @@
           </a:fontRef>
         </p:style>
         <p:txBody>
-          <a:bodyPr rtlCol="0" anchor="ctr" wrap="none" lIns="50800" rIns="50800" tIns="12700" bIns="12700"/>
+          <a:bodyPr wrap="none" lIns="50800" tIns="12700" rIns="50800" bIns="12700" rtlCol="0" anchor="ctr"/>
           <a:lstStyle/>
           <a:p>
             <a:pPr algn="ctr"/>
@@ -8023,7 +8044,7 @@
           <a:noFill/>
         </p:spPr>
         <p:txBody>
-          <a:bodyPr wrap="square" lIns="0" rIns="0" tIns="0" bIns="0">
+          <a:bodyPr wrap="square" lIns="0" tIns="0" rIns="0" bIns="0">
             <a:spAutoFit/>
           </a:bodyPr>
           <a:lstStyle/>
@@ -8104,6 +8125,7 @@
           <a:lstStyle/>
           <a:p>
             <a:pPr algn="ctr"/>
+            <a:endParaRPr/>
           </a:p>
         </p:txBody>
       </p:sp>
@@ -8198,7 +8220,7 @@
           <a:noFill/>
         </p:spPr>
         <p:txBody>
-          <a:bodyPr wrap="none" lIns="101600" rIns="101600" tIns="76200" bIns="76200">
+          <a:bodyPr wrap="none" lIns="101600" tIns="76200" rIns="101600" bIns="76200">
             <a:spAutoFit/>
           </a:bodyPr>
           <a:lstStyle/>
@@ -8264,7 +8286,7 @@
           </a:fontRef>
         </p:style>
         <p:txBody>
-          <a:bodyPr rtlCol="0" anchor="ctr" wrap="none" lIns="101600" rIns="101600" tIns="76200" bIns="76200"/>
+          <a:bodyPr wrap="none" lIns="101600" tIns="76200" rIns="101600" bIns="76200" rtlCol="0" anchor="ctr"/>
           <a:lstStyle/>
           <a:p>
             <a:pPr algn="ctr"/>
@@ -8302,7 +8324,7 @@
           <a:noFill/>
         </p:spPr>
         <p:txBody>
-          <a:bodyPr wrap="square" lIns="101600" rIns="101600" tIns="76200" bIns="76200">
+          <a:bodyPr wrap="square" lIns="101600" tIns="76200" rIns="101600" bIns="76200">
             <a:spAutoFit/>
           </a:bodyPr>
           <a:lstStyle/>
@@ -8411,12 +8433,12 @@
           </a:fontRef>
         </p:style>
         <p:txBody>
-          <a:bodyPr lIns="101600" rIns="101600" rtlCol="0" anchor="ctr" wrap="square" tIns="76200" bIns="76200"/>
+          <a:bodyPr wrap="square" lIns="101600" tIns="76200" rIns="101600" bIns="76200" rtlCol="0" anchor="ctr"/>
           <a:lstStyle/>
           <a:p>
             <a:pPr algn="l"/>
             <a:r>
-              <a:rPr lang="ru-RU" b="1" sz="1300">
+              <a:rPr lang="ru-RU" sz="1300" b="1">
                 <a:solidFill>
                   <a:srgbClr val="111111"/>
                 </a:solidFill>
@@ -8449,7 +8471,7 @@
           <a:noFill/>
         </p:spPr>
         <p:txBody>
-          <a:bodyPr wrap="square" lIns="127000" rIns="101600" tIns="76200" bIns="76200">
+          <a:bodyPr wrap="square" lIns="127000" tIns="76200" rIns="101600" bIns="76200">
             <a:spAutoFit/>
           </a:bodyPr>
           <a:lstStyle/>
@@ -8605,7 +8627,7 @@
           <a:noFill/>
         </p:spPr>
         <p:txBody>
-          <a:bodyPr wrap="square" lIns="101600" rIns="101600" tIns="76200" bIns="76200">
+          <a:bodyPr wrap="square" lIns="101600" tIns="76200" rIns="101600" bIns="76200">
             <a:spAutoFit/>
           </a:bodyPr>
           <a:lstStyle/>
@@ -8654,7 +8676,7 @@
           </a:fontRef>
         </p:style>
         <p:txBody>
-          <a:bodyPr rtlCol="0" anchor="ctr" wrap="square" lIns="101600" rIns="101600" tIns="76200" bIns="76200"/>
+          <a:bodyPr wrap="square" lIns="101600" tIns="76200" rIns="101600" bIns="76200" rtlCol="0" anchor="ctr"/>
           <a:lstStyle/>
           <a:p>
             <a:pPr algn="ctr"/>
@@ -8717,7 +8739,7 @@
           </a:fontRef>
         </p:style>
         <p:txBody>
-          <a:bodyPr rtlCol="0" anchor="ctr" wrap="square" lIns="101600" rIns="101600" tIns="76200" bIns="76200"/>
+          <a:bodyPr wrap="square" lIns="101600" tIns="76200" rIns="101600" bIns="76200" rtlCol="0" anchor="ctr"/>
           <a:lstStyle/>
           <a:p>
             <a:pPr algn="ctr"/>
@@ -8773,6 +8795,7 @@
           <a:lstStyle/>
           <a:p>
             <a:pPr algn="ctr"/>
+            <a:endParaRPr/>
           </a:p>
         </p:txBody>
       </p:sp>
@@ -8816,6 +8839,7 @@
           <a:lstStyle/>
           <a:p>
             <a:pPr algn="ctr"/>
+            <a:endParaRPr/>
           </a:p>
         </p:txBody>
       </p:sp>
@@ -8855,7 +8879,7 @@
           </a:fontRef>
         </p:style>
         <p:txBody>
-          <a:bodyPr rtlCol="0" anchor="ctr" wrap="none" lIns="50800" rIns="50800" tIns="12700" bIns="12700"/>
+          <a:bodyPr wrap="none" lIns="50800" tIns="12700" rIns="50800" bIns="12700" rtlCol="0" anchor="ctr"/>
           <a:lstStyle/>
           <a:p>
             <a:pPr algn="ctr"/>
@@ -8907,7 +8931,7 @@
           </a:fontRef>
         </p:style>
         <p:txBody>
-          <a:bodyPr rtlCol="0" anchor="ctr" wrap="none" lIns="50800" rIns="50800" tIns="12700" bIns="12700"/>
+          <a:bodyPr wrap="none" lIns="50800" tIns="12700" rIns="50800" bIns="12700" rtlCol="0" anchor="ctr"/>
           <a:lstStyle/>
           <a:p>
             <a:pPr algn="ctr"/>
@@ -8963,6 +8987,7 @@
           <a:lstStyle/>
           <a:p>
             <a:pPr algn="ctr"/>
+            <a:endParaRPr/>
           </a:p>
         </p:txBody>
       </p:sp>
@@ -9006,6 +9031,7 @@
           <a:lstStyle/>
           <a:p>
             <a:pPr algn="ctr"/>
+            <a:endParaRPr/>
           </a:p>
         </p:txBody>
       </p:sp>
@@ -9049,6 +9075,7 @@
           <a:lstStyle/>
           <a:p>
             <a:pPr algn="ctr"/>
+            <a:endParaRPr/>
           </a:p>
         </p:txBody>
       </p:sp>
@@ -9088,7 +9115,7 @@
           </a:fontRef>
         </p:style>
         <p:txBody>
-          <a:bodyPr rtlCol="0" anchor="ctr" wrap="none" lIns="50800" rIns="50800" tIns="12700" bIns="12700"/>
+          <a:bodyPr wrap="none" lIns="50800" tIns="12700" rIns="50800" bIns="12700" rtlCol="0" anchor="ctr"/>
           <a:lstStyle/>
           <a:p>
             <a:pPr algn="ctr"/>
@@ -9140,7 +9167,7 @@
           </a:fontRef>
         </p:style>
         <p:txBody>
-          <a:bodyPr rtlCol="0" anchor="ctr" wrap="none" lIns="50800" rIns="50800" tIns="12700" bIns="12700"/>
+          <a:bodyPr wrap="none" lIns="50800" tIns="12700" rIns="50800" bIns="12700" rtlCol="0" anchor="ctr"/>
           <a:lstStyle/>
           <a:p>
             <a:pPr algn="ctr"/>
@@ -9192,7 +9219,7 @@
           </a:fontRef>
         </p:style>
         <p:txBody>
-          <a:bodyPr rtlCol="0" anchor="ctr" wrap="none" lIns="50800" rIns="50800" tIns="12700" bIns="12700"/>
+          <a:bodyPr wrap="none" lIns="50800" tIns="12700" rIns="50800" bIns="12700" rtlCol="0" anchor="ctr"/>
           <a:lstStyle/>
           <a:p>
             <a:pPr algn="ctr"/>
@@ -9225,7 +9252,7 @@
           <a:noFill/>
         </p:spPr>
         <p:txBody>
-          <a:bodyPr wrap="square" lIns="0" rIns="0" tIns="0" bIns="0">
+          <a:bodyPr wrap="square" lIns="0" tIns="0" rIns="0" bIns="0">
             <a:spAutoFit/>
           </a:bodyPr>
           <a:lstStyle/>
@@ -9306,6 +9333,7 @@
           <a:lstStyle/>
           <a:p>
             <a:pPr algn="ctr"/>
+            <a:endParaRPr/>
           </a:p>
         </p:txBody>
       </p:sp>
@@ -9400,7 +9428,7 @@
           <a:noFill/>
         </p:spPr>
         <p:txBody>
-          <a:bodyPr wrap="none" lIns="101600" rIns="101600" tIns="76200" bIns="76200">
+          <a:bodyPr wrap="none" lIns="101600" tIns="76200" rIns="101600" bIns="76200">
             <a:spAutoFit/>
           </a:bodyPr>
           <a:lstStyle/>
@@ -9466,7 +9494,7 @@
           </a:fontRef>
         </p:style>
         <p:txBody>
-          <a:bodyPr rtlCol="0" anchor="ctr" wrap="none" lIns="101600" rIns="101600" tIns="76200" bIns="76200"/>
+          <a:bodyPr wrap="none" lIns="101600" tIns="76200" rIns="101600" bIns="76200" rtlCol="0" anchor="ctr"/>
           <a:lstStyle/>
           <a:p>
             <a:pPr algn="ctr"/>
@@ -9504,7 +9532,7 @@
           <a:noFill/>
         </p:spPr>
         <p:txBody>
-          <a:bodyPr wrap="square" lIns="101600" rIns="101600" tIns="76200" bIns="76200">
+          <a:bodyPr wrap="square" lIns="101600" tIns="76200" rIns="101600" bIns="76200">
             <a:spAutoFit/>
           </a:bodyPr>
           <a:lstStyle/>
@@ -9613,12 +9641,12 @@
           </a:fontRef>
         </p:style>
         <p:txBody>
-          <a:bodyPr lIns="101600" rIns="101600" rtlCol="0" anchor="ctr" wrap="square" tIns="76200" bIns="76200"/>
+          <a:bodyPr wrap="square" lIns="101600" tIns="76200" rIns="101600" bIns="76200" rtlCol="0" anchor="ctr"/>
           <a:lstStyle/>
           <a:p>
             <a:pPr algn="l"/>
             <a:r>
-              <a:rPr lang="ru-RU" b="1" sz="1300">
+              <a:rPr lang="ru-RU" sz="1300" b="1">
                 <a:solidFill>
                   <a:srgbClr val="111111"/>
                 </a:solidFill>
@@ -9651,7 +9679,7 @@
           <a:noFill/>
         </p:spPr>
         <p:txBody>
-          <a:bodyPr wrap="square" lIns="127000" rIns="101600" tIns="76200" bIns="76200">
+          <a:bodyPr wrap="square" lIns="127000" tIns="76200" rIns="101600" bIns="76200">
             <a:spAutoFit/>
           </a:bodyPr>
           <a:lstStyle/>
@@ -9807,7 +9835,7 @@
           <a:noFill/>
         </p:spPr>
         <p:txBody>
-          <a:bodyPr wrap="square" lIns="101600" rIns="101600" tIns="76200" bIns="76200">
+          <a:bodyPr wrap="square" lIns="101600" tIns="76200" rIns="101600" bIns="76200">
             <a:spAutoFit/>
           </a:bodyPr>
           <a:lstStyle/>
@@ -9856,7 +9884,7 @@
           </a:fontRef>
         </p:style>
         <p:txBody>
-          <a:bodyPr rtlCol="0" anchor="ctr" wrap="square" lIns="101600" rIns="101600" tIns="76200" bIns="76200"/>
+          <a:bodyPr wrap="square" lIns="101600" tIns="76200" rIns="101600" bIns="76200" rtlCol="0" anchor="ctr"/>
           <a:lstStyle/>
           <a:p>
             <a:pPr algn="ctr"/>
@@ -9919,7 +9947,7 @@
           </a:fontRef>
         </p:style>
         <p:txBody>
-          <a:bodyPr rtlCol="0" anchor="ctr" wrap="square" lIns="101600" rIns="101600" tIns="76200" bIns="76200"/>
+          <a:bodyPr wrap="square" lIns="101600" tIns="76200" rIns="101600" bIns="76200" rtlCol="0" anchor="ctr"/>
           <a:lstStyle/>
           <a:p>
             <a:pPr algn="ctr"/>
@@ -9975,6 +10003,7 @@
           <a:lstStyle/>
           <a:p>
             <a:pPr algn="ctr"/>
+            <a:endParaRPr/>
           </a:p>
         </p:txBody>
       </p:sp>
@@ -10018,6 +10047,7 @@
           <a:lstStyle/>
           <a:p>
             <a:pPr algn="ctr"/>
+            <a:endParaRPr/>
           </a:p>
         </p:txBody>
       </p:sp>
@@ -10057,7 +10087,7 @@
           </a:fontRef>
         </p:style>
         <p:txBody>
-          <a:bodyPr rtlCol="0" anchor="ctr" wrap="none" lIns="50800" rIns="50800" tIns="12700" bIns="12700"/>
+          <a:bodyPr wrap="none" lIns="50800" tIns="12700" rIns="50800" bIns="12700" rtlCol="0" anchor="ctr"/>
           <a:lstStyle/>
           <a:p>
             <a:pPr algn="ctr"/>
@@ -10109,7 +10139,7 @@
           </a:fontRef>
         </p:style>
         <p:txBody>
-          <a:bodyPr rtlCol="0" anchor="ctr" wrap="none" lIns="50800" rIns="50800" tIns="12700" bIns="12700"/>
+          <a:bodyPr wrap="none" lIns="50800" tIns="12700" rIns="50800" bIns="12700" rtlCol="0" anchor="ctr"/>
           <a:lstStyle/>
           <a:p>
             <a:pPr algn="ctr"/>
@@ -10165,6 +10195,7 @@
           <a:lstStyle/>
           <a:p>
             <a:pPr algn="ctr"/>
+            <a:endParaRPr/>
           </a:p>
         </p:txBody>
       </p:sp>
@@ -10208,6 +10239,7 @@
           <a:lstStyle/>
           <a:p>
             <a:pPr algn="ctr"/>
+            <a:endParaRPr/>
           </a:p>
         </p:txBody>
       </p:sp>
@@ -10251,6 +10283,7 @@
           <a:lstStyle/>
           <a:p>
             <a:pPr algn="ctr"/>
+            <a:endParaRPr/>
           </a:p>
         </p:txBody>
       </p:sp>
@@ -10290,7 +10323,7 @@
           </a:fontRef>
         </p:style>
         <p:txBody>
-          <a:bodyPr rtlCol="0" anchor="ctr" wrap="none" lIns="50800" rIns="50800" tIns="12700" bIns="12700"/>
+          <a:bodyPr wrap="none" lIns="50800" tIns="12700" rIns="50800" bIns="12700" rtlCol="0" anchor="ctr"/>
           <a:lstStyle/>
           <a:p>
             <a:pPr algn="ctr"/>
@@ -10342,7 +10375,7 @@
           </a:fontRef>
         </p:style>
         <p:txBody>
-          <a:bodyPr rtlCol="0" anchor="ctr" wrap="none" lIns="50800" rIns="50800" tIns="12700" bIns="12700"/>
+          <a:bodyPr wrap="none" lIns="50800" tIns="12700" rIns="50800" bIns="12700" rtlCol="0" anchor="ctr"/>
           <a:lstStyle/>
           <a:p>
             <a:pPr algn="ctr"/>
@@ -10394,7 +10427,7 @@
           </a:fontRef>
         </p:style>
         <p:txBody>
-          <a:bodyPr rtlCol="0" anchor="ctr" wrap="none" lIns="50800" rIns="50800" tIns="12700" bIns="12700"/>
+          <a:bodyPr wrap="none" lIns="50800" tIns="12700" rIns="50800" bIns="12700" rtlCol="0" anchor="ctr"/>
           <a:lstStyle/>
           <a:p>
             <a:pPr algn="ctr"/>
@@ -10427,7 +10460,7 @@
           <a:noFill/>
         </p:spPr>
         <p:txBody>
-          <a:bodyPr wrap="square" lIns="0" rIns="0" tIns="0" bIns="0">
+          <a:bodyPr wrap="square" lIns="0" tIns="0" rIns="0" bIns="0">
             <a:spAutoFit/>
           </a:bodyPr>
           <a:lstStyle/>
@@ -10508,6 +10541,7 @@
           <a:lstStyle/>
           <a:p>
             <a:pPr algn="ctr"/>
+            <a:endParaRPr/>
           </a:p>
         </p:txBody>
       </p:sp>
@@ -10602,7 +10636,7 @@
           <a:noFill/>
         </p:spPr>
         <p:txBody>
-          <a:bodyPr wrap="none" lIns="101600" rIns="101600" tIns="76200" bIns="76200">
+          <a:bodyPr wrap="none" lIns="101600" tIns="76200" rIns="101600" bIns="76200">
             <a:spAutoFit/>
           </a:bodyPr>
           <a:lstStyle/>
@@ -10668,7 +10702,7 @@
           </a:fontRef>
         </p:style>
         <p:txBody>
-          <a:bodyPr rtlCol="0" anchor="ctr" wrap="none" lIns="101600" rIns="101600" tIns="76200" bIns="76200"/>
+          <a:bodyPr wrap="none" lIns="101600" tIns="76200" rIns="101600" bIns="76200" rtlCol="0" anchor="ctr"/>
           <a:lstStyle/>
           <a:p>
             <a:pPr algn="ctr"/>
@@ -10706,7 +10740,7 @@
           <a:noFill/>
         </p:spPr>
         <p:txBody>
-          <a:bodyPr wrap="square" lIns="101600" rIns="101600" tIns="76200" bIns="76200">
+          <a:bodyPr wrap="square" lIns="101600" tIns="76200" rIns="101600" bIns="76200">
             <a:spAutoFit/>
           </a:bodyPr>
           <a:lstStyle/>
@@ -10815,12 +10849,12 @@
           </a:fontRef>
         </p:style>
         <p:txBody>
-          <a:bodyPr lIns="101600" rIns="101600" rtlCol="0" anchor="ctr" wrap="square" tIns="76200" bIns="76200"/>
+          <a:bodyPr wrap="square" lIns="101600" tIns="76200" rIns="101600" bIns="76200" rtlCol="0" anchor="ctr"/>
           <a:lstStyle/>
           <a:p>
             <a:pPr algn="l"/>
             <a:r>
-              <a:rPr lang="ru-RU" b="1" sz="1300">
+              <a:rPr lang="ru-RU" sz="1300" b="1">
                 <a:solidFill>
                   <a:srgbClr val="111111"/>
                 </a:solidFill>
@@ -10853,7 +10887,7 @@
           <a:noFill/>
         </p:spPr>
         <p:txBody>
-          <a:bodyPr wrap="square" lIns="127000" rIns="101600" tIns="76200" bIns="76200">
+          <a:bodyPr wrap="square" lIns="127000" tIns="76200" rIns="101600" bIns="76200">
             <a:spAutoFit/>
           </a:bodyPr>
           <a:lstStyle/>
@@ -10993,7 +11027,7 @@
           <a:noFill/>
         </p:spPr>
         <p:txBody>
-          <a:bodyPr wrap="square" lIns="101600" rIns="101600" tIns="76200" bIns="76200">
+          <a:bodyPr wrap="square" lIns="101600" tIns="76200" rIns="101600" bIns="76200">
             <a:spAutoFit/>
           </a:bodyPr>
           <a:lstStyle/>
@@ -11042,7 +11076,7 @@
           </a:fontRef>
         </p:style>
         <p:txBody>
-          <a:bodyPr rtlCol="0" anchor="ctr" wrap="square" lIns="101600" rIns="101600" tIns="76200" bIns="76200"/>
+          <a:bodyPr wrap="square" lIns="101600" tIns="76200" rIns="101600" bIns="76200" rtlCol="0" anchor="ctr"/>
           <a:lstStyle/>
           <a:p>
             <a:pPr algn="ctr"/>
@@ -11105,7 +11139,7 @@
           </a:fontRef>
         </p:style>
         <p:txBody>
-          <a:bodyPr rtlCol="0" anchor="ctr" wrap="square" lIns="101600" rIns="101600" tIns="76200" bIns="76200"/>
+          <a:bodyPr wrap="square" lIns="101600" tIns="76200" rIns="101600" bIns="76200" rtlCol="0" anchor="ctr"/>
           <a:lstStyle/>
           <a:p>
             <a:pPr algn="ctr"/>
@@ -11161,6 +11195,7 @@
           <a:lstStyle/>
           <a:p>
             <a:pPr algn="ctr"/>
+            <a:endParaRPr/>
           </a:p>
         </p:txBody>
       </p:sp>
@@ -11204,6 +11239,7 @@
           <a:lstStyle/>
           <a:p>
             <a:pPr algn="ctr"/>
+            <a:endParaRPr/>
           </a:p>
         </p:txBody>
       </p:sp>
@@ -11243,7 +11279,7 @@
           </a:fontRef>
         </p:style>
         <p:txBody>
-          <a:bodyPr rtlCol="0" anchor="ctr" wrap="none" lIns="50800" rIns="50800" tIns="12700" bIns="12700"/>
+          <a:bodyPr wrap="none" lIns="50800" tIns="12700" rIns="50800" bIns="12700" rtlCol="0" anchor="ctr"/>
           <a:lstStyle/>
           <a:p>
             <a:pPr algn="ctr"/>
@@ -11295,7 +11331,7 @@
           </a:fontRef>
         </p:style>
         <p:txBody>
-          <a:bodyPr rtlCol="0" anchor="ctr" wrap="none" lIns="50800" rIns="50800" tIns="12700" bIns="12700"/>
+          <a:bodyPr wrap="none" lIns="50800" tIns="12700" rIns="50800" bIns="12700" rtlCol="0" anchor="ctr"/>
           <a:lstStyle/>
           <a:p>
             <a:pPr algn="ctr"/>
@@ -11351,6 +11387,7 @@
           <a:lstStyle/>
           <a:p>
             <a:pPr algn="ctr"/>
+            <a:endParaRPr/>
           </a:p>
         </p:txBody>
       </p:sp>
@@ -11394,6 +11431,7 @@
           <a:lstStyle/>
           <a:p>
             <a:pPr algn="ctr"/>
+            <a:endParaRPr/>
           </a:p>
         </p:txBody>
       </p:sp>
@@ -11437,6 +11475,7 @@
           <a:lstStyle/>
           <a:p>
             <a:pPr algn="ctr"/>
+            <a:endParaRPr/>
           </a:p>
         </p:txBody>
       </p:sp>
@@ -11476,7 +11515,7 @@
           </a:fontRef>
         </p:style>
         <p:txBody>
-          <a:bodyPr rtlCol="0" anchor="ctr" wrap="none" lIns="50800" rIns="50800" tIns="12700" bIns="12700"/>
+          <a:bodyPr wrap="none" lIns="50800" tIns="12700" rIns="50800" bIns="12700" rtlCol="0" anchor="ctr"/>
           <a:lstStyle/>
           <a:p>
             <a:pPr algn="ctr"/>
@@ -11528,7 +11567,7 @@
           </a:fontRef>
         </p:style>
         <p:txBody>
-          <a:bodyPr rtlCol="0" anchor="ctr" wrap="none" lIns="50800" rIns="50800" tIns="12700" bIns="12700"/>
+          <a:bodyPr wrap="none" lIns="50800" tIns="12700" rIns="50800" bIns="12700" rtlCol="0" anchor="ctr"/>
           <a:lstStyle/>
           <a:p>
             <a:pPr algn="ctr"/>
@@ -11580,7 +11619,7 @@
           </a:fontRef>
         </p:style>
         <p:txBody>
-          <a:bodyPr rtlCol="0" anchor="ctr" wrap="none" lIns="50800" rIns="50800" tIns="12700" bIns="12700"/>
+          <a:bodyPr wrap="none" lIns="50800" tIns="12700" rIns="50800" bIns="12700" rtlCol="0" anchor="ctr"/>
           <a:lstStyle/>
           <a:p>
             <a:pPr algn="ctr"/>
@@ -11613,7 +11652,7 @@
           <a:noFill/>
         </p:spPr>
         <p:txBody>
-          <a:bodyPr wrap="square" lIns="0" rIns="0" tIns="0" bIns="0">
+          <a:bodyPr wrap="square" lIns="0" tIns="0" rIns="0" bIns="0">
             <a:spAutoFit/>
           </a:bodyPr>
           <a:lstStyle/>
@@ -11694,6 +11733,7 @@
           <a:lstStyle/>
           <a:p>
             <a:pPr algn="ctr"/>
+            <a:endParaRPr/>
           </a:p>
         </p:txBody>
       </p:sp>
@@ -11788,7 +11828,7 @@
           <a:noFill/>
         </p:spPr>
         <p:txBody>
-          <a:bodyPr wrap="none" lIns="101600" rIns="101600" tIns="76200" bIns="76200">
+          <a:bodyPr wrap="none" lIns="101600" tIns="76200" rIns="101600" bIns="76200">
             <a:spAutoFit/>
           </a:bodyPr>
           <a:lstStyle/>
@@ -11854,7 +11894,7 @@
           </a:fontRef>
         </p:style>
         <p:txBody>
-          <a:bodyPr rtlCol="0" anchor="ctr" wrap="none" lIns="101600" rIns="101600" tIns="76200" bIns="76200"/>
+          <a:bodyPr wrap="none" lIns="101600" tIns="76200" rIns="101600" bIns="76200" rtlCol="0" anchor="ctr"/>
           <a:lstStyle/>
           <a:p>
             <a:pPr algn="ctr"/>
@@ -11892,7 +11932,7 @@
           <a:noFill/>
         </p:spPr>
         <p:txBody>
-          <a:bodyPr wrap="square" lIns="101600" rIns="101600" tIns="76200" bIns="76200">
+          <a:bodyPr wrap="square" lIns="101600" tIns="76200" rIns="101600" bIns="76200">
             <a:spAutoFit/>
           </a:bodyPr>
           <a:lstStyle/>
@@ -12001,12 +12041,12 @@
           </a:fontRef>
         </p:style>
         <p:txBody>
-          <a:bodyPr lIns="101600" rIns="101600" rtlCol="0" anchor="ctr" wrap="square" tIns="76200" bIns="76200"/>
+          <a:bodyPr wrap="square" lIns="101600" tIns="76200" rIns="101600" bIns="76200" rtlCol="0" anchor="ctr"/>
           <a:lstStyle/>
           <a:p>
             <a:pPr algn="l"/>
             <a:r>
-              <a:rPr lang="ru-RU" b="1" sz="1300">
+              <a:rPr lang="ru-RU" sz="1300" b="1">
                 <a:solidFill>
                   <a:srgbClr val="111111"/>
                 </a:solidFill>
@@ -12039,7 +12079,7 @@
           <a:noFill/>
         </p:spPr>
         <p:txBody>
-          <a:bodyPr wrap="square" lIns="127000" rIns="101600" tIns="76200" bIns="76200">
+          <a:bodyPr wrap="square" lIns="127000" tIns="76200" rIns="101600" bIns="76200">
             <a:spAutoFit/>
           </a:bodyPr>
           <a:lstStyle/>
@@ -12179,7 +12219,7 @@
           <a:noFill/>
         </p:spPr>
         <p:txBody>
-          <a:bodyPr wrap="square" lIns="101600" rIns="101600" tIns="76200" bIns="76200">
+          <a:bodyPr wrap="square" lIns="101600" tIns="76200" rIns="101600" bIns="76200">
             <a:spAutoFit/>
           </a:bodyPr>
           <a:lstStyle/>
@@ -12228,7 +12268,7 @@
           </a:fontRef>
         </p:style>
         <p:txBody>
-          <a:bodyPr rtlCol="0" anchor="ctr" wrap="square" lIns="101600" rIns="101600" tIns="76200" bIns="76200"/>
+          <a:bodyPr wrap="square" lIns="101600" tIns="76200" rIns="101600" bIns="76200" rtlCol="0" anchor="ctr"/>
           <a:lstStyle/>
           <a:p>
             <a:pPr algn="ctr"/>
@@ -12291,7 +12331,7 @@
           </a:fontRef>
         </p:style>
         <p:txBody>
-          <a:bodyPr rtlCol="0" anchor="ctr" wrap="square" lIns="101600" rIns="101600" tIns="76200" bIns="76200"/>
+          <a:bodyPr wrap="square" lIns="101600" tIns="76200" rIns="101600" bIns="76200" rtlCol="0" anchor="ctr"/>
           <a:lstStyle/>
           <a:p>
             <a:pPr algn="ctr"/>
@@ -12347,6 +12387,7 @@
           <a:lstStyle/>
           <a:p>
             <a:pPr algn="ctr"/>
+            <a:endParaRPr/>
           </a:p>
         </p:txBody>
       </p:sp>
@@ -12390,6 +12431,7 @@
           <a:lstStyle/>
           <a:p>
             <a:pPr algn="ctr"/>
+            <a:endParaRPr/>
           </a:p>
         </p:txBody>
       </p:sp>
@@ -12429,7 +12471,7 @@
           </a:fontRef>
         </p:style>
         <p:txBody>
-          <a:bodyPr rtlCol="0" anchor="ctr" wrap="none" lIns="50800" rIns="50800" tIns="12700" bIns="12700"/>
+          <a:bodyPr wrap="none" lIns="50800" tIns="12700" rIns="50800" bIns="12700" rtlCol="0" anchor="ctr"/>
           <a:lstStyle/>
           <a:p>
             <a:pPr algn="ctr"/>
@@ -12481,7 +12523,7 @@
           </a:fontRef>
         </p:style>
         <p:txBody>
-          <a:bodyPr rtlCol="0" anchor="ctr" wrap="none" lIns="50800" rIns="50800" tIns="12700" bIns="12700"/>
+          <a:bodyPr wrap="none" lIns="50800" tIns="12700" rIns="50800" bIns="12700" rtlCol="0" anchor="ctr"/>
           <a:lstStyle/>
           <a:p>
             <a:pPr algn="ctr"/>
@@ -12537,6 +12579,7 @@
           <a:lstStyle/>
           <a:p>
             <a:pPr algn="ctr"/>
+            <a:endParaRPr/>
           </a:p>
         </p:txBody>
       </p:sp>
@@ -12580,6 +12623,7 @@
           <a:lstStyle/>
           <a:p>
             <a:pPr algn="ctr"/>
+            <a:endParaRPr/>
           </a:p>
         </p:txBody>
       </p:sp>
@@ -12623,6 +12667,7 @@
           <a:lstStyle/>
           <a:p>
             <a:pPr algn="ctr"/>
+            <a:endParaRPr/>
           </a:p>
         </p:txBody>
       </p:sp>
@@ -12662,7 +12707,7 @@
           </a:fontRef>
         </p:style>
         <p:txBody>
-          <a:bodyPr rtlCol="0" anchor="ctr" wrap="none" lIns="50800" rIns="50800" tIns="12700" bIns="12700"/>
+          <a:bodyPr wrap="none" lIns="50800" tIns="12700" rIns="50800" bIns="12700" rtlCol="0" anchor="ctr"/>
           <a:lstStyle/>
           <a:p>
             <a:pPr algn="ctr"/>
@@ -12714,7 +12759,7 @@
           </a:fontRef>
         </p:style>
         <p:txBody>
-          <a:bodyPr rtlCol="0" anchor="ctr" wrap="none" lIns="50800" rIns="50800" tIns="12700" bIns="12700"/>
+          <a:bodyPr wrap="none" lIns="50800" tIns="12700" rIns="50800" bIns="12700" rtlCol="0" anchor="ctr"/>
           <a:lstStyle/>
           <a:p>
             <a:pPr algn="ctr"/>
@@ -12766,7 +12811,7 @@
           </a:fontRef>
         </p:style>
         <p:txBody>
-          <a:bodyPr rtlCol="0" anchor="ctr" wrap="none" lIns="50800" rIns="50800" tIns="12700" bIns="12700"/>
+          <a:bodyPr wrap="none" lIns="50800" tIns="12700" rIns="50800" bIns="12700" rtlCol="0" anchor="ctr"/>
           <a:lstStyle/>
           <a:p>
             <a:pPr algn="ctr"/>
@@ -12799,7 +12844,7 @@
           <a:noFill/>
         </p:spPr>
         <p:txBody>
-          <a:bodyPr wrap="square" lIns="0" rIns="0" tIns="0" bIns="0">
+          <a:bodyPr wrap="square" lIns="0" tIns="0" rIns="0" bIns="0">
             <a:spAutoFit/>
           </a:bodyPr>
           <a:lstStyle/>
@@ -12880,6 +12925,7 @@
           <a:lstStyle/>
           <a:p>
             <a:pPr algn="ctr"/>
+            <a:endParaRPr/>
           </a:p>
         </p:txBody>
       </p:sp>
@@ -12974,7 +13020,7 @@
           <a:noFill/>
         </p:spPr>
         <p:txBody>
-          <a:bodyPr wrap="none" lIns="101600" rIns="101600" tIns="76200" bIns="76200">
+          <a:bodyPr wrap="none" lIns="101600" tIns="76200" rIns="101600" bIns="76200">
             <a:spAutoFit/>
           </a:bodyPr>
           <a:lstStyle/>
@@ -13040,7 +13086,7 @@
           </a:fontRef>
         </p:style>
         <p:txBody>
-          <a:bodyPr rtlCol="0" anchor="ctr" wrap="none" lIns="101600" rIns="101600" tIns="76200" bIns="76200"/>
+          <a:bodyPr wrap="none" lIns="101600" tIns="76200" rIns="101600" bIns="76200" rtlCol="0" anchor="ctr"/>
           <a:lstStyle/>
           <a:p>
             <a:pPr algn="ctr"/>
@@ -13078,7 +13124,7 @@
           <a:noFill/>
         </p:spPr>
         <p:txBody>
-          <a:bodyPr wrap="square" lIns="101600" rIns="101600" tIns="76200" bIns="76200">
+          <a:bodyPr wrap="square" lIns="101600" tIns="76200" rIns="101600" bIns="76200">
             <a:spAutoFit/>
           </a:bodyPr>
           <a:lstStyle/>
@@ -13187,12 +13233,12 @@
           </a:fontRef>
         </p:style>
         <p:txBody>
-          <a:bodyPr lIns="101600" rIns="101600" rtlCol="0" anchor="ctr" wrap="square" tIns="76200" bIns="76200"/>
+          <a:bodyPr wrap="square" lIns="101600" tIns="76200" rIns="101600" bIns="76200" rtlCol="0" anchor="ctr"/>
           <a:lstStyle/>
           <a:p>
             <a:pPr algn="l"/>
             <a:r>
-              <a:rPr lang="ru-RU" b="1" sz="1300">
+              <a:rPr lang="ru-RU" sz="1300" b="1">
                 <a:solidFill>
                   <a:srgbClr val="111111"/>
                 </a:solidFill>
@@ -13225,7 +13271,7 @@
           <a:noFill/>
         </p:spPr>
         <p:txBody>
-          <a:bodyPr wrap="square" lIns="127000" rIns="101600" tIns="76200" bIns="76200">
+          <a:bodyPr wrap="square" lIns="127000" tIns="76200" rIns="101600" bIns="76200">
             <a:spAutoFit/>
           </a:bodyPr>
           <a:lstStyle/>
@@ -13381,7 +13427,7 @@
           <a:noFill/>
         </p:spPr>
         <p:txBody>
-          <a:bodyPr wrap="square" lIns="101600" rIns="101600" tIns="76200" bIns="76200">
+          <a:bodyPr wrap="square" lIns="101600" tIns="76200" rIns="101600" bIns="76200">
             <a:spAutoFit/>
           </a:bodyPr>
           <a:lstStyle/>
@@ -13430,7 +13476,7 @@
           </a:fontRef>
         </p:style>
         <p:txBody>
-          <a:bodyPr rtlCol="0" anchor="ctr" wrap="square" lIns="101600" rIns="101600" tIns="76200" bIns="76200"/>
+          <a:bodyPr wrap="square" lIns="101600" tIns="76200" rIns="101600" bIns="76200" rtlCol="0" anchor="ctr"/>
           <a:lstStyle/>
           <a:p>
             <a:pPr algn="ctr"/>
@@ -13493,7 +13539,7 @@
           </a:fontRef>
         </p:style>
         <p:txBody>
-          <a:bodyPr rtlCol="0" anchor="ctr" wrap="square" lIns="101600" rIns="101600" tIns="76200" bIns="76200"/>
+          <a:bodyPr wrap="square" lIns="101600" tIns="76200" rIns="101600" bIns="76200" rtlCol="0" anchor="ctr"/>
           <a:lstStyle/>
           <a:p>
             <a:pPr algn="ctr"/>
@@ -13549,6 +13595,7 @@
           <a:lstStyle/>
           <a:p>
             <a:pPr algn="ctr"/>
+            <a:endParaRPr/>
           </a:p>
         </p:txBody>
       </p:sp>
@@ -13592,6 +13639,7 @@
           <a:lstStyle/>
           <a:p>
             <a:pPr algn="ctr"/>
+            <a:endParaRPr/>
           </a:p>
         </p:txBody>
       </p:sp>
@@ -13631,7 +13679,7 @@
           </a:fontRef>
         </p:style>
         <p:txBody>
-          <a:bodyPr rtlCol="0" anchor="ctr" wrap="none" lIns="50800" rIns="50800" tIns="12700" bIns="12700"/>
+          <a:bodyPr wrap="none" lIns="50800" tIns="12700" rIns="50800" bIns="12700" rtlCol="0" anchor="ctr"/>
           <a:lstStyle/>
           <a:p>
             <a:pPr algn="ctr"/>
@@ -13683,7 +13731,7 @@
           </a:fontRef>
         </p:style>
         <p:txBody>
-          <a:bodyPr rtlCol="0" anchor="ctr" wrap="none" lIns="50800" rIns="50800" tIns="12700" bIns="12700"/>
+          <a:bodyPr wrap="none" lIns="50800" tIns="12700" rIns="50800" bIns="12700" rtlCol="0" anchor="ctr"/>
           <a:lstStyle/>
           <a:p>
             <a:pPr algn="ctr"/>
@@ -13739,6 +13787,7 @@
           <a:lstStyle/>
           <a:p>
             <a:pPr algn="ctr"/>
+            <a:endParaRPr/>
           </a:p>
         </p:txBody>
       </p:sp>
@@ -13782,6 +13831,7 @@
           <a:lstStyle/>
           <a:p>
             <a:pPr algn="ctr"/>
+            <a:endParaRPr/>
           </a:p>
         </p:txBody>
       </p:sp>
@@ -13825,6 +13875,7 @@
           <a:lstStyle/>
           <a:p>
             <a:pPr algn="ctr"/>
+            <a:endParaRPr/>
           </a:p>
         </p:txBody>
       </p:sp>
@@ -13864,7 +13915,7 @@
           </a:fontRef>
         </p:style>
         <p:txBody>
-          <a:bodyPr rtlCol="0" anchor="ctr" wrap="none" lIns="50800" rIns="50800" tIns="12700" bIns="12700"/>
+          <a:bodyPr wrap="none" lIns="50800" tIns="12700" rIns="50800" bIns="12700" rtlCol="0" anchor="ctr"/>
           <a:lstStyle/>
           <a:p>
             <a:pPr algn="ctr"/>
@@ -13916,7 +13967,7 @@
           </a:fontRef>
         </p:style>
         <p:txBody>
-          <a:bodyPr rtlCol="0" anchor="ctr" wrap="none" lIns="50800" rIns="50800" tIns="12700" bIns="12700"/>
+          <a:bodyPr wrap="none" lIns="50800" tIns="12700" rIns="50800" bIns="12700" rtlCol="0" anchor="ctr"/>
           <a:lstStyle/>
           <a:p>
             <a:pPr algn="ctr"/>
@@ -13968,7 +14019,7 @@
           </a:fontRef>
         </p:style>
         <p:txBody>
-          <a:bodyPr rtlCol="0" anchor="ctr" wrap="none" lIns="50800" rIns="50800" tIns="12700" bIns="12700"/>
+          <a:bodyPr wrap="none" lIns="50800" tIns="12700" rIns="50800" bIns="12700" rtlCol="0" anchor="ctr"/>
           <a:lstStyle/>
           <a:p>
             <a:pPr algn="ctr"/>
@@ -14001,7 +14052,7 @@
           <a:noFill/>
         </p:spPr>
         <p:txBody>
-          <a:bodyPr wrap="square" lIns="0" rIns="0" tIns="0" bIns="0">
+          <a:bodyPr wrap="square" lIns="0" tIns="0" rIns="0" bIns="0">
             <a:spAutoFit/>
           </a:bodyPr>
           <a:lstStyle/>
@@ -14082,6 +14133,7 @@
           <a:lstStyle/>
           <a:p>
             <a:pPr algn="ctr"/>
+            <a:endParaRPr/>
           </a:p>
         </p:txBody>
       </p:sp>
@@ -14176,7 +14228,7 @@
           <a:noFill/>
         </p:spPr>
         <p:txBody>
-          <a:bodyPr wrap="none" lIns="101600" rIns="101600" tIns="76200" bIns="76200">
+          <a:bodyPr wrap="none" lIns="101600" tIns="76200" rIns="101600" bIns="76200">
             <a:spAutoFit/>
           </a:bodyPr>
           <a:lstStyle/>
@@ -14242,7 +14294,7 @@
           </a:fontRef>
         </p:style>
         <p:txBody>
-          <a:bodyPr rtlCol="0" anchor="ctr" wrap="none" lIns="101600" rIns="101600" tIns="76200" bIns="76200"/>
+          <a:bodyPr wrap="none" lIns="101600" tIns="76200" rIns="101600" bIns="76200" rtlCol="0" anchor="ctr"/>
           <a:lstStyle/>
           <a:p>
             <a:pPr algn="ctr"/>
@@ -14280,7 +14332,7 @@
           <a:noFill/>
         </p:spPr>
         <p:txBody>
-          <a:bodyPr wrap="square" lIns="101600" rIns="101600" tIns="76200" bIns="76200">
+          <a:bodyPr wrap="square" lIns="101600" tIns="76200" rIns="101600" bIns="76200">
             <a:spAutoFit/>
           </a:bodyPr>
           <a:lstStyle/>
@@ -14389,12 +14441,12 @@
           </a:fontRef>
         </p:style>
         <p:txBody>
-          <a:bodyPr lIns="101600" rIns="101600" rtlCol="0" anchor="ctr" wrap="square" tIns="76200" bIns="76200"/>
+          <a:bodyPr wrap="square" lIns="101600" tIns="76200" rIns="101600" bIns="76200" rtlCol="0" anchor="ctr"/>
           <a:lstStyle/>
           <a:p>
             <a:pPr algn="l"/>
             <a:r>
-              <a:rPr lang="ru-RU" b="1" sz="1300">
+              <a:rPr lang="ru-RU" sz="1300" b="1">
                 <a:solidFill>
                   <a:srgbClr val="111111"/>
                 </a:solidFill>
@@ -14427,7 +14479,7 @@
           <a:noFill/>
         </p:spPr>
         <p:txBody>
-          <a:bodyPr wrap="square" lIns="127000" rIns="101600" tIns="76200" bIns="76200">
+          <a:bodyPr wrap="square" lIns="127000" tIns="76200" rIns="101600" bIns="76200">
             <a:spAutoFit/>
           </a:bodyPr>
           <a:lstStyle/>
@@ -14583,7 +14635,7 @@
           <a:noFill/>
         </p:spPr>
         <p:txBody>
-          <a:bodyPr wrap="square" lIns="101600" rIns="101600" tIns="76200" bIns="76200">
+          <a:bodyPr wrap="square" lIns="101600" tIns="76200" rIns="101600" bIns="76200">
             <a:spAutoFit/>
           </a:bodyPr>
           <a:lstStyle/>
@@ -14632,7 +14684,7 @@
           </a:fontRef>
         </p:style>
         <p:txBody>
-          <a:bodyPr rtlCol="0" anchor="ctr" wrap="square" lIns="101600" rIns="101600" tIns="76200" bIns="76200"/>
+          <a:bodyPr wrap="square" lIns="101600" tIns="76200" rIns="101600" bIns="76200" rtlCol="0" anchor="ctr"/>
           <a:lstStyle/>
           <a:p>
             <a:pPr algn="ctr"/>
@@ -14695,7 +14747,7 @@
           </a:fontRef>
         </p:style>
         <p:txBody>
-          <a:bodyPr rtlCol="0" anchor="ctr" wrap="square" lIns="101600" rIns="101600" tIns="76200" bIns="76200"/>
+          <a:bodyPr wrap="square" lIns="101600" tIns="76200" rIns="101600" bIns="76200" rtlCol="0" anchor="ctr"/>
           <a:lstStyle/>
           <a:p>
             <a:pPr algn="ctr"/>
@@ -14751,6 +14803,7 @@
           <a:lstStyle/>
           <a:p>
             <a:pPr algn="ctr"/>
+            <a:endParaRPr/>
           </a:p>
         </p:txBody>
       </p:sp>
@@ -14794,6 +14847,7 @@
           <a:lstStyle/>
           <a:p>
             <a:pPr algn="ctr"/>
+            <a:endParaRPr/>
           </a:p>
         </p:txBody>
       </p:sp>
@@ -14833,7 +14887,7 @@
           </a:fontRef>
         </p:style>
         <p:txBody>
-          <a:bodyPr rtlCol="0" anchor="ctr" wrap="none" lIns="50800" rIns="50800" tIns="12700" bIns="12700"/>
+          <a:bodyPr wrap="none" lIns="50800" tIns="12700" rIns="50800" bIns="12700" rtlCol="0" anchor="ctr"/>
           <a:lstStyle/>
           <a:p>
             <a:pPr algn="ctr"/>
@@ -14885,7 +14939,7 @@
           </a:fontRef>
         </p:style>
         <p:txBody>
-          <a:bodyPr rtlCol="0" anchor="ctr" wrap="none" lIns="50800" rIns="50800" tIns="12700" bIns="12700"/>
+          <a:bodyPr wrap="none" lIns="50800" tIns="12700" rIns="50800" bIns="12700" rtlCol="0" anchor="ctr"/>
           <a:lstStyle/>
           <a:p>
             <a:pPr algn="ctr"/>
@@ -14941,6 +14995,7 @@
           <a:lstStyle/>
           <a:p>
             <a:pPr algn="ctr"/>
+            <a:endParaRPr/>
           </a:p>
         </p:txBody>
       </p:sp>
@@ -14984,6 +15039,7 @@
           <a:lstStyle/>
           <a:p>
             <a:pPr algn="ctr"/>
+            <a:endParaRPr/>
           </a:p>
         </p:txBody>
       </p:sp>
@@ -15027,6 +15083,7 @@
           <a:lstStyle/>
           <a:p>
             <a:pPr algn="ctr"/>
+            <a:endParaRPr/>
           </a:p>
         </p:txBody>
       </p:sp>
@@ -15066,7 +15123,7 @@
           </a:fontRef>
         </p:style>
         <p:txBody>
-          <a:bodyPr rtlCol="0" anchor="ctr" wrap="none" lIns="50800" rIns="50800" tIns="12700" bIns="12700"/>
+          <a:bodyPr wrap="none" lIns="50800" tIns="12700" rIns="50800" bIns="12700" rtlCol="0" anchor="ctr"/>
           <a:lstStyle/>
           <a:p>
             <a:pPr algn="ctr"/>
@@ -15118,7 +15175,7 @@
           </a:fontRef>
         </p:style>
         <p:txBody>
-          <a:bodyPr rtlCol="0" anchor="ctr" wrap="none" lIns="50800" rIns="50800" tIns="12700" bIns="12700"/>
+          <a:bodyPr wrap="none" lIns="50800" tIns="12700" rIns="50800" bIns="12700" rtlCol="0" anchor="ctr"/>
           <a:lstStyle/>
           <a:p>
             <a:pPr algn="ctr"/>
@@ -15170,7 +15227,7 @@
           </a:fontRef>
         </p:style>
         <p:txBody>
-          <a:bodyPr rtlCol="0" anchor="ctr" wrap="none" lIns="50800" rIns="50800" tIns="12700" bIns="12700"/>
+          <a:bodyPr wrap="none" lIns="50800" tIns="12700" rIns="50800" bIns="12700" rtlCol="0" anchor="ctr"/>
           <a:lstStyle/>
           <a:p>
             <a:pPr algn="ctr"/>
@@ -15203,7 +15260,7 @@
           <a:noFill/>
         </p:spPr>
         <p:txBody>
-          <a:bodyPr wrap="square" lIns="0" rIns="0" tIns="0" bIns="0">
+          <a:bodyPr wrap="square" lIns="0" tIns="0" rIns="0" bIns="0">
             <a:spAutoFit/>
           </a:bodyPr>
           <a:lstStyle/>
@@ -15284,6 +15341,7 @@
           <a:lstStyle/>
           <a:p>
             <a:pPr algn="ctr"/>
+            <a:endParaRPr/>
           </a:p>
         </p:txBody>
       </p:sp>
@@ -15378,7 +15436,7 @@
           <a:noFill/>
         </p:spPr>
         <p:txBody>
-          <a:bodyPr wrap="none" lIns="101600" rIns="101600" tIns="76200" bIns="76200">
+          <a:bodyPr wrap="none" lIns="101600" tIns="76200" rIns="101600" bIns="76200">
             <a:spAutoFit/>
           </a:bodyPr>
           <a:lstStyle/>
@@ -15444,7 +15502,7 @@
           </a:fontRef>
         </p:style>
         <p:txBody>
-          <a:bodyPr rtlCol="0" anchor="ctr" wrap="none" lIns="101600" rIns="101600" tIns="76200" bIns="76200"/>
+          <a:bodyPr wrap="none" lIns="101600" tIns="76200" rIns="101600" bIns="76200" rtlCol="0" anchor="ctr"/>
           <a:lstStyle/>
           <a:p>
             <a:pPr algn="ctr"/>
@@ -15482,7 +15540,7 @@
           <a:noFill/>
         </p:spPr>
         <p:txBody>
-          <a:bodyPr wrap="square" lIns="101600" rIns="101600" tIns="76200" bIns="76200">
+          <a:bodyPr wrap="square" lIns="101600" tIns="76200" rIns="101600" bIns="76200">
             <a:spAutoFit/>
           </a:bodyPr>
           <a:lstStyle/>
@@ -15591,12 +15649,12 @@
           </a:fontRef>
         </p:style>
         <p:txBody>
-          <a:bodyPr lIns="101600" rIns="101600" rtlCol="0" anchor="ctr" wrap="square" tIns="76200" bIns="76200"/>
+          <a:bodyPr wrap="square" lIns="101600" tIns="76200" rIns="101600" bIns="76200" rtlCol="0" anchor="ctr"/>
           <a:lstStyle/>
           <a:p>
             <a:pPr algn="l"/>
             <a:r>
-              <a:rPr lang="ru-RU" b="1" sz="1300">
+              <a:rPr lang="ru-RU" sz="1300" b="1">
                 <a:solidFill>
                   <a:srgbClr val="111111"/>
                 </a:solidFill>
@@ -15629,7 +15687,7 @@
           <a:noFill/>
         </p:spPr>
         <p:txBody>
-          <a:bodyPr wrap="square" lIns="127000" rIns="101600" tIns="76200" bIns="76200">
+          <a:bodyPr wrap="square" lIns="127000" tIns="76200" rIns="101600" bIns="76200">
             <a:spAutoFit/>
           </a:bodyPr>
           <a:lstStyle/>
@@ -15785,7 +15843,7 @@
           <a:noFill/>
         </p:spPr>
         <p:txBody>
-          <a:bodyPr wrap="square" lIns="101600" rIns="101600" tIns="76200" bIns="76200">
+          <a:bodyPr wrap="square" lIns="101600" tIns="76200" rIns="101600" bIns="76200">
             <a:spAutoFit/>
           </a:bodyPr>
           <a:lstStyle/>
@@ -15834,7 +15892,7 @@
           </a:fontRef>
         </p:style>
         <p:txBody>
-          <a:bodyPr rtlCol="0" anchor="ctr" wrap="square" lIns="101600" rIns="101600" tIns="76200" bIns="76200"/>
+          <a:bodyPr wrap="square" lIns="101600" tIns="76200" rIns="101600" bIns="76200" rtlCol="0" anchor="ctr"/>
           <a:lstStyle/>
           <a:p>
             <a:pPr algn="ctr"/>
@@ -15897,7 +15955,7 @@
           </a:fontRef>
         </p:style>
         <p:txBody>
-          <a:bodyPr rtlCol="0" anchor="ctr" wrap="square" lIns="101600" rIns="101600" tIns="76200" bIns="76200"/>
+          <a:bodyPr wrap="square" lIns="101600" tIns="76200" rIns="101600" bIns="76200" rtlCol="0" anchor="ctr"/>
           <a:lstStyle/>
           <a:p>
             <a:pPr algn="ctr"/>
@@ -15953,6 +16011,7 @@
           <a:lstStyle/>
           <a:p>
             <a:pPr algn="ctr"/>
+            <a:endParaRPr/>
           </a:p>
         </p:txBody>
       </p:sp>
@@ -15996,6 +16055,7 @@
           <a:lstStyle/>
           <a:p>
             <a:pPr algn="ctr"/>
+            <a:endParaRPr/>
           </a:p>
         </p:txBody>
       </p:sp>
@@ -16035,7 +16095,7 @@
           </a:fontRef>
         </p:style>
         <p:txBody>
-          <a:bodyPr rtlCol="0" anchor="ctr" wrap="none" lIns="50800" rIns="50800" tIns="12700" bIns="12700"/>
+          <a:bodyPr wrap="none" lIns="50800" tIns="12700" rIns="50800" bIns="12700" rtlCol="0" anchor="ctr"/>
           <a:lstStyle/>
           <a:p>
             <a:pPr algn="ctr"/>
@@ -16087,7 +16147,7 @@
           </a:fontRef>
         </p:style>
         <p:txBody>
-          <a:bodyPr rtlCol="0" anchor="ctr" wrap="none" lIns="50800" rIns="50800" tIns="12700" bIns="12700"/>
+          <a:bodyPr wrap="none" lIns="50800" tIns="12700" rIns="50800" bIns="12700" rtlCol="0" anchor="ctr"/>
           <a:lstStyle/>
           <a:p>
             <a:pPr algn="ctr"/>
@@ -16143,6 +16203,7 @@
           <a:lstStyle/>
           <a:p>
             <a:pPr algn="ctr"/>
+            <a:endParaRPr/>
           </a:p>
         </p:txBody>
       </p:sp>
@@ -16186,6 +16247,7 @@
           <a:lstStyle/>
           <a:p>
             <a:pPr algn="ctr"/>
+            <a:endParaRPr/>
           </a:p>
         </p:txBody>
       </p:sp>
@@ -16229,6 +16291,7 @@
           <a:lstStyle/>
           <a:p>
             <a:pPr algn="ctr"/>
+            <a:endParaRPr/>
           </a:p>
         </p:txBody>
       </p:sp>
@@ -16268,7 +16331,7 @@
           </a:fontRef>
         </p:style>
         <p:txBody>
-          <a:bodyPr rtlCol="0" anchor="ctr" wrap="none" lIns="50800" rIns="50800" tIns="12700" bIns="12700"/>
+          <a:bodyPr wrap="none" lIns="50800" tIns="12700" rIns="50800" bIns="12700" rtlCol="0" anchor="ctr"/>
           <a:lstStyle/>
           <a:p>
             <a:pPr algn="ctr"/>
@@ -16320,7 +16383,7 @@
           </a:fontRef>
         </p:style>
         <p:txBody>
-          <a:bodyPr rtlCol="0" anchor="ctr" wrap="none" lIns="50800" rIns="50800" tIns="12700" bIns="12700"/>
+          <a:bodyPr wrap="none" lIns="50800" tIns="12700" rIns="50800" bIns="12700" rtlCol="0" anchor="ctr"/>
           <a:lstStyle/>
           <a:p>
             <a:pPr algn="ctr"/>
@@ -16372,7 +16435,7 @@
           </a:fontRef>
         </p:style>
         <p:txBody>
-          <a:bodyPr rtlCol="0" anchor="ctr" wrap="none" lIns="50800" rIns="50800" tIns="12700" bIns="12700"/>
+          <a:bodyPr wrap="none" lIns="50800" tIns="12700" rIns="50800" bIns="12700" rtlCol="0" anchor="ctr"/>
           <a:lstStyle/>
           <a:p>
             <a:pPr algn="ctr"/>
@@ -16405,7 +16468,7 @@
           <a:noFill/>
         </p:spPr>
         <p:txBody>
-          <a:bodyPr wrap="square" lIns="0" rIns="0" tIns="0" bIns="0">
+          <a:bodyPr wrap="square" lIns="0" tIns="0" rIns="0" bIns="0">
             <a:spAutoFit/>
           </a:bodyPr>
           <a:lstStyle/>
@@ -16486,6 +16549,7 @@
           <a:lstStyle/>
           <a:p>
             <a:pPr algn="ctr"/>
+            <a:endParaRPr/>
           </a:p>
         </p:txBody>
       </p:sp>
@@ -16580,7 +16644,7 @@
           <a:noFill/>
         </p:spPr>
         <p:txBody>
-          <a:bodyPr wrap="none" lIns="101600" rIns="101600" tIns="76200" bIns="76200">
+          <a:bodyPr wrap="none" lIns="101600" tIns="76200" rIns="101600" bIns="76200">
             <a:spAutoFit/>
           </a:bodyPr>
           <a:lstStyle/>
@@ -16646,7 +16710,7 @@
           </a:fontRef>
         </p:style>
         <p:txBody>
-          <a:bodyPr rtlCol="0" anchor="ctr" wrap="none" lIns="101600" rIns="101600" tIns="76200" bIns="76200"/>
+          <a:bodyPr wrap="none" lIns="101600" tIns="76200" rIns="101600" bIns="76200" rtlCol="0" anchor="ctr"/>
           <a:lstStyle/>
           <a:p>
             <a:pPr algn="ctr"/>
@@ -16684,7 +16748,7 @@
           <a:noFill/>
         </p:spPr>
         <p:txBody>
-          <a:bodyPr wrap="square" lIns="101600" rIns="101600" tIns="76200" bIns="76200">
+          <a:bodyPr wrap="square" lIns="101600" tIns="76200" rIns="101600" bIns="76200">
             <a:spAutoFit/>
           </a:bodyPr>
           <a:lstStyle/>
@@ -16793,12 +16857,12 @@
           </a:fontRef>
         </p:style>
         <p:txBody>
-          <a:bodyPr lIns="101600" rIns="101600" rtlCol="0" anchor="ctr" wrap="square" tIns="76200" bIns="76200"/>
+          <a:bodyPr wrap="square" lIns="101600" tIns="76200" rIns="101600" bIns="76200" rtlCol="0" anchor="ctr"/>
           <a:lstStyle/>
           <a:p>
             <a:pPr algn="l"/>
             <a:r>
-              <a:rPr lang="ru-RU" b="1" sz="1300">
+              <a:rPr lang="ru-RU" sz="1300" b="1">
                 <a:solidFill>
                   <a:srgbClr val="111111"/>
                 </a:solidFill>
@@ -16831,7 +16895,7 @@
           <a:noFill/>
         </p:spPr>
         <p:txBody>
-          <a:bodyPr wrap="square" lIns="101600" rIns="101600" tIns="76200" bIns="76200">
+          <a:bodyPr wrap="square" lIns="101600" tIns="76200" rIns="101600" bIns="76200">
             <a:spAutoFit/>
           </a:bodyPr>
           <a:lstStyle/>
@@ -16987,7 +17051,7 @@
           <a:noFill/>
         </p:spPr>
         <p:txBody>
-          <a:bodyPr wrap="square" lIns="101600" rIns="101600" tIns="76200" bIns="76200">
+          <a:bodyPr wrap="square" lIns="101600" tIns="76200" rIns="101600" bIns="76200">
             <a:spAutoFit/>
           </a:bodyPr>
           <a:lstStyle/>
@@ -17108,7 +17172,7 @@
           </a:fontRef>
         </p:style>
         <p:txBody>
-          <a:bodyPr rtlCol="0" anchor="ctr" wrap="square" lIns="101600" rIns="101600" tIns="76200" bIns="76200"/>
+          <a:bodyPr wrap="square" lIns="101600" tIns="76200" rIns="101600" bIns="76200" rtlCol="0" anchor="ctr"/>
           <a:lstStyle/>
           <a:p>
             <a:pPr algn="ctr"/>
@@ -17171,7 +17235,7 @@
           </a:fontRef>
         </p:style>
         <p:txBody>
-          <a:bodyPr rtlCol="0" anchor="ctr" wrap="square" lIns="101600" rIns="101600" tIns="76200" bIns="76200"/>
+          <a:bodyPr wrap="square" lIns="101600" tIns="76200" rIns="101600" bIns="76200" rtlCol="0" anchor="ctr"/>
           <a:lstStyle/>
           <a:p>
             <a:pPr algn="ctr"/>
@@ -17227,6 +17291,7 @@
           <a:lstStyle/>
           <a:p>
             <a:pPr algn="ctr"/>
+            <a:endParaRPr/>
           </a:p>
         </p:txBody>
       </p:sp>
@@ -17270,6 +17335,7 @@
           <a:lstStyle/>
           <a:p>
             <a:pPr algn="ctr"/>
+            <a:endParaRPr/>
           </a:p>
         </p:txBody>
       </p:sp>
@@ -17309,7 +17375,7 @@
           </a:fontRef>
         </p:style>
         <p:txBody>
-          <a:bodyPr rtlCol="0" anchor="ctr" wrap="none" lIns="50800" rIns="50800" tIns="12700" bIns="12700"/>
+          <a:bodyPr wrap="none" lIns="50800" tIns="12700" rIns="50800" bIns="12700" rtlCol="0" anchor="ctr"/>
           <a:lstStyle/>
           <a:p>
             <a:pPr algn="ctr"/>
@@ -17361,7 +17427,7 @@
           </a:fontRef>
         </p:style>
         <p:txBody>
-          <a:bodyPr rtlCol="0" anchor="ctr" wrap="none" lIns="50800" rIns="50800" tIns="12700" bIns="12700"/>
+          <a:bodyPr wrap="none" lIns="50800" tIns="12700" rIns="50800" bIns="12700" rtlCol="0" anchor="ctr"/>
           <a:lstStyle/>
           <a:p>
             <a:pPr algn="ctr"/>
@@ -17417,6 +17483,7 @@
           <a:lstStyle/>
           <a:p>
             <a:pPr algn="ctr"/>
+            <a:endParaRPr/>
           </a:p>
         </p:txBody>
       </p:sp>
@@ -17456,7 +17523,7 @@
           </a:fontRef>
         </p:style>
         <p:txBody>
-          <a:bodyPr rtlCol="0" anchor="ctr" wrap="none" lIns="50800" rIns="50800" tIns="12700" bIns="12700"/>
+          <a:bodyPr wrap="none" lIns="50800" tIns="12700" rIns="50800" bIns="12700" rtlCol="0" anchor="ctr"/>
           <a:lstStyle/>
           <a:p>
             <a:pPr algn="ctr"/>
@@ -17508,7 +17575,7 @@
           </a:fontRef>
         </p:style>
         <p:txBody>
-          <a:bodyPr rtlCol="0" anchor="ctr" wrap="none" lIns="50800" rIns="50800" tIns="12700" bIns="12700"/>
+          <a:bodyPr wrap="none" lIns="50800" tIns="12700" rIns="50800" bIns="12700" rtlCol="0" anchor="ctr"/>
           <a:lstStyle/>
           <a:p>
             <a:pPr algn="ctr"/>
@@ -17560,7 +17627,7 @@
           </a:fontRef>
         </p:style>
         <p:txBody>
-          <a:bodyPr rtlCol="0" anchor="ctr" wrap="none" lIns="50800" rIns="50800" tIns="12700" bIns="12700"/>
+          <a:bodyPr wrap="none" lIns="50800" tIns="12700" rIns="50800" bIns="12700" rtlCol="0" anchor="ctr"/>
           <a:lstStyle/>
           <a:p>
             <a:pPr algn="ctr"/>
@@ -17593,7 +17660,7 @@
           <a:noFill/>
         </p:spPr>
         <p:txBody>
-          <a:bodyPr wrap="square" lIns="0" rIns="0" tIns="0" bIns="0">
+          <a:bodyPr wrap="square" lIns="0" tIns="0" rIns="0" bIns="0">
             <a:spAutoFit/>
           </a:bodyPr>
           <a:lstStyle/>
@@ -17701,7 +17768,7 @@
           <a:noFill/>
         </p:spPr>
         <p:txBody>
-          <a:bodyPr wrap="none" lIns="101600" rIns="101600" tIns="76200" bIns="76200">
+          <a:bodyPr wrap="none" lIns="101600" tIns="76200" rIns="101600" bIns="76200">
             <a:spAutoFit/>
           </a:bodyPr>
           <a:lstStyle/>
@@ -17767,7 +17834,7 @@
           </a:fontRef>
         </p:style>
         <p:txBody>
-          <a:bodyPr rtlCol="0" anchor="ctr" wrap="none" lIns="101600" rIns="101600" tIns="76200" bIns="76200"/>
+          <a:bodyPr wrap="none" lIns="101600" tIns="76200" rIns="101600" bIns="76200" rtlCol="0" anchor="ctr"/>
           <a:lstStyle/>
           <a:p>
             <a:pPr algn="ctr"/>
@@ -17805,7 +17872,7 @@
           <a:noFill/>
         </p:spPr>
         <p:txBody>
-          <a:bodyPr wrap="square" lIns="101600" rIns="101600" tIns="76200" bIns="76200">
+          <a:bodyPr wrap="square" lIns="101600" tIns="76200" rIns="101600" bIns="76200">
             <a:spAutoFit/>
           </a:bodyPr>
           <a:lstStyle/>
@@ -17914,12 +17981,12 @@
           </a:fontRef>
         </p:style>
         <p:txBody>
-          <a:bodyPr lIns="101600" rIns="101600" rtlCol="0" anchor="ctr" wrap="square" tIns="76200" bIns="76200"/>
+          <a:bodyPr wrap="square" lIns="101600" tIns="76200" rIns="101600" bIns="76200" rtlCol="0" anchor="ctr"/>
           <a:lstStyle/>
           <a:p>
             <a:pPr algn="l"/>
             <a:r>
-              <a:rPr lang="ru-RU" b="1" sz="1300">
+              <a:rPr lang="ru-RU" sz="1300" b="1">
                 <a:solidFill>
                   <a:srgbClr val="111111"/>
                 </a:solidFill>
@@ -17952,7 +18019,7 @@
           <a:noFill/>
         </p:spPr>
         <p:txBody>
-          <a:bodyPr wrap="square" lIns="101600" rIns="101600" tIns="76200" bIns="76200">
+          <a:bodyPr wrap="square" lIns="101600" tIns="76200" rIns="101600" bIns="76200">
             <a:spAutoFit/>
           </a:bodyPr>
           <a:lstStyle/>
@@ -18092,7 +18159,7 @@
           <a:noFill/>
         </p:spPr>
         <p:txBody>
-          <a:bodyPr wrap="square" lIns="101600" rIns="101600" tIns="76200" bIns="76200">
+          <a:bodyPr wrap="square" lIns="101600" tIns="76200" rIns="101600" bIns="76200">
             <a:spAutoFit/>
           </a:bodyPr>
           <a:lstStyle/>
@@ -18201,7 +18268,7 @@
           </a:fontRef>
         </p:style>
         <p:txBody>
-          <a:bodyPr rtlCol="0" anchor="ctr" wrap="square" lIns="101600" rIns="101600" tIns="76200" bIns="76200"/>
+          <a:bodyPr wrap="square" lIns="101600" tIns="76200" rIns="101600" bIns="76200" rtlCol="0" anchor="ctr"/>
           <a:lstStyle/>
           <a:p>
             <a:pPr algn="ctr"/>
@@ -18264,7 +18331,7 @@
           </a:fontRef>
         </p:style>
         <p:txBody>
-          <a:bodyPr rtlCol="0" anchor="ctr" wrap="square" lIns="101600" rIns="101600" tIns="76200" bIns="76200"/>
+          <a:bodyPr wrap="square" lIns="101600" tIns="76200" rIns="101600" bIns="76200" rtlCol="0" anchor="ctr"/>
           <a:lstStyle/>
           <a:p>
             <a:pPr algn="ctr"/>
@@ -18320,6 +18387,7 @@
           <a:lstStyle/>
           <a:p>
             <a:pPr algn="ctr"/>
+            <a:endParaRPr/>
           </a:p>
         </p:txBody>
       </p:sp>
@@ -18363,6 +18431,7 @@
           <a:lstStyle/>
           <a:p>
             <a:pPr algn="ctr"/>
+            <a:endParaRPr/>
           </a:p>
         </p:txBody>
       </p:sp>
@@ -18402,7 +18471,7 @@
           </a:fontRef>
         </p:style>
         <p:txBody>
-          <a:bodyPr rtlCol="0" anchor="ctr" wrap="none" lIns="50800" rIns="50800" tIns="12700" bIns="12700"/>
+          <a:bodyPr wrap="none" lIns="50800" tIns="12700" rIns="50800" bIns="12700" rtlCol="0" anchor="ctr"/>
           <a:lstStyle/>
           <a:p>
             <a:pPr algn="ctr"/>
@@ -18454,7 +18523,7 @@
           </a:fontRef>
         </p:style>
         <p:txBody>
-          <a:bodyPr rtlCol="0" anchor="ctr" wrap="none" lIns="50800" rIns="50800" tIns="12700" bIns="12700"/>
+          <a:bodyPr wrap="none" lIns="50800" tIns="12700" rIns="50800" bIns="12700" rtlCol="0" anchor="ctr"/>
           <a:lstStyle/>
           <a:p>
             <a:pPr algn="ctr"/>
@@ -18510,6 +18579,7 @@
           <a:lstStyle/>
           <a:p>
             <a:pPr algn="ctr"/>
+            <a:endParaRPr/>
           </a:p>
         </p:txBody>
       </p:sp>
@@ -18549,7 +18619,7 @@
           </a:fontRef>
         </p:style>
         <p:txBody>
-          <a:bodyPr rtlCol="0" anchor="ctr" wrap="none" lIns="50800" rIns="50800" tIns="12700" bIns="12700"/>
+          <a:bodyPr wrap="none" lIns="50800" tIns="12700" rIns="50800" bIns="12700" rtlCol="0" anchor="ctr"/>
           <a:lstStyle/>
           <a:p>
             <a:pPr algn="ctr"/>
@@ -18601,7 +18671,7 @@
           </a:fontRef>
         </p:style>
         <p:txBody>
-          <a:bodyPr rtlCol="0" anchor="ctr" wrap="none" lIns="50800" rIns="50800" tIns="12700" bIns="12700"/>
+          <a:bodyPr wrap="none" lIns="50800" tIns="12700" rIns="50800" bIns="12700" rtlCol="0" anchor="ctr"/>
           <a:lstStyle/>
           <a:p>
             <a:pPr algn="ctr"/>
@@ -18653,7 +18723,7 @@
           </a:fontRef>
         </p:style>
         <p:txBody>
-          <a:bodyPr rtlCol="0" anchor="ctr" wrap="none" lIns="50800" rIns="50800" tIns="12700" bIns="12700"/>
+          <a:bodyPr wrap="none" lIns="50800" tIns="12700" rIns="50800" bIns="12700" rtlCol="0" anchor="ctr"/>
           <a:lstStyle/>
           <a:p>
             <a:pPr algn="ctr"/>
@@ -18686,7 +18756,7 @@
           <a:noFill/>
         </p:spPr>
         <p:txBody>
-          <a:bodyPr wrap="square" lIns="0" rIns="0" tIns="0" bIns="0">
+          <a:bodyPr wrap="square" lIns="0" tIns="0" rIns="0" bIns="0">
             <a:spAutoFit/>
           </a:bodyPr>
           <a:lstStyle/>
@@ -18794,7 +18864,7 @@
           <a:noFill/>
         </p:spPr>
         <p:txBody>
-          <a:bodyPr wrap="none" lIns="101600" rIns="101600" tIns="76200" bIns="76200">
+          <a:bodyPr wrap="none" lIns="101600" tIns="76200" rIns="101600" bIns="76200">
             <a:spAutoFit/>
           </a:bodyPr>
           <a:lstStyle/>
@@ -18860,7 +18930,7 @@
           </a:fontRef>
         </p:style>
         <p:txBody>
-          <a:bodyPr rtlCol="0" anchor="ctr" wrap="none" lIns="101600" rIns="101600" tIns="76200" bIns="76200"/>
+          <a:bodyPr wrap="none" lIns="101600" tIns="76200" rIns="101600" bIns="76200" rtlCol="0" anchor="ctr"/>
           <a:lstStyle/>
           <a:p>
             <a:pPr algn="ctr"/>
@@ -18898,7 +18968,7 @@
           <a:noFill/>
         </p:spPr>
         <p:txBody>
-          <a:bodyPr wrap="square" lIns="101600" rIns="101600" tIns="76200" bIns="76200">
+          <a:bodyPr wrap="square" lIns="101600" tIns="76200" rIns="101600" bIns="76200">
             <a:spAutoFit/>
           </a:bodyPr>
           <a:lstStyle/>
@@ -19007,12 +19077,12 @@
           </a:fontRef>
         </p:style>
         <p:txBody>
-          <a:bodyPr lIns="101600" rIns="101600" rtlCol="0" anchor="ctr" wrap="square" tIns="76200" bIns="76200"/>
+          <a:bodyPr wrap="square" lIns="101600" tIns="76200" rIns="101600" bIns="76200" rtlCol="0" anchor="ctr"/>
           <a:lstStyle/>
           <a:p>
             <a:pPr algn="l"/>
             <a:r>
-              <a:rPr lang="ru-RU" b="1" sz="1300">
+              <a:rPr lang="ru-RU" sz="1300" b="1">
                 <a:solidFill>
                   <a:srgbClr val="111111"/>
                 </a:solidFill>
@@ -19045,7 +19115,7 @@
           <a:noFill/>
         </p:spPr>
         <p:txBody>
-          <a:bodyPr wrap="square" lIns="101600" rIns="101600" tIns="76200" bIns="76200">
+          <a:bodyPr wrap="square" lIns="101600" tIns="76200" rIns="101600" bIns="76200">
             <a:spAutoFit/>
           </a:bodyPr>
           <a:lstStyle/>
@@ -19201,7 +19271,7 @@
           <a:noFill/>
         </p:spPr>
         <p:txBody>
-          <a:bodyPr wrap="square" lIns="101600" rIns="101600" tIns="76200" bIns="76200">
+          <a:bodyPr wrap="square" lIns="101600" tIns="76200" rIns="101600" bIns="76200">
             <a:spAutoFit/>
           </a:bodyPr>
           <a:lstStyle/>
@@ -19310,7 +19380,7 @@
           </a:fontRef>
         </p:style>
         <p:txBody>
-          <a:bodyPr rtlCol="0" anchor="ctr" wrap="square" lIns="101600" rIns="101600" tIns="76200" bIns="76200"/>
+          <a:bodyPr wrap="square" lIns="101600" tIns="76200" rIns="101600" bIns="76200" rtlCol="0" anchor="ctr"/>
           <a:lstStyle/>
           <a:p>
             <a:pPr algn="ctr"/>
@@ -19373,7 +19443,7 @@
           </a:fontRef>
         </p:style>
         <p:txBody>
-          <a:bodyPr rtlCol="0" anchor="ctr" wrap="square" lIns="101600" rIns="101600" tIns="76200" bIns="76200"/>
+          <a:bodyPr wrap="square" lIns="101600" tIns="76200" rIns="101600" bIns="76200" rtlCol="0" anchor="ctr"/>
           <a:lstStyle/>
           <a:p>
             <a:pPr algn="ctr"/>
@@ -19429,6 +19499,7 @@
           <a:lstStyle/>
           <a:p>
             <a:pPr algn="ctr"/>
+            <a:endParaRPr/>
           </a:p>
         </p:txBody>
       </p:sp>
@@ -19472,6 +19543,7 @@
           <a:lstStyle/>
           <a:p>
             <a:pPr algn="ctr"/>
+            <a:endParaRPr/>
           </a:p>
         </p:txBody>
       </p:sp>
@@ -19511,7 +19583,7 @@
           </a:fontRef>
         </p:style>
         <p:txBody>
-          <a:bodyPr rtlCol="0" anchor="ctr" wrap="none" lIns="50800" rIns="50800" tIns="12700" bIns="12700"/>
+          <a:bodyPr wrap="none" lIns="50800" tIns="12700" rIns="50800" bIns="12700" rtlCol="0" anchor="ctr"/>
           <a:lstStyle/>
           <a:p>
             <a:pPr algn="ctr"/>
@@ -19563,7 +19635,7 @@
           </a:fontRef>
         </p:style>
         <p:txBody>
-          <a:bodyPr rtlCol="0" anchor="ctr" wrap="none" lIns="50800" rIns="50800" tIns="12700" bIns="12700"/>
+          <a:bodyPr wrap="none" lIns="50800" tIns="12700" rIns="50800" bIns="12700" rtlCol="0" anchor="ctr"/>
           <a:lstStyle/>
           <a:p>
             <a:pPr algn="ctr"/>
@@ -19619,6 +19691,7 @@
           <a:lstStyle/>
           <a:p>
             <a:pPr algn="ctr"/>
+            <a:endParaRPr/>
           </a:p>
         </p:txBody>
       </p:sp>
@@ -19658,7 +19731,7 @@
           </a:fontRef>
         </p:style>
         <p:txBody>
-          <a:bodyPr rtlCol="0" anchor="ctr" wrap="none" lIns="50800" rIns="50800" tIns="12700" bIns="12700"/>
+          <a:bodyPr wrap="none" lIns="50800" tIns="12700" rIns="50800" bIns="12700" rtlCol="0" anchor="ctr"/>
           <a:lstStyle/>
           <a:p>
             <a:pPr algn="ctr"/>
@@ -19710,7 +19783,7 @@
           </a:fontRef>
         </p:style>
         <p:txBody>
-          <a:bodyPr rtlCol="0" anchor="ctr" wrap="none" lIns="50800" rIns="50800" tIns="12700" bIns="12700"/>
+          <a:bodyPr wrap="none" lIns="50800" tIns="12700" rIns="50800" bIns="12700" rtlCol="0" anchor="ctr"/>
           <a:lstStyle/>
           <a:p>
             <a:pPr algn="ctr"/>
@@ -19762,7 +19835,7 @@
           </a:fontRef>
         </p:style>
         <p:txBody>
-          <a:bodyPr rtlCol="0" anchor="ctr" wrap="none" lIns="50800" rIns="50800" tIns="12700" bIns="12700"/>
+          <a:bodyPr wrap="none" lIns="50800" tIns="12700" rIns="50800" bIns="12700" rtlCol="0" anchor="ctr"/>
           <a:lstStyle/>
           <a:p>
             <a:pPr algn="ctr"/>
@@ -19795,7 +19868,7 @@
           <a:noFill/>
         </p:spPr>
         <p:txBody>
-          <a:bodyPr wrap="square" lIns="0" rIns="0" tIns="0" bIns="0">
+          <a:bodyPr wrap="square" lIns="0" tIns="0" rIns="0" bIns="0">
             <a:spAutoFit/>
           </a:bodyPr>
           <a:lstStyle/>
@@ -19903,7 +19976,7 @@
           <a:noFill/>
         </p:spPr>
         <p:txBody>
-          <a:bodyPr wrap="none" lIns="101600" rIns="101600" tIns="76200" bIns="76200">
+          <a:bodyPr wrap="none" lIns="101600" tIns="76200" rIns="101600" bIns="76200">
             <a:spAutoFit/>
           </a:bodyPr>
           <a:lstStyle/>
@@ -19969,7 +20042,7 @@
           </a:fontRef>
         </p:style>
         <p:txBody>
-          <a:bodyPr rtlCol="0" anchor="ctr" wrap="none" lIns="101600" rIns="101600" tIns="76200" bIns="76200"/>
+          <a:bodyPr wrap="none" lIns="101600" tIns="76200" rIns="101600" bIns="76200" rtlCol="0" anchor="ctr"/>
           <a:lstStyle/>
           <a:p>
             <a:pPr algn="ctr"/>
@@ -20007,7 +20080,7 @@
           <a:noFill/>
         </p:spPr>
         <p:txBody>
-          <a:bodyPr wrap="square" lIns="101600" rIns="101600" tIns="76200" bIns="76200">
+          <a:bodyPr wrap="square" lIns="101600" tIns="76200" rIns="101600" bIns="76200">
             <a:spAutoFit/>
           </a:bodyPr>
           <a:lstStyle/>
@@ -20032,7 +20105,9 @@
       </p:sp>
       <p:sp>
         <p:nvSpPr>
-          <p:cNvPr id="6" name="Rounded Rectangle 5"/>
+          <p:cNvPr id="6" name="Rounded Rectangle 5">
+            <a:hlinkClick r:id="" action="ppaction://noaction"/>
+          </p:cNvPr>
           <p:cNvSpPr/>
           <p:nvPr/>
         </p:nvSpPr>
@@ -20080,7 +20155,9 @@
       </p:sp>
       <p:sp>
         <p:nvSpPr>
-          <p:cNvPr id="7" name="Rounded Rectangle 6"/>
+          <p:cNvPr id="7" name="Rounded Rectangle 6">
+            <a:hlinkClick r:id="" action="ppaction://noaction"/>
+          </p:cNvPr>
           <p:cNvSpPr/>
           <p:nvPr/>
         </p:nvSpPr>
@@ -20116,12 +20193,12 @@
           </a:fontRef>
         </p:style>
         <p:txBody>
-          <a:bodyPr lIns="101600" rIns="101600" rtlCol="0" anchor="ctr" wrap="square" tIns="76200" bIns="76200"/>
+          <a:bodyPr wrap="square" lIns="101600" tIns="76200" rIns="101600" bIns="76200" rtlCol="0" anchor="ctr"/>
           <a:lstStyle/>
           <a:p>
             <a:pPr algn="l"/>
             <a:r>
-              <a:rPr lang="ru-RU" b="1" sz="1300">
+              <a:rPr lang="ru-RU" sz="1300" b="1">
                 <a:solidFill>
                   <a:srgbClr val="111111"/>
                 </a:solidFill>
@@ -20139,14 +20216,16 @@
       </p:sp>
       <p:sp>
         <p:nvSpPr>
-          <p:cNvPr id="8" name="TextBox 7"/>
+          <p:cNvPr id="8" name="TextBox 7">
+            <a:hlinkClick r:id="" action="ppaction://noaction"/>
+          </p:cNvPr>
           <p:cNvSpPr txBox="1"/>
           <p:nvPr/>
         </p:nvSpPr>
         <p:spPr>
           <a:xfrm>
             <a:off x="896112" y="2596896"/>
-            <a:ext cx="3685032" cy="2761488"/>
+            <a:ext cx="3685032" cy="1795363"/>
           </a:xfrm>
           <a:prstGeom prst="rect">
             <a:avLst/>
@@ -20154,7 +20233,7 @@
           <a:noFill/>
         </p:spPr>
         <p:txBody>
-          <a:bodyPr wrap="square" lIns="101600" rIns="101600" tIns="76200" bIns="76200">
+          <a:bodyPr wrap="square" lIns="101600" tIns="76200" rIns="101600" bIns="76200">
             <a:spAutoFit/>
           </a:bodyPr>
           <a:lstStyle/>
@@ -20165,7 +20244,7 @@
               </a:spcAft>
             </a:pPr>
             <a:r>
-              <a:rPr lang="ru-RU" sz="1600" b="0">
+              <a:rPr lang="ru-RU" sz="1600" b="0" dirty="0">
                 <a:solidFill>
                   <a:srgbClr val="111111"/>
                 </a:solidFill>
@@ -20181,7 +20260,7 @@
               </a:spcAft>
             </a:pPr>
             <a:r>
-              <a:rPr lang="ru-RU" sz="1600" b="0">
+              <a:rPr lang="ru-RU" sz="1600" b="0" dirty="0">
                 <a:solidFill>
                   <a:srgbClr val="111111"/>
                 </a:solidFill>
@@ -20197,7 +20276,7 @@
               </a:spcAft>
             </a:pPr>
             <a:r>
-              <a:rPr lang="ru-RU" sz="1600" b="0">
+              <a:rPr lang="ru-RU" sz="1600" b="0" dirty="0">
                 <a:solidFill>
                   <a:srgbClr val="111111"/>
                 </a:solidFill>
@@ -20213,7 +20292,7 @@
               </a:spcAft>
             </a:pPr>
             <a:r>
-              <a:rPr lang="ru-RU" sz="1600" b="0">
+              <a:rPr lang="ru-RU" sz="1600" b="0" dirty="0">
                 <a:solidFill>
                   <a:srgbClr val="111111"/>
                 </a:solidFill>
@@ -20235,7 +20314,16 @@
                 </a:solidFill>
                 <a:latin typeface="Arial"/>
               </a:rPr>
-              <a:t>Осмотри оснастку</a:t>
+              <a:t>Осмотри </a:t>
+            </a:r>
+            <a:r>
+              <a:rPr lang="ru-RU" sz="1600">
+                <a:solidFill>
+                  <a:srgbClr val="111111"/>
+                </a:solidFill>
+                <a:latin typeface="Arial"/>
+              </a:rPr>
+              <a:t>приспособления и тару</a:t>
             </a:r>
             <a:endParaRPr dirty="0">
               <a:solidFill>
@@ -20253,7 +20341,7 @@
         </p:nvSpPr>
         <p:spPr>
           <a:xfrm>
-            <a:off x="4983480" y="1828800"/>
+            <a:off x="5001768" y="1865376"/>
             <a:ext cx="6181344" cy="3913632"/>
           </a:xfrm>
           <a:prstGeom prst="roundRect">
@@ -20289,35 +20377,7 @@
           <a:lstStyle/>
           <a:p>
             <a:pPr algn="ctr"/>
-            <a:endParaRPr/>
-          </a:p>
-        </p:txBody>
-      </p:sp>
-      <p:sp>
-        <p:nvSpPr>
-          <p:cNvPr id="10" name="TextBox 9"/>
-          <p:cNvSpPr txBox="1"/>
-          <p:nvPr/>
-        </p:nvSpPr>
-        <p:spPr>
-          <a:xfrm>
-            <a:off x="5166360" y="5376672"/>
-            <a:ext cx="5815584" cy="219456"/>
-          </a:xfrm>
-          <a:prstGeom prst="rect">
-            <a:avLst/>
-          </a:prstGeom>
-          <a:noFill/>
-        </p:spPr>
-        <p:txBody>
-          <a:bodyPr wrap="square" lIns="101600" rIns="101600" tIns="76200" bIns="76200">
-            <a:spAutoFit/>
-          </a:bodyPr>
-          <a:lstStyle/>
-          <a:p>
-            <a:r>
-              <a:t>Памятка по подготовке до начала работ</a:t>
-            </a:r>
+            <a:endParaRPr dirty="0"/>
           </a:p>
         </p:txBody>
       </p:sp>
@@ -20359,7 +20419,7 @@
           </a:fontRef>
         </p:style>
         <p:txBody>
-          <a:bodyPr rtlCol="0" anchor="ctr" wrap="square" lIns="101600" rIns="101600" tIns="76200" bIns="76200"/>
+          <a:bodyPr wrap="square" lIns="101600" tIns="76200" rIns="101600" bIns="76200" rtlCol="0" anchor="ctr"/>
           <a:lstStyle/>
           <a:p>
             <a:pPr algn="ctr"/>
@@ -20422,7 +20482,7 @@
           </a:fontRef>
         </p:style>
         <p:txBody>
-          <a:bodyPr rtlCol="0" anchor="ctr" wrap="square" lIns="101600" rIns="101600" tIns="76200" bIns="76200"/>
+          <a:bodyPr wrap="square" lIns="101600" tIns="76200" rIns="101600" bIns="76200" rtlCol="0" anchor="ctr"/>
           <a:lstStyle/>
           <a:p>
             <a:pPr algn="ctr"/>
@@ -20478,6 +20538,7 @@
           <a:lstStyle/>
           <a:p>
             <a:pPr algn="ctr"/>
+            <a:endParaRPr/>
           </a:p>
         </p:txBody>
       </p:sp>
@@ -20521,6 +20582,7 @@
           <a:lstStyle/>
           <a:p>
             <a:pPr algn="ctr"/>
+            <a:endParaRPr/>
           </a:p>
         </p:txBody>
       </p:sp>
@@ -20560,7 +20622,7 @@
           </a:fontRef>
         </p:style>
         <p:txBody>
-          <a:bodyPr rtlCol="0" anchor="ctr" wrap="none" lIns="50800" rIns="50800" tIns="12700" bIns="12700"/>
+          <a:bodyPr wrap="none" lIns="50800" tIns="12700" rIns="50800" bIns="12700" rtlCol="0" anchor="ctr"/>
           <a:lstStyle/>
           <a:p>
             <a:pPr algn="ctr"/>
@@ -20612,7 +20674,7 @@
           </a:fontRef>
         </p:style>
         <p:txBody>
-          <a:bodyPr rtlCol="0" anchor="ctr" wrap="none" lIns="50800" rIns="50800" tIns="12700" bIns="12700"/>
+          <a:bodyPr wrap="none" lIns="50800" tIns="12700" rIns="50800" bIns="12700" rtlCol="0" anchor="ctr"/>
           <a:lstStyle/>
           <a:p>
             <a:pPr algn="ctr"/>
@@ -20668,6 +20730,7 @@
           <a:lstStyle/>
           <a:p>
             <a:pPr algn="ctr"/>
+            <a:endParaRPr/>
           </a:p>
         </p:txBody>
       </p:sp>
@@ -20707,7 +20770,7 @@
           </a:fontRef>
         </p:style>
         <p:txBody>
-          <a:bodyPr rtlCol="0" anchor="ctr" wrap="none" lIns="50800" rIns="50800" tIns="12700" bIns="12700"/>
+          <a:bodyPr wrap="none" lIns="50800" tIns="12700" rIns="50800" bIns="12700" rtlCol="0" anchor="ctr"/>
           <a:lstStyle/>
           <a:p>
             <a:pPr algn="ctr"/>
@@ -20759,7 +20822,7 @@
           </a:fontRef>
         </p:style>
         <p:txBody>
-          <a:bodyPr rtlCol="0" anchor="ctr" wrap="none" lIns="50800" rIns="50800" tIns="12700" bIns="12700"/>
+          <a:bodyPr wrap="none" lIns="50800" tIns="12700" rIns="50800" bIns="12700" rtlCol="0" anchor="ctr"/>
           <a:lstStyle/>
           <a:p>
             <a:pPr algn="ctr"/>
@@ -20811,7 +20874,7 @@
           </a:fontRef>
         </p:style>
         <p:txBody>
-          <a:bodyPr rtlCol="0" anchor="ctr" wrap="none" lIns="50800" rIns="50800" tIns="12700" bIns="12700"/>
+          <a:bodyPr wrap="none" lIns="50800" tIns="12700" rIns="50800" bIns="12700" rtlCol="0" anchor="ctr"/>
           <a:lstStyle/>
           <a:p>
             <a:pPr algn="ctr"/>
@@ -20844,47 +20907,47 @@
           <a:noFill/>
         </p:spPr>
         <p:txBody>
-          <a:bodyPr wrap="square" lIns="0" rIns="0" tIns="0" bIns="0">
+          <a:bodyPr wrap="square" lIns="0" tIns="0" rIns="0" bIns="0">
             <a:spAutoFit/>
           </a:bodyPr>
           <a:lstStyle/>
           <a:p>
             <a:r>
-              <a:rPr sz="1300" b="1">
+              <a:rPr sz="1300" b="1" dirty="0" err="1">
                 <a:solidFill>
                   <a:srgbClr val="111111"/>
                 </a:solidFill>
                 <a:latin typeface="Arial"/>
               </a:rPr>
-              <a:t>Памятка и схема</a:t>
-            </a:r>
-          </a:p>
-        </p:txBody>
-      </p:sp>
-      <p:pic>
-        <p:nvPicPr>
-          <p:cNvPr id="22" name="Picture 21" descr="S031-P01_podgotovka-k-rabote_checklist.png"/>
-          <p:cNvPicPr>
-            <a:picLocks noChangeAspect="1"/>
-          </p:cNvPicPr>
-          <p:nvPr/>
-        </p:nvPicPr>
-        <p:blipFill>
-          <a:blip r:embed="rId2"/>
-          <a:stretch>
-            <a:fillRect/>
-          </a:stretch>
-        </p:blipFill>
-        <p:spPr>
-          <a:xfrm>
-            <a:off x="5700776" y="2633472"/>
-            <a:ext cx="4746752" cy="2670048"/>
-          </a:xfrm>
-          <a:prstGeom prst="rect">
-            <a:avLst/>
-          </a:prstGeom>
-        </p:spPr>
-      </p:pic>
+              <a:t>Памятка</a:t>
+            </a:r>
+            <a:r>
+              <a:rPr sz="1300" b="1" dirty="0">
+                <a:solidFill>
+                  <a:srgbClr val="111111"/>
+                </a:solidFill>
+                <a:latin typeface="Arial"/>
+              </a:rPr>
+              <a:t> и </a:t>
+            </a:r>
+            <a:r>
+              <a:rPr sz="1300" b="1" dirty="0" err="1">
+                <a:solidFill>
+                  <a:srgbClr val="111111"/>
+                </a:solidFill>
+                <a:latin typeface="Arial"/>
+              </a:rPr>
+              <a:t>схема</a:t>
+            </a:r>
+            <a:endParaRPr sz="1300" b="1" dirty="0">
+              <a:solidFill>
+                <a:srgbClr val="111111"/>
+              </a:solidFill>
+              <a:latin typeface="Arial"/>
+            </a:endParaRPr>
+          </a:p>
+        </p:txBody>
+      </p:sp>
       <p:sp>
         <p:nvSpPr>
           <p:cNvPr id="23" name="Rectangle 22"/>
@@ -20925,6 +20988,55 @@
           <a:lstStyle/>
           <a:p>
             <a:pPr algn="ctr"/>
+            <a:endParaRPr/>
+          </a:p>
+        </p:txBody>
+      </p:sp>
+      <p:sp>
+        <p:nvSpPr>
+          <p:cNvPr id="24" name="TextBox 23">
+            <a:extLst>
+              <a:ext uri="{FF2B5EF4-FFF2-40B4-BE49-F238E27FC236}">
+                <a16:creationId xmlns:a16="http://schemas.microsoft.com/office/drawing/2014/main" id="{901A88E7-B59F-1E2B-3492-3A579B025CBC}"/>
+              </a:ext>
+            </a:extLst>
+          </p:cNvPr>
+          <p:cNvSpPr txBox="1"/>
+          <p:nvPr/>
+        </p:nvSpPr>
+        <p:spPr>
+          <a:xfrm>
+            <a:off x="6095847" y="3314700"/>
+            <a:ext cx="4069080" cy="923330"/>
+          </a:xfrm>
+          <a:prstGeom prst="rect">
+            <a:avLst/>
+          </a:prstGeom>
+          <a:noFill/>
+        </p:spPr>
+        <p:txBody>
+          <a:bodyPr wrap="square" rtlCol="0">
+            <a:spAutoFit/>
+          </a:bodyPr>
+          <a:lstStyle/>
+          <a:p>
+            <a:r>
+              <a:rPr lang="ru-RU" dirty="0"/>
+              <a:t>Вставляем </a:t>
+            </a:r>
+            <a:r>
+              <a:rPr lang="ru-RU" dirty="0" err="1"/>
+              <a:t>слайдшоу</a:t>
+            </a:r>
+            <a:r>
+              <a:rPr lang="ru-RU" dirty="0"/>
+              <a:t> с озвучкой. Последовательность так как указано по пунктам в подвале </a:t>
+            </a:r>
+            <a:r>
+              <a:rPr lang="en-US" dirty="0"/>
+              <a:t>S031-P01</a:t>
+            </a:r>
+            <a:endParaRPr lang="ru-RU" dirty="0"/>
           </a:p>
         </p:txBody>
       </p:sp>
@@ -21019,7 +21131,7 @@
           <a:noFill/>
         </p:spPr>
         <p:txBody>
-          <a:bodyPr wrap="none" lIns="101600" rIns="101600" tIns="76200" bIns="76200">
+          <a:bodyPr wrap="none" lIns="101600" tIns="76200" rIns="101600" bIns="76200">
             <a:spAutoFit/>
           </a:bodyPr>
           <a:lstStyle/>
@@ -21085,7 +21197,7 @@
           </a:fontRef>
         </p:style>
         <p:txBody>
-          <a:bodyPr rtlCol="0" anchor="ctr" wrap="none" lIns="101600" rIns="101600" tIns="76200" bIns="76200"/>
+          <a:bodyPr wrap="none" lIns="101600" tIns="76200" rIns="101600" bIns="76200" rtlCol="0" anchor="ctr"/>
           <a:lstStyle/>
           <a:p>
             <a:pPr algn="ctr"/>
@@ -21123,7 +21235,7 @@
           <a:noFill/>
         </p:spPr>
         <p:txBody>
-          <a:bodyPr wrap="square" lIns="101600" rIns="101600" tIns="76200" bIns="76200">
+          <a:bodyPr wrap="square" lIns="101600" tIns="76200" rIns="101600" bIns="76200">
             <a:spAutoFit/>
           </a:bodyPr>
           <a:lstStyle/>
@@ -21154,8 +21266,8 @@
         </p:nvSpPr>
         <p:spPr>
           <a:xfrm>
-            <a:off x="676656" y="1828800"/>
-            <a:ext cx="4069080" cy="3913632"/>
+            <a:off x="676910" y="1828800"/>
+            <a:ext cx="10487660" cy="3914140"/>
           </a:xfrm>
           <a:prstGeom prst="roundRect">
             <a:avLst>
@@ -21165,7 +21277,7 @@
           <a:solidFill>
             <a:srgbClr val="FFFFFF"/>
           </a:solidFill>
-          <a:ln w="15875">
+          <a:ln w="14605">
             <a:solidFill>
               <a:srgbClr val="E5E7EB"/>
             </a:solidFill>
@@ -21191,309 +21303,6 @@
           <a:p>
             <a:pPr algn="ctr"/>
             <a:endParaRPr/>
-          </a:p>
-        </p:txBody>
-      </p:sp>
-      <p:sp>
-        <p:nvSpPr>
-          <p:cNvPr id="7" name="Rounded Rectangle 6"/>
-          <p:cNvSpPr/>
-          <p:nvPr/>
-        </p:nvSpPr>
-        <p:spPr>
-          <a:xfrm>
-            <a:off x="676656" y="2066543"/>
-            <a:ext cx="4069080" cy="365760"/>
-          </a:xfrm>
-          <a:prstGeom prst="roundRect">
-            <a:avLst>
-              <a:gd name="adj" fmla="val 19300"/>
-            </a:avLst>
-          </a:prstGeom>
-          <a:solidFill>
-            <a:srgbClr val="FFFFFF"/>
-          </a:solidFill>
-          <a:ln>
-            <a:noFill/>
-          </a:ln>
-        </p:spPr>
-        <p:style>
-          <a:lnRef idx="1">
-            <a:schemeClr val="accent1"/>
-          </a:lnRef>
-          <a:fillRef idx="3">
-            <a:schemeClr val="accent1"/>
-          </a:fillRef>
-          <a:effectRef idx="2">
-            <a:schemeClr val="accent1"/>
-          </a:effectRef>
-          <a:fontRef idx="minor">
-            <a:schemeClr val="lt1"/>
-          </a:fontRef>
-        </p:style>
-        <p:txBody>
-          <a:bodyPr lIns="101600" rIns="101600" rtlCol="0" anchor="ctr" wrap="square" tIns="76200" bIns="76200"/>
-          <a:lstStyle/>
-          <a:p>
-            <a:pPr algn="l"/>
-            <a:r>
-              <a:rPr lang="ru-RU" b="1" sz="1300">
-                <a:solidFill>
-                  <a:srgbClr val="111111"/>
-                </a:solidFill>
-                <a:latin typeface="Arial"/>
-              </a:rPr>
-              <a:t>Памятка перед началом работы</a:t>
-            </a:r>
-            <a:endParaRPr b="1">
-              <a:solidFill>
-                <a:srgbClr val="FFFFFF"/>
-              </a:solidFill>
-            </a:endParaRPr>
-          </a:p>
-        </p:txBody>
-      </p:sp>
-      <p:sp>
-        <p:nvSpPr>
-          <p:cNvPr id="8" name="TextBox 7"/>
-          <p:cNvSpPr txBox="1"/>
-          <p:nvPr/>
-        </p:nvSpPr>
-        <p:spPr>
-          <a:xfrm>
-            <a:off x="896112" y="2596896"/>
-            <a:ext cx="3685032" cy="2761488"/>
-          </a:xfrm>
-          <a:prstGeom prst="rect">
-            <a:avLst/>
-          </a:prstGeom>
-          <a:noFill/>
-        </p:spPr>
-        <p:txBody>
-          <a:bodyPr wrap="square" lIns="101600" rIns="101600" tIns="76200" bIns="76200">
-            <a:spAutoFit/>
-          </a:bodyPr>
-          <a:lstStyle/>
-          <a:p>
-            <a:pPr algn="l">
-              <a:spcAft>
-                <a:spcPts val="800"/>
-              </a:spcAft>
-            </a:pPr>
-            <a:r>
-              <a:rPr lang="ru-RU" sz="1200" b="0">
-                <a:solidFill>
-                  <a:srgbClr val="111111"/>
-                </a:solidFill>
-                <a:latin typeface="Arial"/>
-              </a:rPr>
-              <a:t>1. Понятно задание</a:t>
-            </a:r>
-          </a:p>
-          <a:p>
-            <a:pPr algn="l">
-              <a:spcAft>
-                <a:spcPts val="800"/>
-              </a:spcAft>
-            </a:pPr>
-            <a:r>
-              <a:rPr lang="ru-RU" sz="1200" b="0">
-                <a:solidFill>
-                  <a:srgbClr val="111111"/>
-                </a:solidFill>
-                <a:latin typeface="Arial"/>
-              </a:rPr>
-              <a:t>- что поднимать</a:t>
-            </a:r>
-          </a:p>
-          <a:p>
-            <a:pPr algn="l">
-              <a:spcAft>
-                <a:spcPts val="800"/>
-              </a:spcAft>
-            </a:pPr>
-            <a:r>
-              <a:rPr lang="ru-RU" sz="1200" b="0">
-                <a:solidFill>
-                  <a:srgbClr val="111111"/>
-                </a:solidFill>
-                <a:latin typeface="Arial"/>
-              </a:rPr>
-              <a:t>- откуда и куда</a:t>
-            </a:r>
-          </a:p>
-          <a:p>
-            <a:pPr algn="l">
-              <a:spcAft>
-                <a:spcPts val="800"/>
-              </a:spcAft>
-            </a:pPr>
-            <a:r>
-              <a:rPr lang="ru-RU" sz="1200" b="0">
-                <a:solidFill>
-                  <a:srgbClr val="111111"/>
-                </a:solidFill>
-                <a:latin typeface="Arial"/>
-              </a:rPr>
-              <a:t>- в каких условиях</a:t>
-            </a:r>
-          </a:p>
-          <a:p>
-            <a:pPr algn="l">
-              <a:spcAft>
-                <a:spcPts val="800"/>
-              </a:spcAft>
-            </a:pPr>
-            <a:endParaRPr lang="ru-RU">
-              <a:solidFill>
-                <a:srgbClr val="212B36"/>
-              </a:solidFill>
-            </a:endParaRPr>
-          </a:p>
-          <a:p>
-            <a:pPr algn="l">
-              <a:spcAft>
-                <a:spcPts val="800"/>
-              </a:spcAft>
-            </a:pPr>
-            <a:r>
-              <a:rPr lang="ru-RU" sz="1200" b="0">
-                <a:solidFill>
-                  <a:srgbClr val="111111"/>
-                </a:solidFill>
-                <a:latin typeface="Arial"/>
-              </a:rPr>
-              <a:t>2. Понятен груз</a:t>
-            </a:r>
-          </a:p>
-          <a:p>
-            <a:pPr algn="l">
-              <a:spcAft>
-                <a:spcPts val="800"/>
-              </a:spcAft>
-            </a:pPr>
-            <a:r>
-              <a:rPr lang="ru-RU" sz="1200" b="0">
-                <a:solidFill>
-                  <a:srgbClr val="111111"/>
-                </a:solidFill>
-                <a:latin typeface="Arial"/>
-              </a:rPr>
-              <a:t>- масса</a:t>
-            </a:r>
-          </a:p>
-          <a:p>
-            <a:pPr algn="l">
-              <a:spcAft>
-                <a:spcPts val="800"/>
-              </a:spcAft>
-            </a:pPr>
-            <a:r>
-              <a:rPr lang="ru-RU" sz="1200" b="0">
-                <a:solidFill>
-                  <a:srgbClr val="111111"/>
-                </a:solidFill>
-                <a:latin typeface="Arial"/>
-              </a:rPr>
-              <a:t>- характер груза</a:t>
-            </a:r>
-          </a:p>
-          <a:p>
-            <a:pPr algn="l">
-              <a:spcAft>
-                <a:spcPts val="800"/>
-              </a:spcAft>
-            </a:pPr>
-            <a:r>
-              <a:rPr lang="ru-RU" sz="1200" b="0">
-                <a:solidFill>
-                  <a:srgbClr val="111111"/>
-                </a:solidFill>
-                <a:latin typeface="Arial"/>
-              </a:rPr>
-              <a:t>- устойчивость</a:t>
-            </a:r>
-            <a:endParaRPr dirty="0">
-              <a:solidFill>
-                <a:srgbClr val="212B36"/>
-              </a:solidFill>
-            </a:endParaRPr>
-          </a:p>
-        </p:txBody>
-      </p:sp>
-      <p:sp>
-        <p:nvSpPr>
-          <p:cNvPr id="9" name="Rounded Rectangle 8"/>
-          <p:cNvSpPr/>
-          <p:nvPr/>
-        </p:nvSpPr>
-        <p:spPr>
-          <a:xfrm>
-            <a:off x="4983480" y="1828800"/>
-            <a:ext cx="6181344" cy="3913632"/>
-          </a:xfrm>
-          <a:prstGeom prst="roundRect">
-            <a:avLst>
-              <a:gd name="adj" fmla="val 3050"/>
-            </a:avLst>
-          </a:prstGeom>
-          <a:solidFill>
-            <a:srgbClr val="FFFFFF"/>
-          </a:solidFill>
-          <a:ln w="15875">
-            <a:solidFill>
-              <a:srgbClr val="E5E7EB"/>
-            </a:solidFill>
-          </a:ln>
-        </p:spPr>
-        <p:style>
-          <a:lnRef idx="1">
-            <a:schemeClr val="accent1"/>
-          </a:lnRef>
-          <a:fillRef idx="3">
-            <a:schemeClr val="accent1"/>
-          </a:fillRef>
-          <a:effectRef idx="2">
-            <a:schemeClr val="accent1"/>
-          </a:effectRef>
-          <a:fontRef idx="minor">
-            <a:schemeClr val="lt1"/>
-          </a:fontRef>
-        </p:style>
-        <p:txBody>
-          <a:bodyPr rtlCol="0" anchor="ctr"/>
-          <a:lstStyle/>
-          <a:p>
-            <a:pPr algn="ctr"/>
-            <a:endParaRPr/>
-          </a:p>
-        </p:txBody>
-      </p:sp>
-      <p:sp>
-        <p:nvSpPr>
-          <p:cNvPr id="10" name="TextBox 9"/>
-          <p:cNvSpPr txBox="1"/>
-          <p:nvPr/>
-        </p:nvSpPr>
-        <p:spPr>
-          <a:xfrm>
-            <a:off x="5166360" y="5376672"/>
-            <a:ext cx="5815584" cy="219456"/>
-          </a:xfrm>
-          <a:prstGeom prst="rect">
-            <a:avLst/>
-          </a:prstGeom>
-          <a:noFill/>
-        </p:spPr>
-        <p:txBody>
-          <a:bodyPr wrap="square" lIns="101600" rIns="101600" tIns="76200" bIns="76200">
-            <a:spAutoFit/>
-          </a:bodyPr>
-          <a:lstStyle/>
-          <a:p>
-            <a:r>
-              <a:t>Подготовка: задание, условия, оснастка и рабочая зона</a:t>
-            </a:r>
           </a:p>
         </p:txBody>
       </p:sp>
@@ -21535,7 +21344,7 @@
           </a:fontRef>
         </p:style>
         <p:txBody>
-          <a:bodyPr rtlCol="0" anchor="ctr" wrap="square" lIns="101600" rIns="101600" tIns="76200" bIns="76200"/>
+          <a:bodyPr wrap="square" lIns="101600" tIns="76200" rIns="101600" bIns="76200" rtlCol="0" anchor="ctr"/>
           <a:lstStyle/>
           <a:p>
             <a:pPr algn="ctr"/>
@@ -21598,7 +21407,7 @@
           </a:fontRef>
         </p:style>
         <p:txBody>
-          <a:bodyPr rtlCol="0" anchor="ctr" wrap="square" lIns="101600" rIns="101600" tIns="76200" bIns="76200"/>
+          <a:bodyPr wrap="square" lIns="101600" tIns="76200" rIns="101600" bIns="76200" rtlCol="0" anchor="ctr"/>
           <a:lstStyle/>
           <a:p>
             <a:pPr algn="ctr"/>
@@ -21654,6 +21463,7 @@
           <a:lstStyle/>
           <a:p>
             <a:pPr algn="ctr"/>
+            <a:endParaRPr/>
           </a:p>
         </p:txBody>
       </p:sp>
@@ -21665,8 +21475,8 @@
         </p:nvSpPr>
         <p:spPr>
           <a:xfrm>
-            <a:off x="676656" y="1828800"/>
-            <a:ext cx="4069080" cy="36576"/>
+            <a:off x="676910" y="1828800"/>
+            <a:ext cx="10487660" cy="36830"/>
           </a:xfrm>
           <a:prstGeom prst="rect">
             <a:avLst/>
@@ -21697,6 +21507,7 @@
           <a:lstStyle/>
           <a:p>
             <a:pPr algn="ctr"/>
+            <a:endParaRPr/>
           </a:p>
         </p:txBody>
       </p:sp>
@@ -21736,7 +21547,7 @@
           </a:fontRef>
         </p:style>
         <p:txBody>
-          <a:bodyPr rtlCol="0" anchor="ctr" wrap="none" lIns="50800" rIns="50800" tIns="12700" bIns="12700"/>
+          <a:bodyPr wrap="none" lIns="50800" tIns="12700" rIns="50800" bIns="12700" rtlCol="0" anchor="ctr"/>
           <a:lstStyle/>
           <a:p>
             <a:pPr algn="ctr"/>
@@ -21788,7 +21599,7 @@
           </a:fontRef>
         </p:style>
         <p:txBody>
-          <a:bodyPr rtlCol="0" anchor="ctr" wrap="none" lIns="50800" rIns="50800" tIns="12700" bIns="12700"/>
+          <a:bodyPr wrap="none" lIns="50800" tIns="12700" rIns="50800" bIns="12700" rtlCol="0" anchor="ctr"/>
           <a:lstStyle/>
           <a:p>
             <a:pPr algn="ctr"/>
@@ -21801,49 +21612,6 @@
               </a:rPr>
               <a:t>Опора</a:t>
             </a:r>
-          </a:p>
-        </p:txBody>
-      </p:sp>
-      <p:sp>
-        <p:nvSpPr>
-          <p:cNvPr id="17" name="Rectangle 16"/>
-          <p:cNvSpPr/>
-          <p:nvPr/>
-        </p:nvSpPr>
-        <p:spPr>
-          <a:xfrm>
-            <a:off x="4983480" y="1828800"/>
-            <a:ext cx="6181344" cy="36576"/>
-          </a:xfrm>
-          <a:prstGeom prst="rect">
-            <a:avLst/>
-          </a:prstGeom>
-          <a:solidFill>
-            <a:srgbClr val="0038B8"/>
-          </a:solidFill>
-          <a:ln>
-            <a:noFill/>
-          </a:ln>
-        </p:spPr>
-        <p:style>
-          <a:lnRef idx="1">
-            <a:schemeClr val="accent1"/>
-          </a:lnRef>
-          <a:fillRef idx="3">
-            <a:schemeClr val="accent1"/>
-          </a:fillRef>
-          <a:effectRef idx="2">
-            <a:schemeClr val="accent1"/>
-          </a:effectRef>
-          <a:fontRef idx="minor">
-            <a:schemeClr val="lt1"/>
-          </a:fontRef>
-        </p:style>
-        <p:txBody>
-          <a:bodyPr rtlCol="0" anchor="ctr"/>
-          <a:lstStyle/>
-          <a:p>
-            <a:pPr algn="ctr"/>
           </a:p>
         </p:txBody>
       </p:sp>
@@ -21883,7 +21651,7 @@
           </a:fontRef>
         </p:style>
         <p:txBody>
-          <a:bodyPr rtlCol="0" anchor="ctr" wrap="none" lIns="50800" rIns="50800" tIns="12700" bIns="12700"/>
+          <a:bodyPr wrap="none" lIns="50800" tIns="12700" rIns="50800" bIns="12700" rtlCol="0" anchor="ctr"/>
           <a:lstStyle/>
           <a:p>
             <a:pPr algn="ctr"/>
@@ -21935,7 +21703,7 @@
           </a:fontRef>
         </p:style>
         <p:txBody>
-          <a:bodyPr rtlCol="0" anchor="ctr" wrap="none" lIns="50800" rIns="50800" tIns="12700" bIns="12700"/>
+          <a:bodyPr wrap="none" lIns="50800" tIns="12700" rIns="50800" bIns="12700" rtlCol="0" anchor="ctr"/>
           <a:lstStyle/>
           <a:p>
             <a:pPr algn="ctr"/>
@@ -21987,7 +21755,7 @@
           </a:fontRef>
         </p:style>
         <p:txBody>
-          <a:bodyPr rtlCol="0" anchor="ctr" wrap="none" lIns="50800" rIns="50800" tIns="12700" bIns="12700"/>
+          <a:bodyPr wrap="none" lIns="50800" tIns="12700" rIns="50800" bIns="12700" rtlCol="0" anchor="ctr"/>
           <a:lstStyle/>
           <a:p>
             <a:pPr algn="ctr"/>
@@ -22005,14 +21773,20 @@
       </p:sp>
       <p:sp>
         <p:nvSpPr>
-          <p:cNvPr id="21" name="TextBox 20"/>
+          <p:cNvPr id="10" name="TextBox 9">
+            <a:extLst>
+              <a:ext uri="{FF2B5EF4-FFF2-40B4-BE49-F238E27FC236}">
+                <a16:creationId xmlns:a16="http://schemas.microsoft.com/office/drawing/2014/main" id="{726B51D7-9970-D187-0403-565B4CF7DF5F}"/>
+              </a:ext>
+            </a:extLst>
+          </p:cNvPr>
           <p:cNvSpPr txBox="1"/>
           <p:nvPr/>
         </p:nvSpPr>
         <p:spPr>
           <a:xfrm>
-            <a:off x="5093208" y="2176272"/>
-            <a:ext cx="5961888" cy="219456"/>
+            <a:off x="901700" y="2324100"/>
+            <a:ext cx="10033000" cy="3764107"/>
           </a:xfrm>
           <a:prstGeom prst="rect">
             <a:avLst/>
@@ -22020,87 +21794,456 @@
           <a:noFill/>
         </p:spPr>
         <p:txBody>
-          <a:bodyPr wrap="square" lIns="0" rIns="0" tIns="0" bIns="0">
+          <a:bodyPr vert="horz" wrap="square" lIns="101600" tIns="76200" rIns="101600" bIns="76200" numCol="2" spcCol="228600" rtlCol="0">
             <a:spAutoFit/>
           </a:bodyPr>
           <a:lstStyle/>
           <a:p>
             <a:r>
-              <a:rPr sz="1300" b="1">
+              <a:rPr lang="ru-RU" sz="1020" b="1" dirty="0">
+                <a:solidFill>
+                  <a:srgbClr val="0038B8"/>
+                </a:solidFill>
+                <a:latin typeface="Arial" panose="020B0604020202020204" pitchFamily="34" charset="0"/>
+              </a:rPr>
+              <a:t>Инструкция "Уточни задание перед началом работ"</a:t>
+            </a:r>
+          </a:p>
+          <a:p>
+            <a:endParaRPr lang="ru-RU" sz="1020" dirty="0">
+              <a:solidFill>
+                <a:srgbClr val="111111"/>
+              </a:solidFill>
+              <a:latin typeface="Arial" panose="020B0604020202020204" pitchFamily="34" charset="0"/>
+            </a:endParaRPr>
+          </a:p>
+          <a:p>
+            <a:r>
+              <a:rPr lang="ru-RU" sz="1020" dirty="0">
                 <a:solidFill>
                   <a:srgbClr val="111111"/>
                 </a:solidFill>
-                <a:latin typeface="Arial"/>
-              </a:rPr>
-              <a:t>Опорная памятка</a:t>
-            </a:r>
-          </a:p>
-        </p:txBody>
-      </p:sp>
-      <p:pic>
-        <p:nvPicPr>
-          <p:cNvPr id="22" name="Picture 21" descr="S031-P01_podgotovka-k-rabote_checklist.png"/>
-          <p:cNvPicPr>
-            <a:picLocks noChangeAspect="1"/>
-          </p:cNvPicPr>
-          <p:nvPr/>
-        </p:nvPicPr>
-        <p:blipFill>
-          <a:blip r:embed="rId2"/>
-          <a:stretch>
-            <a:fillRect/>
-          </a:stretch>
-        </p:blipFill>
-        <p:spPr>
-          <a:xfrm>
-            <a:off x="5700776" y="2633472"/>
-            <a:ext cx="4746752" cy="2670048"/>
-          </a:xfrm>
-          <a:prstGeom prst="rect">
-            <a:avLst/>
-          </a:prstGeom>
-        </p:spPr>
-      </p:pic>
-      <p:sp>
-        <p:nvSpPr>
-          <p:cNvPr id="23" name="Rectangle 22"/>
-          <p:cNvSpPr/>
-          <p:nvPr/>
-        </p:nvSpPr>
-        <p:spPr>
-          <a:xfrm>
-            <a:off x="5148072" y="5303520"/>
-            <a:ext cx="5852160" cy="18288"/>
-          </a:xfrm>
-          <a:prstGeom prst="rect">
-            <a:avLst/>
-          </a:prstGeom>
-          <a:solidFill>
-            <a:srgbClr val="E5E7EB"/>
-          </a:solidFill>
-          <a:ln>
-            <a:noFill/>
-          </a:ln>
-        </p:spPr>
-        <p:style>
-          <a:lnRef idx="1">
-            <a:schemeClr val="accent1"/>
-          </a:lnRef>
-          <a:fillRef idx="3">
-            <a:schemeClr val="accent1"/>
-          </a:fillRef>
-          <a:effectRef idx="2">
-            <a:schemeClr val="accent1"/>
-          </a:effectRef>
-          <a:fontRef idx="minor">
-            <a:schemeClr val="lt1"/>
-          </a:fontRef>
-        </p:style>
-        <p:txBody>
-          <a:bodyPr rtlCol="0" anchor="ctr"/>
-          <a:lstStyle/>
-          <a:p>
-            <a:pPr algn="ctr"/>
+                <a:latin typeface="Arial" panose="020B0604020202020204" pitchFamily="34" charset="0"/>
+              </a:rPr>
+              <a:t>Инструкция требует от работника получить четкие указания от лица, ответственного за безопасное производство работ (обычно это мастер или прораб).</a:t>
+            </a:r>
+          </a:p>
+          <a:p>
+            <a:endParaRPr lang="ru-RU" sz="1020" dirty="0">
+              <a:solidFill>
+                <a:srgbClr val="111111"/>
+              </a:solidFill>
+              <a:latin typeface="Arial" panose="020B0604020202020204" pitchFamily="34" charset="0"/>
+            </a:endParaRPr>
+          </a:p>
+          <a:p>
+            <a:r>
+              <a:rPr lang="ru-RU" sz="1020" b="1" dirty="0">
+                <a:solidFill>
+                  <a:srgbClr val="0038B8"/>
+                </a:solidFill>
+                <a:latin typeface="Arial" panose="020B0604020202020204" pitchFamily="34" charset="0"/>
+              </a:rPr>
+              <a:t>Что входит в уточнение задания</a:t>
+            </a:r>
+          </a:p>
+          <a:p>
+            <a:r>
+              <a:rPr lang="ru-RU" sz="1020" dirty="0">
+                <a:solidFill>
+                  <a:srgbClr val="111111"/>
+                </a:solidFill>
+                <a:latin typeface="Arial" panose="020B0604020202020204" pitchFamily="34" charset="0"/>
+              </a:rPr>
+              <a:t>• </a:t>
+            </a:r>
+            <a:r>
+              <a:rPr lang="ru-RU" sz="1020" b="1" dirty="0">
+                <a:solidFill>
+                  <a:srgbClr val="111111"/>
+                </a:solidFill>
+                <a:latin typeface="Arial" panose="020B0604020202020204" pitchFamily="34" charset="0"/>
+              </a:rPr>
+              <a:t>Место проведения работ:</a:t>
+            </a:r>
+            <a:r>
+              <a:rPr lang="ru-RU" sz="1020" dirty="0">
+                <a:solidFill>
+                  <a:srgbClr val="111111"/>
+                </a:solidFill>
+                <a:latin typeface="Arial" panose="020B0604020202020204" pitchFamily="34" charset="0"/>
+              </a:rPr>
+              <a:t> точная зона, где будут перемещать грузы.</a:t>
+            </a:r>
+          </a:p>
+          <a:p>
+            <a:r>
+              <a:rPr lang="ru-RU" sz="1020" dirty="0">
+                <a:solidFill>
+                  <a:srgbClr val="111111"/>
+                </a:solidFill>
+                <a:latin typeface="Arial" panose="020B0604020202020204" pitchFamily="34" charset="0"/>
+              </a:rPr>
+              <a:t>• </a:t>
+            </a:r>
+            <a:r>
+              <a:rPr lang="ru-RU" sz="1020" b="1" dirty="0">
+                <a:solidFill>
+                  <a:srgbClr val="111111"/>
+                </a:solidFill>
+                <a:latin typeface="Arial" panose="020B0604020202020204" pitchFamily="34" charset="0"/>
+              </a:rPr>
+              <a:t>Тип и масса груза:</a:t>
+            </a:r>
+            <a:r>
+              <a:rPr lang="ru-RU" sz="1020" dirty="0">
+                <a:solidFill>
+                  <a:srgbClr val="111111"/>
+                </a:solidFill>
+                <a:latin typeface="Arial" panose="020B0604020202020204" pitchFamily="34" charset="0"/>
+              </a:rPr>
+              <a:t> стропальщик должен знать точный вес и характер груза.</a:t>
+            </a:r>
+          </a:p>
+          <a:p>
+            <a:r>
+              <a:rPr lang="ru-RU" sz="1020" dirty="0">
+                <a:solidFill>
+                  <a:srgbClr val="111111"/>
+                </a:solidFill>
+                <a:latin typeface="Arial" panose="020B0604020202020204" pitchFamily="34" charset="0"/>
+              </a:rPr>
+              <a:t>• </a:t>
+            </a:r>
+            <a:r>
+              <a:rPr lang="ru-RU" sz="1020" b="1" dirty="0">
+                <a:solidFill>
+                  <a:srgbClr val="111111"/>
+                </a:solidFill>
+                <a:latin typeface="Arial" panose="020B0604020202020204" pitchFamily="34" charset="0"/>
+              </a:rPr>
+              <a:t>Схема строповки:</a:t>
+            </a:r>
+            <a:r>
+              <a:rPr lang="ru-RU" sz="1020" dirty="0">
+                <a:solidFill>
+                  <a:srgbClr val="111111"/>
+                </a:solidFill>
+                <a:latin typeface="Arial" panose="020B0604020202020204" pitchFamily="34" charset="0"/>
+              </a:rPr>
+              <a:t> способ обвязки или зацепки конкретного груза.</a:t>
+            </a:r>
+          </a:p>
+          <a:p>
+            <a:r>
+              <a:rPr lang="ru-RU" sz="1020" dirty="0">
+                <a:solidFill>
+                  <a:srgbClr val="111111"/>
+                </a:solidFill>
+                <a:latin typeface="Arial" panose="020B0604020202020204" pitchFamily="34" charset="0"/>
+              </a:rPr>
+              <a:t>• </a:t>
+            </a:r>
+            <a:r>
+              <a:rPr lang="ru-RU" sz="1020" b="1" dirty="0">
+                <a:solidFill>
+                  <a:srgbClr val="111111"/>
+                </a:solidFill>
+                <a:latin typeface="Arial" panose="020B0604020202020204" pitchFamily="34" charset="0"/>
+              </a:rPr>
+              <a:t>Выбор приспособлений:</a:t>
+            </a:r>
+            <a:r>
+              <a:rPr lang="ru-RU" sz="1020" dirty="0">
+                <a:solidFill>
+                  <a:srgbClr val="111111"/>
+                </a:solidFill>
+                <a:latin typeface="Arial" panose="020B0604020202020204" pitchFamily="34" charset="0"/>
+              </a:rPr>
+              <a:t> типы и грузоподъемность необходимых строп, траверс или захватов.</a:t>
+            </a:r>
+          </a:p>
+          <a:p>
+            <a:r>
+              <a:rPr lang="ru-RU" sz="1020" dirty="0">
+                <a:solidFill>
+                  <a:srgbClr val="111111"/>
+                </a:solidFill>
+                <a:latin typeface="Arial" panose="020B0604020202020204" pitchFamily="34" charset="0"/>
+              </a:rPr>
+              <a:t>• </a:t>
+            </a:r>
+            <a:r>
+              <a:rPr lang="ru-RU" sz="1020" b="1" dirty="0">
+                <a:solidFill>
+                  <a:srgbClr val="111111"/>
+                </a:solidFill>
+                <a:latin typeface="Arial" panose="020B0604020202020204" pitchFamily="34" charset="0"/>
+              </a:rPr>
+              <a:t>Маршрут перемещения:</a:t>
+            </a:r>
+            <a:r>
+              <a:rPr lang="ru-RU" sz="1020" dirty="0">
+                <a:solidFill>
+                  <a:srgbClr val="111111"/>
+                </a:solidFill>
+                <a:latin typeface="Arial" panose="020B0604020202020204" pitchFamily="34" charset="0"/>
+              </a:rPr>
+              <a:t> траектория движения груза и место его конечной укладки.</a:t>
+            </a:r>
+          </a:p>
+          <a:p>
+            <a:r>
+              <a:rPr lang="ru-RU" sz="1020" dirty="0">
+                <a:solidFill>
+                  <a:srgbClr val="111111"/>
+                </a:solidFill>
+                <a:latin typeface="Arial" panose="020B0604020202020204" pitchFamily="34" charset="0"/>
+              </a:rPr>
+              <a:t>• </a:t>
+            </a:r>
+            <a:r>
+              <a:rPr lang="ru-RU" sz="1020" b="1" dirty="0">
+                <a:solidFill>
+                  <a:srgbClr val="111111"/>
+                </a:solidFill>
+                <a:latin typeface="Arial" panose="020B0604020202020204" pitchFamily="34" charset="0"/>
+              </a:rPr>
+              <a:t>Опасные зоны:</a:t>
+            </a:r>
+            <a:r>
+              <a:rPr lang="ru-RU" sz="1020" dirty="0">
+                <a:solidFill>
+                  <a:srgbClr val="111111"/>
+                </a:solidFill>
+                <a:latin typeface="Arial" panose="020B0604020202020204" pitchFamily="34" charset="0"/>
+              </a:rPr>
+              <a:t> наличие вблизи ЛЭП, котлованов, заборов или других препятствий.</a:t>
+            </a:r>
+          </a:p>
+          <a:p>
+            <a:r>
+              <a:rPr lang="ru-RU" sz="1020" dirty="0">
+                <a:solidFill>
+                  <a:srgbClr val="111111"/>
+                </a:solidFill>
+                <a:latin typeface="Arial" panose="020B0604020202020204" pitchFamily="34" charset="0"/>
+              </a:rPr>
+              <a:t>• </a:t>
+            </a:r>
+            <a:r>
+              <a:rPr lang="ru-RU" sz="1020" b="1" dirty="0">
+                <a:solidFill>
+                  <a:srgbClr val="111111"/>
+                </a:solidFill>
+                <a:latin typeface="Arial" panose="020B0604020202020204" pitchFamily="34" charset="0"/>
+              </a:rPr>
+              <a:t>Знаки сигнализации:</a:t>
+            </a:r>
+            <a:r>
+              <a:rPr lang="ru-RU" sz="1020" dirty="0">
+                <a:solidFill>
+                  <a:srgbClr val="111111"/>
+                </a:solidFill>
+                <a:latin typeface="Arial" panose="020B0604020202020204" pitchFamily="34" charset="0"/>
+              </a:rPr>
+              <a:t> согласование порядка обмена сигналами с машинистом крана.</a:t>
+            </a:r>
+          </a:p>
+          <a:p>
+            <a:endParaRPr lang="ru-RU" sz="1020" dirty="0">
+              <a:solidFill>
+                <a:srgbClr val="111111"/>
+              </a:solidFill>
+              <a:latin typeface="Arial" panose="020B0604020202020204" pitchFamily="34" charset="0"/>
+            </a:endParaRPr>
+          </a:p>
+          <a:p>
+            <a:br>
+              <a:rPr lang="ru-RU" sz="1020" b="1" dirty="0">
+                <a:solidFill>
+                  <a:srgbClr val="0038B8"/>
+                </a:solidFill>
+                <a:latin typeface="Arial" panose="020B0604020202020204" pitchFamily="34" charset="0"/>
+              </a:rPr>
+            </a:br>
+            <a:br>
+              <a:rPr lang="ru-RU" sz="1020" b="1" dirty="0">
+                <a:solidFill>
+                  <a:srgbClr val="0038B8"/>
+                </a:solidFill>
+                <a:latin typeface="Arial" panose="020B0604020202020204" pitchFamily="34" charset="0"/>
+              </a:rPr>
+            </a:br>
+            <a:br>
+              <a:rPr lang="ru-RU" sz="1020" b="1" dirty="0">
+                <a:solidFill>
+                  <a:srgbClr val="0038B8"/>
+                </a:solidFill>
+                <a:latin typeface="Arial" panose="020B0604020202020204" pitchFamily="34" charset="0"/>
+              </a:rPr>
+            </a:br>
+            <a:br>
+              <a:rPr lang="ru-RU" sz="1020" b="1" dirty="0">
+                <a:solidFill>
+                  <a:srgbClr val="0038B8"/>
+                </a:solidFill>
+                <a:latin typeface="Arial" panose="020B0604020202020204" pitchFamily="34" charset="0"/>
+              </a:rPr>
+            </a:br>
+            <a:r>
+              <a:rPr lang="ru-RU" sz="1020" b="1" dirty="0">
+                <a:solidFill>
+                  <a:srgbClr val="0038B8"/>
+                </a:solidFill>
+                <a:latin typeface="Arial" panose="020B0604020202020204" pitchFamily="34" charset="0"/>
+              </a:rPr>
+              <a:t>Порядок действий стропальщика перед стартом</a:t>
+            </a:r>
+          </a:p>
+          <a:p>
+            <a:endParaRPr lang="ru-RU" sz="1020" dirty="0">
+              <a:solidFill>
+                <a:srgbClr val="111111"/>
+              </a:solidFill>
+              <a:latin typeface="Arial" panose="020B0604020202020204" pitchFamily="34" charset="0"/>
+            </a:endParaRPr>
+          </a:p>
+          <a:p>
+            <a:r>
+              <a:rPr lang="ru-RU" sz="1020" b="1" dirty="0">
+                <a:solidFill>
+                  <a:srgbClr val="111111"/>
+                </a:solidFill>
+                <a:latin typeface="Arial" panose="020B0604020202020204" pitchFamily="34" charset="0"/>
+              </a:rPr>
+              <a:t>1. Получить инструктаж:</a:t>
+            </a:r>
+            <a:r>
+              <a:rPr lang="ru-RU" sz="1020" dirty="0">
+                <a:solidFill>
+                  <a:srgbClr val="111111"/>
+                </a:solidFill>
+                <a:latin typeface="Arial" panose="020B0604020202020204" pitchFamily="34" charset="0"/>
+              </a:rPr>
+              <a:t> выслушать задание от ответственного лица.</a:t>
+            </a:r>
+          </a:p>
+          <a:p>
+            <a:r>
+              <a:rPr lang="ru-RU" sz="1020" b="1" dirty="0">
+                <a:solidFill>
+                  <a:srgbClr val="111111"/>
+                </a:solidFill>
+                <a:latin typeface="Arial" panose="020B0604020202020204" pitchFamily="34" charset="0"/>
+              </a:rPr>
+              <a:t>2. Проверить документацию:</a:t>
+            </a:r>
+            <a:r>
+              <a:rPr lang="ru-RU" sz="1020" dirty="0">
+                <a:solidFill>
+                  <a:srgbClr val="111111"/>
+                </a:solidFill>
+                <a:latin typeface="Arial" panose="020B0604020202020204" pitchFamily="34" charset="0"/>
+              </a:rPr>
+              <a:t> ознакомиться с технологической картой или </a:t>
+            </a:r>
+            <a:br>
+              <a:rPr lang="ru-RU" sz="1020" dirty="0">
+                <a:solidFill>
+                  <a:srgbClr val="111111"/>
+                </a:solidFill>
+                <a:latin typeface="Arial" panose="020B0604020202020204" pitchFamily="34" charset="0"/>
+              </a:rPr>
+            </a:br>
+            <a:r>
+              <a:rPr lang="ru-RU" sz="1020" dirty="0">
+                <a:solidFill>
+                  <a:srgbClr val="111111"/>
+                </a:solidFill>
+                <a:latin typeface="Arial" panose="020B0604020202020204" pitchFamily="34" charset="0"/>
+              </a:rPr>
+              <a:t>схемой строповки.</a:t>
+            </a:r>
+          </a:p>
+          <a:p>
+            <a:r>
+              <a:rPr lang="ru-RU" sz="1020" b="1" dirty="0">
+                <a:solidFill>
+                  <a:srgbClr val="111111"/>
+                </a:solidFill>
+                <a:latin typeface="Arial" panose="020B0604020202020204" pitchFamily="34" charset="0"/>
+              </a:rPr>
+              <a:t>3. Подобрать СИЗ:</a:t>
+            </a:r>
+            <a:r>
+              <a:rPr lang="ru-RU" sz="1020" dirty="0">
+                <a:solidFill>
+                  <a:srgbClr val="111111"/>
+                </a:solidFill>
+                <a:latin typeface="Arial" panose="020B0604020202020204" pitchFamily="34" charset="0"/>
+              </a:rPr>
+              <a:t> надеть каску, жилет, защитные перчатки и спецобувь.</a:t>
+            </a:r>
+          </a:p>
+          <a:p>
+            <a:r>
+              <a:rPr lang="ru-RU" sz="1020" b="1" dirty="0">
+                <a:solidFill>
+                  <a:srgbClr val="111111"/>
+                </a:solidFill>
+                <a:latin typeface="Arial" panose="020B0604020202020204" pitchFamily="34" charset="0"/>
+              </a:rPr>
+              <a:t>4. Осмотреть инструмент:</a:t>
+            </a:r>
+            <a:r>
+              <a:rPr lang="ru-RU" sz="1020" dirty="0">
+                <a:solidFill>
+                  <a:srgbClr val="111111"/>
+                </a:solidFill>
+                <a:latin typeface="Arial" panose="020B0604020202020204" pitchFamily="34" charset="0"/>
+              </a:rPr>
+              <a:t> проверить бирки и клейма на стропах, убедиться в отсутствии дефектов.</a:t>
+            </a:r>
+          </a:p>
+          <a:p>
+            <a:r>
+              <a:rPr lang="ru-RU" sz="1020" b="1" dirty="0">
+                <a:solidFill>
+                  <a:srgbClr val="111111"/>
+                </a:solidFill>
+                <a:latin typeface="Arial" panose="020B0604020202020204" pitchFamily="34" charset="0"/>
+              </a:rPr>
+              <a:t>5. Оценить площадку:</a:t>
+            </a:r>
+            <a:r>
+              <a:rPr lang="ru-RU" sz="1020" dirty="0">
+                <a:solidFill>
+                  <a:srgbClr val="111111"/>
+                </a:solidFill>
+                <a:latin typeface="Arial" panose="020B0604020202020204" pitchFamily="34" charset="0"/>
+              </a:rPr>
+              <a:t> проверить освещенность и отсутствие посторонних людей в зоне работы.</a:t>
+            </a:r>
+          </a:p>
+          <a:p>
+            <a:endParaRPr lang="ru-RU" sz="1020" dirty="0">
+              <a:solidFill>
+                <a:srgbClr val="111111"/>
+              </a:solidFill>
+              <a:latin typeface="Arial" panose="020B0604020202020204" pitchFamily="34" charset="0"/>
+            </a:endParaRPr>
+          </a:p>
+          <a:p>
+            <a:r>
+              <a:rPr lang="ru-RU" sz="1020" b="1" dirty="0">
+                <a:solidFill>
+                  <a:srgbClr val="0038B8"/>
+                </a:solidFill>
+                <a:latin typeface="Arial" panose="020B0604020202020204" pitchFamily="34" charset="0"/>
+              </a:rPr>
+              <a:t>Если схема строповки неизвестна или масса груза превышает грузоподъемность крана, стропальщик обязан отказаться от выполнения работ до устранения этих проблем.</a:t>
+            </a:r>
           </a:p>
         </p:txBody>
       </p:sp>
@@ -22195,7 +22338,7 @@
           <a:noFill/>
         </p:spPr>
         <p:txBody>
-          <a:bodyPr wrap="none" lIns="101600" rIns="101600" tIns="76200" bIns="76200">
+          <a:bodyPr wrap="none" lIns="101600" tIns="76200" rIns="101600" bIns="76200">
             <a:spAutoFit/>
           </a:bodyPr>
           <a:lstStyle/>
@@ -22261,7 +22404,7 @@
           </a:fontRef>
         </p:style>
         <p:txBody>
-          <a:bodyPr rtlCol="0" anchor="ctr" wrap="none" lIns="101600" rIns="101600" tIns="76200" bIns="76200"/>
+          <a:bodyPr wrap="none" lIns="101600" tIns="76200" rIns="101600" bIns="76200" rtlCol="0" anchor="ctr"/>
           <a:lstStyle/>
           <a:p>
             <a:pPr algn="ctr"/>
@@ -22299,7 +22442,7 @@
           <a:noFill/>
         </p:spPr>
         <p:txBody>
-          <a:bodyPr wrap="square" lIns="101600" rIns="101600" tIns="76200" bIns="76200">
+          <a:bodyPr wrap="square" lIns="101600" tIns="76200" rIns="101600" bIns="76200">
             <a:spAutoFit/>
           </a:bodyPr>
           <a:lstStyle/>
@@ -22408,12 +22551,12 @@
           </a:fontRef>
         </p:style>
         <p:txBody>
-          <a:bodyPr lIns="101600" rIns="101600" rtlCol="0" anchor="ctr" wrap="square" tIns="76200" bIns="76200"/>
+          <a:bodyPr wrap="square" lIns="101600" tIns="76200" rIns="101600" bIns="76200" rtlCol="0" anchor="ctr"/>
           <a:lstStyle/>
           <a:p>
             <a:pPr algn="l"/>
             <a:r>
-              <a:rPr lang="ru-RU" b="1" sz="1300">
+              <a:rPr lang="ru-RU" sz="1300" b="1">
                 <a:solidFill>
                   <a:srgbClr val="111111"/>
                 </a:solidFill>
@@ -22446,7 +22589,7 @@
           <a:noFill/>
         </p:spPr>
         <p:txBody>
-          <a:bodyPr wrap="square" lIns="101600" rIns="101600" tIns="76200" bIns="76200">
+          <a:bodyPr wrap="square" lIns="101600" tIns="76200" rIns="101600" bIns="76200">
             <a:spAutoFit/>
           </a:bodyPr>
           <a:lstStyle/>
@@ -22602,7 +22745,7 @@
           <a:noFill/>
         </p:spPr>
         <p:txBody>
-          <a:bodyPr wrap="square" lIns="101600" rIns="101600" tIns="76200" bIns="76200">
+          <a:bodyPr wrap="square" lIns="101600" tIns="76200" rIns="101600" bIns="76200">
             <a:spAutoFit/>
           </a:bodyPr>
           <a:lstStyle/>
@@ -22651,7 +22794,7 @@
           </a:fontRef>
         </p:style>
         <p:txBody>
-          <a:bodyPr rtlCol="0" anchor="ctr" wrap="square" lIns="101600" rIns="101600" tIns="76200" bIns="76200"/>
+          <a:bodyPr wrap="square" lIns="101600" tIns="76200" rIns="101600" bIns="76200" rtlCol="0" anchor="ctr"/>
           <a:lstStyle/>
           <a:p>
             <a:pPr algn="ctr"/>
@@ -22714,7 +22857,7 @@
           </a:fontRef>
         </p:style>
         <p:txBody>
-          <a:bodyPr rtlCol="0" anchor="ctr" wrap="square" lIns="101600" rIns="101600" tIns="76200" bIns="76200"/>
+          <a:bodyPr wrap="square" lIns="101600" tIns="76200" rIns="101600" bIns="76200" rtlCol="0" anchor="ctr"/>
           <a:lstStyle/>
           <a:p>
             <a:pPr algn="ctr"/>
@@ -22770,6 +22913,7 @@
           <a:lstStyle/>
           <a:p>
             <a:pPr algn="ctr"/>
+            <a:endParaRPr/>
           </a:p>
         </p:txBody>
       </p:sp>
@@ -22813,6 +22957,7 @@
           <a:lstStyle/>
           <a:p>
             <a:pPr algn="ctr"/>
+            <a:endParaRPr/>
           </a:p>
         </p:txBody>
       </p:sp>
@@ -22852,7 +22997,7 @@
           </a:fontRef>
         </p:style>
         <p:txBody>
-          <a:bodyPr rtlCol="0" anchor="ctr" wrap="none" lIns="50800" rIns="50800" tIns="12700" bIns="12700"/>
+          <a:bodyPr wrap="none" lIns="50800" tIns="12700" rIns="50800" bIns="12700" rtlCol="0" anchor="ctr"/>
           <a:lstStyle/>
           <a:p>
             <a:pPr algn="ctr"/>
@@ -22904,7 +23049,7 @@
           </a:fontRef>
         </p:style>
         <p:txBody>
-          <a:bodyPr rtlCol="0" anchor="ctr" wrap="none" lIns="50800" rIns="50800" tIns="12700" bIns="12700"/>
+          <a:bodyPr wrap="none" lIns="50800" tIns="12700" rIns="50800" bIns="12700" rtlCol="0" anchor="ctr"/>
           <a:lstStyle/>
           <a:p>
             <a:pPr algn="ctr"/>
@@ -22960,6 +23105,7 @@
           <a:lstStyle/>
           <a:p>
             <a:pPr algn="ctr"/>
+            <a:endParaRPr/>
           </a:p>
         </p:txBody>
       </p:sp>
@@ -22999,7 +23145,7 @@
           </a:fontRef>
         </p:style>
         <p:txBody>
-          <a:bodyPr rtlCol="0" anchor="ctr" wrap="none" lIns="50800" rIns="50800" tIns="12700" bIns="12700"/>
+          <a:bodyPr wrap="none" lIns="50800" tIns="12700" rIns="50800" bIns="12700" rtlCol="0" anchor="ctr"/>
           <a:lstStyle/>
           <a:p>
             <a:pPr algn="ctr"/>
@@ -23051,7 +23197,7 @@
           </a:fontRef>
         </p:style>
         <p:txBody>
-          <a:bodyPr rtlCol="0" anchor="ctr" wrap="none" lIns="50800" rIns="50800" tIns="12700" bIns="12700"/>
+          <a:bodyPr wrap="none" lIns="50800" tIns="12700" rIns="50800" bIns="12700" rtlCol="0" anchor="ctr"/>
           <a:lstStyle/>
           <a:p>
             <a:pPr algn="ctr"/>
@@ -23103,7 +23249,7 @@
           </a:fontRef>
         </p:style>
         <p:txBody>
-          <a:bodyPr rtlCol="0" anchor="ctr" wrap="none" lIns="50800" rIns="50800" tIns="12700" bIns="12700"/>
+          <a:bodyPr wrap="none" lIns="50800" tIns="12700" rIns="50800" bIns="12700" rtlCol="0" anchor="ctr"/>
           <a:lstStyle/>
           <a:p>
             <a:pPr algn="ctr"/>
@@ -23136,7 +23282,7 @@
           <a:noFill/>
         </p:spPr>
         <p:txBody>
-          <a:bodyPr wrap="square" lIns="0" rIns="0" tIns="0" bIns="0">
+          <a:bodyPr wrap="square" lIns="0" tIns="0" rIns="0" bIns="0">
             <a:spAutoFit/>
           </a:bodyPr>
           <a:lstStyle/>
@@ -23217,6 +23363,7 @@
           <a:lstStyle/>
           <a:p>
             <a:pPr algn="ctr"/>
+            <a:endParaRPr/>
           </a:p>
         </p:txBody>
       </p:sp>
@@ -23311,7 +23458,7 @@
           <a:noFill/>
         </p:spPr>
         <p:txBody>
-          <a:bodyPr wrap="none" lIns="101600" rIns="101600" tIns="76200" bIns="76200">
+          <a:bodyPr wrap="none" lIns="101600" tIns="76200" rIns="101600" bIns="76200">
             <a:spAutoFit/>
           </a:bodyPr>
           <a:lstStyle/>
@@ -23377,7 +23524,7 @@
           </a:fontRef>
         </p:style>
         <p:txBody>
-          <a:bodyPr rtlCol="0" anchor="ctr" wrap="none" lIns="101600" rIns="101600" tIns="76200" bIns="76200"/>
+          <a:bodyPr wrap="none" lIns="101600" tIns="76200" rIns="101600" bIns="76200" rtlCol="0" anchor="ctr"/>
           <a:lstStyle/>
           <a:p>
             <a:pPr algn="ctr"/>
@@ -23415,7 +23562,7 @@
           <a:noFill/>
         </p:spPr>
         <p:txBody>
-          <a:bodyPr wrap="square" lIns="101600" rIns="101600" tIns="76200" bIns="76200">
+          <a:bodyPr wrap="square" lIns="101600" tIns="76200" rIns="101600" bIns="76200">
             <a:spAutoFit/>
           </a:bodyPr>
           <a:lstStyle/>
@@ -23524,12 +23671,12 @@
           </a:fontRef>
         </p:style>
         <p:txBody>
-          <a:bodyPr lIns="101600" rIns="101600" rtlCol="0" anchor="ctr" wrap="square" tIns="76200" bIns="76200"/>
+          <a:bodyPr wrap="square" lIns="101600" tIns="76200" rIns="101600" bIns="76200" rtlCol="0" anchor="ctr"/>
           <a:lstStyle/>
           <a:p>
             <a:pPr algn="l"/>
             <a:r>
-              <a:rPr lang="ru-RU" b="1" sz="1300">
+              <a:rPr lang="ru-RU" sz="1300" b="1">
                 <a:solidFill>
                   <a:srgbClr val="111111"/>
                 </a:solidFill>
@@ -23562,7 +23709,7 @@
           <a:noFill/>
         </p:spPr>
         <p:txBody>
-          <a:bodyPr wrap="square" lIns="101600" rIns="101600" tIns="76200" bIns="76200">
+          <a:bodyPr wrap="square" lIns="101600" tIns="76200" rIns="101600" bIns="76200">
             <a:spAutoFit/>
           </a:bodyPr>
           <a:lstStyle/>
@@ -23702,7 +23849,7 @@
           <a:noFill/>
         </p:spPr>
         <p:txBody>
-          <a:bodyPr wrap="square" lIns="101600" rIns="101600" tIns="76200" bIns="76200">
+          <a:bodyPr wrap="square" lIns="101600" tIns="76200" rIns="101600" bIns="76200">
             <a:spAutoFit/>
           </a:bodyPr>
           <a:lstStyle/>
@@ -23799,7 +23946,7 @@
           </a:fontRef>
         </p:style>
         <p:txBody>
-          <a:bodyPr rtlCol="0" anchor="ctr" wrap="square" lIns="101600" rIns="101600" tIns="76200" bIns="76200"/>
+          <a:bodyPr wrap="square" lIns="101600" tIns="76200" rIns="101600" bIns="76200" rtlCol="0" anchor="ctr"/>
           <a:lstStyle/>
           <a:p>
             <a:pPr algn="ctr"/>
@@ -23862,7 +24009,7 @@
           </a:fontRef>
         </p:style>
         <p:txBody>
-          <a:bodyPr rtlCol="0" anchor="ctr" wrap="square" lIns="101600" rIns="101600" tIns="76200" bIns="76200"/>
+          <a:bodyPr wrap="square" lIns="101600" tIns="76200" rIns="101600" bIns="76200" rtlCol="0" anchor="ctr"/>
           <a:lstStyle/>
           <a:p>
             <a:pPr algn="ctr"/>
@@ -23918,6 +24065,7 @@
           <a:lstStyle/>
           <a:p>
             <a:pPr algn="ctr"/>
+            <a:endParaRPr/>
           </a:p>
         </p:txBody>
       </p:sp>
@@ -23961,6 +24109,7 @@
           <a:lstStyle/>
           <a:p>
             <a:pPr algn="ctr"/>
+            <a:endParaRPr/>
           </a:p>
         </p:txBody>
       </p:sp>
@@ -24000,7 +24149,7 @@
           </a:fontRef>
         </p:style>
         <p:txBody>
-          <a:bodyPr rtlCol="0" anchor="ctr" wrap="none" lIns="50800" rIns="50800" tIns="12700" bIns="12700"/>
+          <a:bodyPr wrap="none" lIns="50800" tIns="12700" rIns="50800" bIns="12700" rtlCol="0" anchor="ctr"/>
           <a:lstStyle/>
           <a:p>
             <a:pPr algn="ctr"/>
@@ -24052,7 +24201,7 @@
           </a:fontRef>
         </p:style>
         <p:txBody>
-          <a:bodyPr rtlCol="0" anchor="ctr" wrap="none" lIns="50800" rIns="50800" tIns="12700" bIns="12700"/>
+          <a:bodyPr wrap="none" lIns="50800" tIns="12700" rIns="50800" bIns="12700" rtlCol="0" anchor="ctr"/>
           <a:lstStyle/>
           <a:p>
             <a:pPr algn="ctr"/>
@@ -24108,6 +24257,7 @@
           <a:lstStyle/>
           <a:p>
             <a:pPr algn="ctr"/>
+            <a:endParaRPr/>
           </a:p>
         </p:txBody>
       </p:sp>
@@ -24147,7 +24297,7 @@
           </a:fontRef>
         </p:style>
         <p:txBody>
-          <a:bodyPr rtlCol="0" anchor="ctr" wrap="none" lIns="50800" rIns="50800" tIns="12700" bIns="12700"/>
+          <a:bodyPr wrap="none" lIns="50800" tIns="12700" rIns="50800" bIns="12700" rtlCol="0" anchor="ctr"/>
           <a:lstStyle/>
           <a:p>
             <a:pPr algn="ctr"/>
@@ -24199,7 +24349,7 @@
           </a:fontRef>
         </p:style>
         <p:txBody>
-          <a:bodyPr rtlCol="0" anchor="ctr" wrap="none" lIns="50800" rIns="50800" tIns="12700" bIns="12700"/>
+          <a:bodyPr wrap="none" lIns="50800" tIns="12700" rIns="50800" bIns="12700" rtlCol="0" anchor="ctr"/>
           <a:lstStyle/>
           <a:p>
             <a:pPr algn="ctr"/>
@@ -24251,7 +24401,7 @@
           </a:fontRef>
         </p:style>
         <p:txBody>
-          <a:bodyPr rtlCol="0" anchor="ctr" wrap="none" lIns="50800" rIns="50800" tIns="12700" bIns="12700"/>
+          <a:bodyPr wrap="none" lIns="50800" tIns="12700" rIns="50800" bIns="12700" rtlCol="0" anchor="ctr"/>
           <a:lstStyle/>
           <a:p>
             <a:pPr algn="ctr"/>
@@ -24284,7 +24434,7 @@
           <a:noFill/>
         </p:spPr>
         <p:txBody>
-          <a:bodyPr wrap="square" lIns="0" rIns="0" tIns="0" bIns="0">
+          <a:bodyPr wrap="square" lIns="0" tIns="0" rIns="0" bIns="0">
             <a:spAutoFit/>
           </a:bodyPr>
           <a:lstStyle/>
@@ -24392,7 +24542,7 @@
           <a:noFill/>
         </p:spPr>
         <p:txBody>
-          <a:bodyPr wrap="none" lIns="101600" rIns="101600" tIns="76200" bIns="76200">
+          <a:bodyPr wrap="none" lIns="101600" tIns="76200" rIns="101600" bIns="76200">
             <a:spAutoFit/>
           </a:bodyPr>
           <a:lstStyle/>
@@ -24458,7 +24608,7 @@
           </a:fontRef>
         </p:style>
         <p:txBody>
-          <a:bodyPr rtlCol="0" anchor="ctr" wrap="none" lIns="101600" rIns="101600" tIns="76200" bIns="76200"/>
+          <a:bodyPr wrap="none" lIns="101600" tIns="76200" rIns="101600" bIns="76200" rtlCol="0" anchor="ctr"/>
           <a:lstStyle/>
           <a:p>
             <a:pPr algn="ctr"/>
@@ -24496,7 +24646,7 @@
           <a:noFill/>
         </p:spPr>
         <p:txBody>
-          <a:bodyPr wrap="square" lIns="101600" rIns="101600" tIns="76200" bIns="76200">
+          <a:bodyPr wrap="square" lIns="101600" tIns="76200" rIns="101600" bIns="76200">
             <a:spAutoFit/>
           </a:bodyPr>
           <a:lstStyle/>
@@ -24605,12 +24755,12 @@
           </a:fontRef>
         </p:style>
         <p:txBody>
-          <a:bodyPr lIns="101600" rIns="101600" rtlCol="0" anchor="ctr" wrap="square" tIns="76200" bIns="76200"/>
+          <a:bodyPr wrap="square" lIns="101600" tIns="76200" rIns="101600" bIns="76200" rtlCol="0" anchor="ctr"/>
           <a:lstStyle/>
           <a:p>
             <a:pPr algn="l"/>
             <a:r>
-              <a:rPr lang="ru-RU" b="1" sz="1300">
+              <a:rPr lang="ru-RU" sz="1300" b="1">
                 <a:solidFill>
                   <a:srgbClr val="111111"/>
                 </a:solidFill>
@@ -24643,7 +24793,7 @@
           <a:noFill/>
         </p:spPr>
         <p:txBody>
-          <a:bodyPr wrap="square" lIns="101600" rIns="101600" tIns="76200" bIns="76200">
+          <a:bodyPr wrap="square" lIns="101600" tIns="76200" rIns="101600" bIns="76200">
             <a:spAutoFit/>
           </a:bodyPr>
           <a:lstStyle/>
@@ -24815,7 +24965,7 @@
           <a:noFill/>
         </p:spPr>
         <p:txBody>
-          <a:bodyPr wrap="square" lIns="101600" rIns="101600" tIns="76200" bIns="76200">
+          <a:bodyPr wrap="square" lIns="101600" tIns="76200" rIns="101600" bIns="76200">
             <a:spAutoFit/>
           </a:bodyPr>
           <a:lstStyle/>
@@ -24900,7 +25050,7 @@
           </a:fontRef>
         </p:style>
         <p:txBody>
-          <a:bodyPr rtlCol="0" anchor="ctr" wrap="square" lIns="101600" rIns="101600" tIns="76200" bIns="76200"/>
+          <a:bodyPr wrap="square" lIns="101600" tIns="76200" rIns="101600" bIns="76200" rtlCol="0" anchor="ctr"/>
           <a:lstStyle/>
           <a:p>
             <a:pPr algn="ctr"/>
@@ -24963,7 +25113,7 @@
           </a:fontRef>
         </p:style>
         <p:txBody>
-          <a:bodyPr rtlCol="0" anchor="ctr" wrap="square" lIns="101600" rIns="101600" tIns="76200" bIns="76200"/>
+          <a:bodyPr wrap="square" lIns="101600" tIns="76200" rIns="101600" bIns="76200" rtlCol="0" anchor="ctr"/>
           <a:lstStyle/>
           <a:p>
             <a:pPr algn="ctr"/>
@@ -25019,6 +25169,7 @@
           <a:lstStyle/>
           <a:p>
             <a:pPr algn="ctr"/>
+            <a:endParaRPr/>
           </a:p>
         </p:txBody>
       </p:sp>
@@ -25062,6 +25213,7 @@
           <a:lstStyle/>
           <a:p>
             <a:pPr algn="ctr"/>
+            <a:endParaRPr/>
           </a:p>
         </p:txBody>
       </p:sp>
@@ -25101,7 +25253,7 @@
           </a:fontRef>
         </p:style>
         <p:txBody>
-          <a:bodyPr rtlCol="0" anchor="ctr" wrap="none" lIns="50800" rIns="50800" tIns="12700" bIns="12700"/>
+          <a:bodyPr wrap="none" lIns="50800" tIns="12700" rIns="50800" bIns="12700" rtlCol="0" anchor="ctr"/>
           <a:lstStyle/>
           <a:p>
             <a:pPr algn="ctr"/>
@@ -25153,7 +25305,7 @@
           </a:fontRef>
         </p:style>
         <p:txBody>
-          <a:bodyPr rtlCol="0" anchor="ctr" wrap="none" lIns="50800" rIns="50800" tIns="12700" bIns="12700"/>
+          <a:bodyPr wrap="none" lIns="50800" tIns="12700" rIns="50800" bIns="12700" rtlCol="0" anchor="ctr"/>
           <a:lstStyle/>
           <a:p>
             <a:pPr algn="ctr"/>
@@ -25209,6 +25361,7 @@
           <a:lstStyle/>
           <a:p>
             <a:pPr algn="ctr"/>
+            <a:endParaRPr/>
           </a:p>
         </p:txBody>
       </p:sp>
@@ -25248,7 +25401,7 @@
           </a:fontRef>
         </p:style>
         <p:txBody>
-          <a:bodyPr rtlCol="0" anchor="ctr" wrap="none" lIns="50800" rIns="50800" tIns="12700" bIns="12700"/>
+          <a:bodyPr wrap="none" lIns="50800" tIns="12700" rIns="50800" bIns="12700" rtlCol="0" anchor="ctr"/>
           <a:lstStyle/>
           <a:p>
             <a:pPr algn="ctr"/>
@@ -25300,7 +25453,7 @@
           </a:fontRef>
         </p:style>
         <p:txBody>
-          <a:bodyPr rtlCol="0" anchor="ctr" wrap="none" lIns="50800" rIns="50800" tIns="12700" bIns="12700"/>
+          <a:bodyPr wrap="none" lIns="50800" tIns="12700" rIns="50800" bIns="12700" rtlCol="0" anchor="ctr"/>
           <a:lstStyle/>
           <a:p>
             <a:pPr algn="ctr"/>
@@ -25352,7 +25505,7 @@
           </a:fontRef>
         </p:style>
         <p:txBody>
-          <a:bodyPr rtlCol="0" anchor="ctr" wrap="none" lIns="50800" rIns="50800" tIns="12700" bIns="12700"/>
+          <a:bodyPr wrap="none" lIns="50800" tIns="12700" rIns="50800" bIns="12700" rtlCol="0" anchor="ctr"/>
           <a:lstStyle/>
           <a:p>
             <a:pPr algn="ctr"/>
@@ -25385,7 +25538,7 @@
           <a:noFill/>
         </p:spPr>
         <p:txBody>
-          <a:bodyPr wrap="square" lIns="0" rIns="0" tIns="0" bIns="0">
+          <a:bodyPr wrap="square" lIns="0" tIns="0" rIns="0" bIns="0">
             <a:spAutoFit/>
           </a:bodyPr>
           <a:lstStyle/>
@@ -25493,7 +25646,7 @@
           <a:noFill/>
         </p:spPr>
         <p:txBody>
-          <a:bodyPr wrap="none" lIns="101600" rIns="101600" tIns="76200" bIns="76200">
+          <a:bodyPr wrap="none" lIns="101600" tIns="76200" rIns="101600" bIns="76200">
             <a:spAutoFit/>
           </a:bodyPr>
           <a:lstStyle/>
@@ -25559,7 +25712,7 @@
           </a:fontRef>
         </p:style>
         <p:txBody>
-          <a:bodyPr rtlCol="0" anchor="ctr" wrap="none" lIns="101600" rIns="101600" tIns="76200" bIns="76200"/>
+          <a:bodyPr wrap="none" lIns="101600" tIns="76200" rIns="101600" bIns="76200" rtlCol="0" anchor="ctr"/>
           <a:lstStyle/>
           <a:p>
             <a:pPr algn="ctr"/>
@@ -25597,7 +25750,7 @@
           <a:noFill/>
         </p:spPr>
         <p:txBody>
-          <a:bodyPr wrap="square" lIns="101600" rIns="101600" tIns="76200" bIns="76200">
+          <a:bodyPr wrap="square" lIns="101600" tIns="76200" rIns="101600" bIns="76200">
             <a:spAutoFit/>
           </a:bodyPr>
           <a:lstStyle/>
@@ -25706,12 +25859,12 @@
           </a:fontRef>
         </p:style>
         <p:txBody>
-          <a:bodyPr lIns="101600" rIns="101600" rtlCol="0" anchor="ctr" wrap="square" tIns="76200" bIns="76200"/>
+          <a:bodyPr wrap="square" lIns="101600" tIns="76200" rIns="101600" bIns="76200" rtlCol="0" anchor="ctr"/>
           <a:lstStyle/>
           <a:p>
             <a:pPr algn="l"/>
             <a:r>
-              <a:rPr lang="ru-RU" b="1" sz="1300">
+              <a:rPr lang="ru-RU" sz="1300" b="1">
                 <a:solidFill>
                   <a:srgbClr val="111111"/>
                 </a:solidFill>
@@ -25744,7 +25897,7 @@
           <a:noFill/>
         </p:spPr>
         <p:txBody>
-          <a:bodyPr wrap="square" lIns="101600" rIns="101600" tIns="76200" bIns="76200">
+          <a:bodyPr wrap="square" lIns="101600" tIns="76200" rIns="101600" bIns="76200">
             <a:spAutoFit/>
           </a:bodyPr>
           <a:lstStyle/>
@@ -25948,7 +26101,7 @@
           <a:noFill/>
         </p:spPr>
         <p:txBody>
-          <a:bodyPr wrap="square" lIns="101600" rIns="101600" tIns="76200" bIns="76200">
+          <a:bodyPr wrap="square" lIns="101600" tIns="76200" rIns="101600" bIns="76200">
             <a:spAutoFit/>
           </a:bodyPr>
           <a:lstStyle/>
@@ -25997,7 +26150,7 @@
           </a:fontRef>
         </p:style>
         <p:txBody>
-          <a:bodyPr rtlCol="0" anchor="ctr" wrap="square" lIns="101600" rIns="101600" tIns="76200" bIns="76200"/>
+          <a:bodyPr wrap="square" lIns="101600" tIns="76200" rIns="101600" bIns="76200" rtlCol="0" anchor="ctr"/>
           <a:lstStyle/>
           <a:p>
             <a:pPr algn="ctr"/>
@@ -26060,7 +26213,7 @@
           </a:fontRef>
         </p:style>
         <p:txBody>
-          <a:bodyPr rtlCol="0" anchor="ctr" wrap="square" lIns="101600" rIns="101600" tIns="76200" bIns="76200"/>
+          <a:bodyPr wrap="square" lIns="101600" tIns="76200" rIns="101600" bIns="76200" rtlCol="0" anchor="ctr"/>
           <a:lstStyle/>
           <a:p>
             <a:pPr algn="ctr"/>
@@ -26116,6 +26269,7 @@
           <a:lstStyle/>
           <a:p>
             <a:pPr algn="ctr"/>
+            <a:endParaRPr/>
           </a:p>
         </p:txBody>
       </p:sp>
@@ -26159,6 +26313,7 @@
           <a:lstStyle/>
           <a:p>
             <a:pPr algn="ctr"/>
+            <a:endParaRPr/>
           </a:p>
         </p:txBody>
       </p:sp>
@@ -26198,7 +26353,7 @@
           </a:fontRef>
         </p:style>
         <p:txBody>
-          <a:bodyPr rtlCol="0" anchor="ctr" wrap="none" lIns="50800" rIns="50800" tIns="12700" bIns="12700"/>
+          <a:bodyPr wrap="none" lIns="50800" tIns="12700" rIns="50800" bIns="12700" rtlCol="0" anchor="ctr"/>
           <a:lstStyle/>
           <a:p>
             <a:pPr algn="ctr"/>
@@ -26250,7 +26405,7 @@
           </a:fontRef>
         </p:style>
         <p:txBody>
-          <a:bodyPr rtlCol="0" anchor="ctr" wrap="none" lIns="50800" rIns="50800" tIns="12700" bIns="12700"/>
+          <a:bodyPr wrap="none" lIns="50800" tIns="12700" rIns="50800" bIns="12700" rtlCol="0" anchor="ctr"/>
           <a:lstStyle/>
           <a:p>
             <a:pPr algn="ctr"/>
@@ -26306,6 +26461,7 @@
           <a:lstStyle/>
           <a:p>
             <a:pPr algn="ctr"/>
+            <a:endParaRPr/>
           </a:p>
         </p:txBody>
       </p:sp>
@@ -26345,7 +26501,7 @@
           </a:fontRef>
         </p:style>
         <p:txBody>
-          <a:bodyPr rtlCol="0" anchor="ctr" wrap="none" lIns="50800" rIns="50800" tIns="12700" bIns="12700"/>
+          <a:bodyPr wrap="none" lIns="50800" tIns="12700" rIns="50800" bIns="12700" rtlCol="0" anchor="ctr"/>
           <a:lstStyle/>
           <a:p>
             <a:pPr algn="ctr"/>
@@ -26397,7 +26553,7 @@
           </a:fontRef>
         </p:style>
         <p:txBody>
-          <a:bodyPr rtlCol="0" anchor="ctr" wrap="none" lIns="50800" rIns="50800" tIns="12700" bIns="12700"/>
+          <a:bodyPr wrap="none" lIns="50800" tIns="12700" rIns="50800" bIns="12700" rtlCol="0" anchor="ctr"/>
           <a:lstStyle/>
           <a:p>
             <a:pPr algn="ctr"/>
@@ -26449,7 +26605,7 @@
           </a:fontRef>
         </p:style>
         <p:txBody>
-          <a:bodyPr rtlCol="0" anchor="ctr" wrap="none" lIns="50800" rIns="50800" tIns="12700" bIns="12700"/>
+          <a:bodyPr wrap="none" lIns="50800" tIns="12700" rIns="50800" bIns="12700" rtlCol="0" anchor="ctr"/>
           <a:lstStyle/>
           <a:p>
             <a:pPr algn="ctr"/>
@@ -26482,7 +26638,7 @@
           <a:noFill/>
         </p:spPr>
         <p:txBody>
-          <a:bodyPr wrap="square" lIns="0" rIns="0" tIns="0" bIns="0">
+          <a:bodyPr wrap="square" lIns="0" tIns="0" rIns="0" bIns="0">
             <a:spAutoFit/>
           </a:bodyPr>
           <a:lstStyle/>
@@ -26563,6 +26719,7 @@
           <a:lstStyle/>
           <a:p>
             <a:pPr algn="ctr"/>
+            <a:endParaRPr/>
           </a:p>
         </p:txBody>
       </p:sp>
@@ -26657,7 +26814,7 @@
           <a:noFill/>
         </p:spPr>
         <p:txBody>
-          <a:bodyPr wrap="none" lIns="101600" rIns="101600" tIns="76200" bIns="76200">
+          <a:bodyPr wrap="none" lIns="101600" tIns="76200" rIns="101600" bIns="76200">
             <a:spAutoFit/>
           </a:bodyPr>
           <a:lstStyle/>
@@ -26723,7 +26880,7 @@
           </a:fontRef>
         </p:style>
         <p:txBody>
-          <a:bodyPr rtlCol="0" anchor="ctr" wrap="none" lIns="101600" rIns="101600" tIns="76200" bIns="76200"/>
+          <a:bodyPr wrap="none" lIns="101600" tIns="76200" rIns="101600" bIns="76200" rtlCol="0" anchor="ctr"/>
           <a:lstStyle/>
           <a:p>
             <a:pPr algn="ctr"/>
@@ -26761,7 +26918,7 @@
           <a:noFill/>
         </p:spPr>
         <p:txBody>
-          <a:bodyPr wrap="square" lIns="101600" rIns="101600" tIns="76200" bIns="76200">
+          <a:bodyPr wrap="square" lIns="101600" tIns="76200" rIns="101600" bIns="76200">
             <a:spAutoFit/>
           </a:bodyPr>
           <a:lstStyle/>
@@ -26870,12 +27027,12 @@
           </a:fontRef>
         </p:style>
         <p:txBody>
-          <a:bodyPr lIns="101600" rIns="101600" rtlCol="0" anchor="ctr" wrap="square" tIns="76200" bIns="76200"/>
+          <a:bodyPr wrap="square" lIns="101600" tIns="76200" rIns="101600" bIns="76200" rtlCol="0" anchor="ctr"/>
           <a:lstStyle/>
           <a:p>
             <a:pPr algn="l"/>
             <a:r>
-              <a:rPr lang="ru-RU" b="1" sz="1300">
+              <a:rPr lang="ru-RU" sz="1300" b="1">
                 <a:solidFill>
                   <a:srgbClr val="111111"/>
                 </a:solidFill>
@@ -26908,7 +27065,7 @@
           <a:noFill/>
         </p:spPr>
         <p:txBody>
-          <a:bodyPr wrap="square" lIns="127000" rIns="101600" tIns="76200" bIns="76200">
+          <a:bodyPr wrap="square" lIns="127000" tIns="76200" rIns="101600" bIns="76200">
             <a:spAutoFit/>
           </a:bodyPr>
           <a:lstStyle/>
@@ -27048,7 +27205,7 @@
           <a:noFill/>
         </p:spPr>
         <p:txBody>
-          <a:bodyPr wrap="square" lIns="101600" rIns="101600" tIns="76200" bIns="76200">
+          <a:bodyPr wrap="square" lIns="101600" tIns="76200" rIns="101600" bIns="76200">
             <a:spAutoFit/>
           </a:bodyPr>
           <a:lstStyle/>
@@ -27097,7 +27254,7 @@
           </a:fontRef>
         </p:style>
         <p:txBody>
-          <a:bodyPr rtlCol="0" anchor="ctr" wrap="square" lIns="101600" rIns="101600" tIns="76200" bIns="76200"/>
+          <a:bodyPr wrap="square" lIns="101600" tIns="76200" rIns="101600" bIns="76200" rtlCol="0" anchor="ctr"/>
           <a:lstStyle/>
           <a:p>
             <a:pPr algn="ctr"/>
@@ -27160,7 +27317,7 @@
           </a:fontRef>
         </p:style>
         <p:txBody>
-          <a:bodyPr rtlCol="0" anchor="ctr" wrap="square" lIns="101600" rIns="101600" tIns="76200" bIns="76200"/>
+          <a:bodyPr wrap="square" lIns="101600" tIns="76200" rIns="101600" bIns="76200" rtlCol="0" anchor="ctr"/>
           <a:lstStyle/>
           <a:p>
             <a:pPr algn="ctr"/>
@@ -27216,6 +27373,7 @@
           <a:lstStyle/>
           <a:p>
             <a:pPr algn="ctr"/>
+            <a:endParaRPr/>
           </a:p>
         </p:txBody>
       </p:sp>
@@ -27259,6 +27417,7 @@
           <a:lstStyle/>
           <a:p>
             <a:pPr algn="ctr"/>
+            <a:endParaRPr/>
           </a:p>
         </p:txBody>
       </p:sp>
@@ -27298,7 +27457,7 @@
           </a:fontRef>
         </p:style>
         <p:txBody>
-          <a:bodyPr rtlCol="0" anchor="ctr" wrap="none" lIns="50800" rIns="50800" tIns="12700" bIns="12700"/>
+          <a:bodyPr wrap="none" lIns="50800" tIns="12700" rIns="50800" bIns="12700" rtlCol="0" anchor="ctr"/>
           <a:lstStyle/>
           <a:p>
             <a:pPr algn="ctr"/>
@@ -27350,7 +27509,7 @@
           </a:fontRef>
         </p:style>
         <p:txBody>
-          <a:bodyPr rtlCol="0" anchor="ctr" wrap="none" lIns="50800" rIns="50800" tIns="12700" bIns="12700"/>
+          <a:bodyPr wrap="none" lIns="50800" tIns="12700" rIns="50800" bIns="12700" rtlCol="0" anchor="ctr"/>
           <a:lstStyle/>
           <a:p>
             <a:pPr algn="ctr"/>
@@ -27406,6 +27565,7 @@
           <a:lstStyle/>
           <a:p>
             <a:pPr algn="ctr"/>
+            <a:endParaRPr/>
           </a:p>
         </p:txBody>
       </p:sp>
@@ -27449,6 +27609,7 @@
           <a:lstStyle/>
           <a:p>
             <a:pPr algn="ctr"/>
+            <a:endParaRPr/>
           </a:p>
         </p:txBody>
       </p:sp>
@@ -27492,6 +27653,7 @@
           <a:lstStyle/>
           <a:p>
             <a:pPr algn="ctr"/>
+            <a:endParaRPr/>
           </a:p>
         </p:txBody>
       </p:sp>
@@ -27531,7 +27693,7 @@
           </a:fontRef>
         </p:style>
         <p:txBody>
-          <a:bodyPr rtlCol="0" anchor="ctr" wrap="none" lIns="50800" rIns="50800" tIns="12700" bIns="12700"/>
+          <a:bodyPr wrap="none" lIns="50800" tIns="12700" rIns="50800" bIns="12700" rtlCol="0" anchor="ctr"/>
           <a:lstStyle/>
           <a:p>
             <a:pPr algn="ctr"/>
@@ -27583,7 +27745,7 @@
           </a:fontRef>
         </p:style>
         <p:txBody>
-          <a:bodyPr rtlCol="0" anchor="ctr" wrap="none" lIns="50800" rIns="50800" tIns="12700" bIns="12700"/>
+          <a:bodyPr wrap="none" lIns="50800" tIns="12700" rIns="50800" bIns="12700" rtlCol="0" anchor="ctr"/>
           <a:lstStyle/>
           <a:p>
             <a:pPr algn="ctr"/>
@@ -27635,7 +27797,7 @@
           </a:fontRef>
         </p:style>
         <p:txBody>
-          <a:bodyPr rtlCol="0" anchor="ctr" wrap="none" lIns="50800" rIns="50800" tIns="12700" bIns="12700"/>
+          <a:bodyPr wrap="none" lIns="50800" tIns="12700" rIns="50800" bIns="12700" rtlCol="0" anchor="ctr"/>
           <a:lstStyle/>
           <a:p>
             <a:pPr algn="ctr"/>
@@ -27668,7 +27830,7 @@
           <a:noFill/>
         </p:spPr>
         <p:txBody>
-          <a:bodyPr wrap="square" lIns="0" rIns="0" tIns="0" bIns="0">
+          <a:bodyPr wrap="square" lIns="0" tIns="0" rIns="0" bIns="0">
             <a:spAutoFit/>
           </a:bodyPr>
           <a:lstStyle/>
@@ -27749,6 +27911,7 @@
           <a:lstStyle/>
           <a:p>
             <a:pPr algn="ctr"/>
+            <a:endParaRPr/>
           </a:p>
         </p:txBody>
       </p:sp>

</xml_diff>